<commit_message>
Framework slide: no bullets, all sizes +3 pt, band subtitles removed, Verdana, taller canvas; Figure 1 PDF refreshed
Co-Authored-By: Claude Fable 5.1 <noreply@anthropic.com>
</commit_message>
<xml_diff>
--- a/docs/draft/Figures/STRATA_framework_editable.pptx
+++ b/docs/draft/Figures/STRATA_framework_editable.pptx
@@ -7,7 +7,7 @@
   <p:sldIdLst>
     <p:sldId id="256" r:id="rId7"/>
   </p:sldIdLst>
-  <p:sldSz cx="12191695" cy="6263640" type="screen4x3"/>
+  <p:sldSz cx="12191695" cy="7452360" type="screen4x3"/>
   <p:notesSz cx="6858000" cy="9144000"/>
   <p:defaultTextStyle>
     <a:defPPr>
@@ -3097,7 +3097,7 @@
         <p:spPr>
           <a:xfrm>
             <a:off x="109728" y="91440"/>
-            <a:ext cx="11969496" cy="2286000"/>
+            <a:ext cx="11972239" cy="3017520"/>
           </a:xfrm>
           <a:prstGeom prst="roundRect">
             <a:avLst>
@@ -3140,8 +3140,8 @@
         </p:nvSpPr>
         <p:spPr>
           <a:xfrm>
-            <a:off x="219456" y="155448"/>
-            <a:ext cx="365760" cy="365760"/>
+            <a:off x="237744" y="155448"/>
+            <a:ext cx="420624" cy="420624"/>
           </a:xfrm>
           <a:prstGeom prst="ellipse">
             <a:avLst/>
@@ -3174,11 +3174,11 @@
           <a:p>
             <a:pPr algn="ctr"/>
             <a:r>
-              <a:rPr sz="1300" b="1">
+              <a:rPr sz="1500" b="1">
                 <a:solidFill>
                   <a:srgbClr val="FFFFFF"/>
                 </a:solidFill>
-                <a:latin typeface="Arial"/>
+                <a:latin typeface="Verdana"/>
               </a:rPr>
               <a:t>1</a:t>
             </a:r>
@@ -3193,8 +3193,8 @@
         </p:nvSpPr>
         <p:spPr>
           <a:xfrm>
-            <a:off x="640080" y="128016"/>
-            <a:ext cx="4023360" cy="420624"/>
+            <a:off x="731520" y="128016"/>
+            <a:ext cx="6400800" cy="475488"/>
           </a:xfrm>
           <a:prstGeom prst="rect">
             <a:avLst/>
@@ -3213,11 +3213,11 @@
               </a:lnSpc>
             </a:pPr>
             <a:r>
-              <a:rPr sz="1500" b="1" i="0">
+              <a:rPr sz="1800" b="1" i="0">
                 <a:solidFill>
                   <a:srgbClr val="A0522D"/>
                 </a:solidFill>
-                <a:latin typeface="Arial"/>
+                <a:latin typeface="Verdana"/>
               </a:rPr>
               <a:t>STRATA Benchmark Construction</a:t>
             </a:r>
@@ -3226,53 +3226,14 @@
       </p:sp>
       <p:sp>
         <p:nvSpPr>
-          <p:cNvPr id="5" name="TextBox 4"/>
-          <p:cNvSpPr txBox="1"/>
-          <p:nvPr/>
-        </p:nvSpPr>
-        <p:spPr>
-          <a:xfrm>
-            <a:off x="4297680" y="128016"/>
-            <a:ext cx="7680960" cy="420624"/>
-          </a:xfrm>
-          <a:prstGeom prst="rect">
-            <a:avLst/>
-          </a:prstGeom>
-          <a:noFill/>
-        </p:spPr>
-        <p:txBody>
-          <a:bodyPr wrap="square" lIns="27432" rIns="27432" tIns="9144" bIns="9144" anchor="ctr">
-            <a:spAutoFit/>
-          </a:bodyPr>
-          <a:lstStyle/>
-          <a:p>
-            <a:pPr algn="l">
-              <a:lnSpc>
-                <a:spcPct val="100000"/>
-              </a:lnSpc>
-            </a:pPr>
-            <a:r>
-              <a:rPr sz="900" b="0" i="0">
-                <a:solidFill>
-                  <a:srgbClr val="6B6B6B"/>
-                </a:solidFill>
-                <a:latin typeface="Arial"/>
-              </a:rPr>
-              <a:t>from annotated clinical timelines to temporal–statistical claims with gold at every stage</a:t>
-            </a:r>
-          </a:p>
-        </p:txBody>
-      </p:sp>
-      <p:sp>
-        <p:nvSpPr>
-          <p:cNvPr id="6" name="Rounded Rectangle 5"/>
+          <p:cNvPr id="5" name="Rounded Rectangle 4"/>
           <p:cNvSpPr/>
           <p:nvPr/>
         </p:nvSpPr>
         <p:spPr>
           <a:xfrm>
-            <a:off x="219456" y="621792"/>
-            <a:ext cx="2834640" cy="1682496"/>
+            <a:off x="219456" y="676656"/>
+            <a:ext cx="2834640" cy="2340864"/>
           </a:xfrm>
           <a:prstGeom prst="roundRect">
             <a:avLst>
@@ -3311,14 +3272,14 @@
       </p:sp>
       <p:sp>
         <p:nvSpPr>
-          <p:cNvPr id="7" name="Rounded Rectangle 6"/>
+          <p:cNvPr id="6" name="Rounded Rectangle 5"/>
           <p:cNvSpPr/>
           <p:nvPr/>
         </p:nvSpPr>
         <p:spPr>
           <a:xfrm>
-            <a:off x="283464" y="685800"/>
-            <a:ext cx="365760" cy="182880"/>
+            <a:off x="292608" y="749808"/>
+            <a:ext cx="457200" cy="237744"/>
           </a:xfrm>
           <a:prstGeom prst="roundRect">
             <a:avLst>
@@ -3353,11 +3314,11 @@
           <a:p>
             <a:pPr algn="ctr"/>
             <a:r>
-              <a:rPr sz="750" b="1">
+              <a:rPr sz="1000" b="1">
                 <a:solidFill>
                   <a:srgbClr val="FFFFFF"/>
                 </a:solidFill>
-                <a:latin typeface="Arial"/>
+                <a:latin typeface="Verdana"/>
               </a:rPr>
               <a:t>1.1</a:t>
             </a:r>
@@ -3366,14 +3327,14 @@
       </p:sp>
       <p:sp>
         <p:nvSpPr>
-          <p:cNvPr id="8" name="TextBox 7"/>
+          <p:cNvPr id="7" name="TextBox 6"/>
           <p:cNvSpPr txBox="1"/>
           <p:nvPr/>
         </p:nvSpPr>
         <p:spPr>
           <a:xfrm>
-            <a:off x="676656" y="649224"/>
-            <a:ext cx="2331720" cy="256032"/>
+            <a:off x="786384" y="713232"/>
+            <a:ext cx="2212848" cy="310896"/>
           </a:xfrm>
           <a:prstGeom prst="rect">
             <a:avLst/>
@@ -3392,20 +3353,20 @@
               </a:lnSpc>
             </a:pPr>
             <a:r>
-              <a:rPr sz="900" b="1" i="0">
+              <a:rPr sz="1200" b="1" i="0">
                 <a:solidFill>
                   <a:srgbClr val="2B2B2B"/>
                 </a:solidFill>
-                <a:latin typeface="Arial"/>
+                <a:latin typeface="Verdana"/>
               </a:rPr>
-              <a:t>Annotated clinical timelines</a:t>
-            </a:r>
-            <a:r>
-              <a:rPr sz="620" b="0" i="0">
-                <a:solidFill>
-                  <a:srgbClr val="6B6B6B"/>
-                </a:solidFill>
-                <a:latin typeface="Arial"/>
+              <a:t>Annotated timelines</a:t>
+            </a:r>
+            <a:r>
+              <a:rPr sz="900" b="0" i="0">
+                <a:solidFill>
+                  <a:srgbClr val="5F5F5F"/>
+                </a:solidFill>
+                <a:latin typeface="Verdana"/>
               </a:rPr>
               <a:t> (MedTempo)</a:t>
             </a:r>
@@ -3414,7 +3375,7 @@
       </p:sp>
       <p:pic>
         <p:nvPicPr>
-          <p:cNvPr id="9" name="Picture 8" descr="clipboard-plus_A0522D.png"/>
+          <p:cNvPr id="8" name="Picture 7" descr="clipboard-plus_A0522D.png"/>
           <p:cNvPicPr>
             <a:picLocks noChangeAspect="1"/>
           </p:cNvPicPr>
@@ -3428,8 +3389,8 @@
         </p:blipFill>
         <p:spPr>
           <a:xfrm>
-            <a:off x="310896" y="1005840"/>
-            <a:ext cx="384048" cy="384048"/>
+            <a:off x="310896" y="1115568"/>
+            <a:ext cx="420624" cy="420624"/>
           </a:xfrm>
           <a:prstGeom prst="rect">
             <a:avLst/>
@@ -3438,7 +3399,7 @@
       </p:pic>
       <p:pic>
         <p:nvPicPr>
-          <p:cNvPr id="10" name="Picture 9" descr="file-text_4F6B75.png"/>
+          <p:cNvPr id="9" name="Picture 8" descr="file-text_4F6B75.png"/>
           <p:cNvPicPr>
             <a:picLocks noChangeAspect="1"/>
           </p:cNvPicPr>
@@ -3452,8 +3413,8 @@
         </p:blipFill>
         <p:spPr>
           <a:xfrm>
-            <a:off x="768096" y="1005840"/>
-            <a:ext cx="384048" cy="384048"/>
+            <a:off x="804672" y="1115568"/>
+            <a:ext cx="420624" cy="420624"/>
           </a:xfrm>
           <a:prstGeom prst="rect">
             <a:avLst/>
@@ -3462,14 +3423,14 @@
       </p:pic>
       <p:sp>
         <p:nvSpPr>
-          <p:cNvPr id="11" name="TextBox 10"/>
+          <p:cNvPr id="10" name="TextBox 9"/>
           <p:cNvSpPr txBox="1"/>
           <p:nvPr/>
         </p:nvSpPr>
         <p:spPr>
           <a:xfrm>
-            <a:off x="274320" y="1463040"/>
-            <a:ext cx="1234440" cy="777240"/>
+            <a:off x="274320" y="1609344"/>
+            <a:ext cx="1280160" cy="1371600"/>
           </a:xfrm>
           <a:prstGeom prst="rect">
             <a:avLst/>
@@ -3488,27 +3449,27 @@
               </a:lnSpc>
             </a:pPr>
             <a:r>
-              <a:rPr sz="700" b="0" i="0">
+              <a:rPr sz="1000" b="0" i="0">
                 <a:solidFill>
                   <a:srgbClr val="2B2B2B"/>
                 </a:solidFill>
-                <a:latin typeface="Arial"/>
+                <a:latin typeface="Verdana"/>
               </a:rPr>
-              <a:t>3,166 VAERS adverse-event reports (Janssen, Pfizer, Moderna), expert-annotated as a leveled order of events</a:t>
-            </a:r>
-          </a:p>
-        </p:txBody>
-      </p:sp>
-      <p:sp>
-        <p:nvSpPr>
-          <p:cNvPr id="12" name="Rounded Rectangle 11"/>
+              <a:t>3,166 VAERS reports, three vaccines, expert-annotated as a leveled order of events</a:t>
+            </a:r>
+          </a:p>
+        </p:txBody>
+      </p:sp>
+      <p:sp>
+        <p:nvSpPr>
+          <p:cNvPr id="11" name="Rounded Rectangle 10"/>
           <p:cNvSpPr/>
           <p:nvPr/>
         </p:nvSpPr>
         <p:spPr>
           <a:xfrm>
-            <a:off x="1554480" y="969264"/>
-            <a:ext cx="1426464" cy="1261872"/>
+            <a:off x="1572768" y="1078992"/>
+            <a:ext cx="1408176" cy="1847088"/>
           </a:xfrm>
           <a:prstGeom prst="roundRect">
             <a:avLst>
@@ -3545,14 +3506,14 @@
       </p:sp>
       <p:sp>
         <p:nvSpPr>
-          <p:cNvPr id="13" name="TextBox 12"/>
+          <p:cNvPr id="12" name="TextBox 11"/>
           <p:cNvSpPr txBox="1"/>
           <p:nvPr/>
         </p:nvSpPr>
         <p:spPr>
           <a:xfrm>
-            <a:off x="1591056" y="996696"/>
-            <a:ext cx="1371600" cy="219456"/>
+            <a:off x="1609344" y="1106424"/>
+            <a:ext cx="1353312" cy="457200"/>
           </a:xfrm>
           <a:prstGeom prst="rect">
             <a:avLst/>
@@ -3571,41 +3532,48 @@
               </a:lnSpc>
             </a:pPr>
             <a:r>
-              <a:rPr sz="700" b="1" i="0">
+              <a:rPr sz="900" b="1" i="0">
                 <a:solidFill>
                   <a:srgbClr val="2B2B2B"/>
                 </a:solidFill>
-                <a:latin typeface="Arial"/>
+                <a:latin typeface="Verdana"/>
               </a:rPr>
               <a:t>Example timeline</a:t>
             </a:r>
-            <a:r>
-              <a:rPr sz="620" b="0" i="0">
-                <a:solidFill>
-                  <a:srgbClr val="6B6B6B"/>
-                </a:solidFill>
-                <a:latin typeface="Arial"/>
+          </a:p>
+          <a:p>
+            <a:pPr algn="l">
+              <a:lnSpc>
+                <a:spcPct val="100000"/>
+              </a:lnSpc>
+            </a:pPr>
+            <a:r>
+              <a:rPr sz="900" b="0" i="0">
+                <a:solidFill>
+                  <a:srgbClr val="5F5F5F"/>
+                </a:solidFill>
+                <a:latin typeface="Verdana"/>
               </a:rPr>
-              <a:t> (report MT-0482913)</a:t>
+              <a:t>report MT-0482913</a:t>
             </a:r>
           </a:p>
         </p:txBody>
       </p:sp>
       <p:cxnSp>
         <p:nvCxnSpPr>
-          <p:cNvPr id="14" name="Connector 13"/>
+          <p:cNvPr id="13" name="Connector 12"/>
           <p:cNvCxnSpPr/>
           <p:nvPr/>
         </p:nvCxnSpPr>
         <p:spPr>
           <a:xfrm>
-            <a:off x="1682496" y="1426464"/>
-            <a:ext cx="1188720" cy="0"/>
+            <a:off x="1700784" y="1728216"/>
+            <a:ext cx="1152144" cy="0"/>
           </a:xfrm>
           <a:prstGeom prst="line">
             <a:avLst/>
           </a:prstGeom>
-          <a:ln w="19050">
+          <a:ln w="22225">
             <a:solidFill>
               <a:srgbClr val="4F6B75"/>
             </a:solidFill>
@@ -3628,14 +3596,14 @@
       </p:cxnSp>
       <p:sp>
         <p:nvSpPr>
-          <p:cNvPr id="15" name="Oval 14"/>
+          <p:cNvPr id="14" name="Oval 13"/>
           <p:cNvSpPr/>
           <p:nvPr/>
         </p:nvSpPr>
         <p:spPr>
           <a:xfrm>
-            <a:off x="1714500" y="1367028"/>
-            <a:ext cx="118872" cy="118872"/>
+            <a:off x="1709928" y="1664207"/>
+            <a:ext cx="128016" cy="128016"/>
           </a:xfrm>
           <a:prstGeom prst="ellipse">
             <a:avLst/>
@@ -3668,11 +3636,11 @@
           <a:p>
             <a:pPr algn="ctr"/>
             <a:r>
-              <a:rPr sz="1200" b="1">
+              <a:rPr sz="1400" b="1">
                 <a:solidFill>
                   <a:srgbClr val="FFFFFF"/>
                 </a:solidFill>
-                <a:latin typeface="Arial"/>
+                <a:latin typeface="Verdana"/>
               </a:rPr>
               <a:t/>
             </a:r>
@@ -3681,14 +3649,14 @@
       </p:sp>
       <p:sp>
         <p:nvSpPr>
-          <p:cNvPr id="16" name="TextBox 15"/>
+          <p:cNvPr id="15" name="TextBox 14"/>
           <p:cNvSpPr txBox="1"/>
           <p:nvPr/>
         </p:nvSpPr>
         <p:spPr>
           <a:xfrm>
-            <a:off x="1453895" y="1490472"/>
-            <a:ext cx="640080" cy="164592"/>
+            <a:off x="1408176" y="1801368"/>
+            <a:ext cx="731520" cy="201168"/>
           </a:xfrm>
           <a:prstGeom prst="rect">
             <a:avLst/>
@@ -3707,11 +3675,11 @@
               </a:lnSpc>
             </a:pPr>
             <a:r>
-              <a:rPr sz="620" b="1" i="0">
+              <a:rPr sz="700" b="1" i="0">
                 <a:solidFill>
                   <a:srgbClr val="4F6B75"/>
                 </a:solidFill>
-                <a:latin typeface="Arial"/>
+                <a:latin typeface="Verdana"/>
               </a:rPr>
               <a:t>Fever</a:t>
             </a:r>
@@ -3720,14 +3688,14 @@
       </p:sp>
       <p:sp>
         <p:nvSpPr>
-          <p:cNvPr id="17" name="Oval 16"/>
+          <p:cNvPr id="16" name="Oval 15"/>
           <p:cNvSpPr/>
           <p:nvPr/>
         </p:nvSpPr>
         <p:spPr>
           <a:xfrm>
-            <a:off x="2199132" y="1367028"/>
-            <a:ext cx="118872" cy="118872"/>
+            <a:off x="2212848" y="1664207"/>
+            <a:ext cx="128016" cy="128016"/>
           </a:xfrm>
           <a:prstGeom prst="ellipse">
             <a:avLst/>
@@ -3760,11 +3728,11 @@
           <a:p>
             <a:pPr algn="ctr"/>
             <a:r>
-              <a:rPr sz="1200" b="1">
+              <a:rPr sz="1400" b="1">
                 <a:solidFill>
                   <a:srgbClr val="FFFFFF"/>
                 </a:solidFill>
-                <a:latin typeface="Arial"/>
+                <a:latin typeface="Verdana"/>
               </a:rPr>
               <a:t/>
             </a:r>
@@ -3773,14 +3741,14 @@
       </p:sp>
       <p:sp>
         <p:nvSpPr>
-          <p:cNvPr id="18" name="TextBox 17"/>
+          <p:cNvPr id="17" name="TextBox 16"/>
           <p:cNvSpPr txBox="1"/>
           <p:nvPr/>
         </p:nvSpPr>
         <p:spPr>
           <a:xfrm>
-            <a:off x="1938528" y="1490472"/>
-            <a:ext cx="640080" cy="164592"/>
+            <a:off x="1911096" y="1801368"/>
+            <a:ext cx="731520" cy="201168"/>
           </a:xfrm>
           <a:prstGeom prst="rect">
             <a:avLst/>
@@ -3799,11 +3767,11 @@
               </a:lnSpc>
             </a:pPr>
             <a:r>
-              <a:rPr sz="620" b="1" i="0">
+              <a:rPr sz="700" b="1" i="0">
                 <a:solidFill>
                   <a:srgbClr val="A0522D"/>
                 </a:solidFill>
-                <a:latin typeface="Arial"/>
+                <a:latin typeface="Verdana"/>
               </a:rPr>
               <a:t>Headache</a:t>
             </a:r>
@@ -3812,14 +3780,14 @@
       </p:sp>
       <p:sp>
         <p:nvSpPr>
-          <p:cNvPr id="19" name="Oval 18"/>
+          <p:cNvPr id="18" name="Oval 17"/>
           <p:cNvSpPr/>
           <p:nvPr/>
         </p:nvSpPr>
         <p:spPr>
           <a:xfrm>
-            <a:off x="2683764" y="1367028"/>
-            <a:ext cx="118872" cy="118872"/>
+            <a:off x="2715768" y="1664207"/>
+            <a:ext cx="128016" cy="128016"/>
           </a:xfrm>
           <a:prstGeom prst="ellipse">
             <a:avLst/>
@@ -3852,11 +3820,11 @@
           <a:p>
             <a:pPr algn="ctr"/>
             <a:r>
-              <a:rPr sz="1200" b="1">
+              <a:rPr sz="1400" b="1">
                 <a:solidFill>
                   <a:srgbClr val="FFFFFF"/>
                 </a:solidFill>
-                <a:latin typeface="Arial"/>
+                <a:latin typeface="Verdana"/>
               </a:rPr>
               <a:t/>
             </a:r>
@@ -3865,14 +3833,14 @@
       </p:sp>
       <p:sp>
         <p:nvSpPr>
-          <p:cNvPr id="20" name="TextBox 19"/>
+          <p:cNvPr id="19" name="TextBox 18"/>
           <p:cNvSpPr txBox="1"/>
           <p:nvPr/>
         </p:nvSpPr>
         <p:spPr>
           <a:xfrm>
-            <a:off x="2423160" y="1490472"/>
-            <a:ext cx="640080" cy="164592"/>
+            <a:off x="2414016" y="1801368"/>
+            <a:ext cx="731520" cy="201168"/>
           </a:xfrm>
           <a:prstGeom prst="rect">
             <a:avLst/>
@@ -3891,11 +3859,11 @@
               </a:lnSpc>
             </a:pPr>
             <a:r>
-              <a:rPr sz="620" b="1" i="0">
+              <a:rPr sz="700" b="1" i="0">
                 <a:solidFill>
                   <a:srgbClr val="A8812E"/>
                 </a:solidFill>
-                <a:latin typeface="Arial"/>
+                <a:latin typeface="Verdana"/>
               </a:rPr>
               <a:t>Fatigue</a:t>
             </a:r>
@@ -3904,14 +3872,14 @@
       </p:sp>
       <p:sp>
         <p:nvSpPr>
-          <p:cNvPr id="21" name="TextBox 20"/>
+          <p:cNvPr id="20" name="TextBox 19"/>
           <p:cNvSpPr txBox="1"/>
           <p:nvPr/>
         </p:nvSpPr>
         <p:spPr>
           <a:xfrm>
-            <a:off x="1591056" y="1719072"/>
-            <a:ext cx="1371600" cy="475488"/>
+            <a:off x="1609344" y="2048256"/>
+            <a:ext cx="1353312" cy="868680"/>
           </a:xfrm>
           <a:prstGeom prst="rect">
             <a:avLst/>
@@ -3930,11 +3898,11 @@
               </a:lnSpc>
             </a:pPr>
             <a:r>
-              <a:rPr sz="620" b="0" i="0">
-                <a:solidFill>
-                  <a:srgbClr val="6B6B6B"/>
-                </a:solidFill>
-                <a:latin typeface="Arial"/>
+              <a:rPr sz="900" b="0" i="0">
+                <a:solidFill>
+                  <a:srgbClr val="5F5F5F"/>
+                </a:solidFill>
+                <a:latin typeface="Verdana"/>
               </a:rPr>
               <a:t>stage → events; the first mention fixes the stage; events at one stage co-exist</a:t>
             </a:r>
@@ -3943,21 +3911,21 @@
       </p:sp>
       <p:cxnSp>
         <p:nvCxnSpPr>
-          <p:cNvPr id="22" name="Connector 21"/>
+          <p:cNvPr id="21" name="Connector 20"/>
           <p:cNvCxnSpPr/>
           <p:nvPr/>
         </p:nvCxnSpPr>
         <p:spPr>
           <a:xfrm>
-            <a:off x="3090672" y="1444752"/>
-            <a:ext cx="201168" cy="0"/>
+            <a:off x="3090672" y="1773936"/>
+            <a:ext cx="219456" cy="0"/>
           </a:xfrm>
           <a:prstGeom prst="line">
             <a:avLst/>
           </a:prstGeom>
-          <a:ln w="19050">
+          <a:ln w="22225">
             <a:solidFill>
-              <a:srgbClr val="6B6B6B"/>
+              <a:srgbClr val="5F5F5F"/>
             </a:solidFill>
             <a:tailEnd type="triangle" w="med" len="med"/>
           </a:ln>
@@ -3979,14 +3947,14 @@
       </p:cxnSp>
       <p:sp>
         <p:nvSpPr>
-          <p:cNvPr id="23" name="Rounded Rectangle 22"/>
+          <p:cNvPr id="22" name="Rounded Rectangle 21"/>
           <p:cNvSpPr/>
           <p:nvPr/>
         </p:nvSpPr>
         <p:spPr>
           <a:xfrm>
-            <a:off x="3328416" y="621792"/>
-            <a:ext cx="2651760" cy="1682496"/>
+            <a:off x="3346704" y="676656"/>
+            <a:ext cx="2834640" cy="2340864"/>
           </a:xfrm>
           <a:prstGeom prst="roundRect">
             <a:avLst>
@@ -4025,14 +3993,14 @@
       </p:sp>
       <p:sp>
         <p:nvSpPr>
-          <p:cNvPr id="24" name="Rounded Rectangle 23"/>
+          <p:cNvPr id="23" name="Rounded Rectangle 22"/>
           <p:cNvSpPr/>
           <p:nvPr/>
         </p:nvSpPr>
         <p:spPr>
           <a:xfrm>
-            <a:off x="3392424" y="685800"/>
-            <a:ext cx="365760" cy="182880"/>
+            <a:off x="3419856" y="749808"/>
+            <a:ext cx="457200" cy="237744"/>
           </a:xfrm>
           <a:prstGeom prst="roundRect">
             <a:avLst>
@@ -4067,11 +4035,11 @@
           <a:p>
             <a:pPr algn="ctr"/>
             <a:r>
-              <a:rPr sz="750" b="1">
+              <a:rPr sz="1000" b="1">
                 <a:solidFill>
                   <a:srgbClr val="FFFFFF"/>
                 </a:solidFill>
-                <a:latin typeface="Arial"/>
+                <a:latin typeface="Verdana"/>
               </a:rPr>
               <a:t>1.2</a:t>
             </a:r>
@@ -4080,14 +4048,14 @@
       </p:sp>
       <p:sp>
         <p:nvSpPr>
-          <p:cNvPr id="25" name="TextBox 24"/>
+          <p:cNvPr id="24" name="TextBox 23"/>
           <p:cNvSpPr txBox="1"/>
           <p:nvPr/>
         </p:nvSpPr>
         <p:spPr>
           <a:xfrm>
-            <a:off x="3785616" y="649224"/>
-            <a:ext cx="2148839" cy="256032"/>
+            <a:off x="3913632" y="713232"/>
+            <a:ext cx="2212848" cy="310896"/>
           </a:xfrm>
           <a:prstGeom prst="rect">
             <a:avLst/>
@@ -4106,11 +4074,11 @@
               </a:lnSpc>
             </a:pPr>
             <a:r>
-              <a:rPr sz="900" b="1" i="0">
+              <a:rPr sz="1200" b="1" i="0">
                 <a:solidFill>
                   <a:srgbClr val="2B2B2B"/>
                 </a:solidFill>
-                <a:latin typeface="Arial"/>
+                <a:latin typeface="Verdana"/>
               </a:rPr>
               <a:t>Hypothesis templates</a:t>
             </a:r>
@@ -4119,15 +4087,15 @@
       </p:sp>
       <p:graphicFrame>
         <p:nvGraphicFramePr>
-          <p:cNvPr id="26" name="Table 25"/>
+          <p:cNvPr id="25" name="Table 24"/>
           <p:cNvGraphicFramePr>
             <a:graphicFrameLocks noGrp="1"/>
           </p:cNvGraphicFramePr>
           <p:nvPr/>
         </p:nvGraphicFramePr>
         <p:xfrm>
-          <a:off x="3401568" y="950976"/>
-          <a:ext cx="2505456" cy="1280153"/>
+          <a:off x="3419856" y="1078992"/>
+          <a:ext cx="2688336" cy="1828799"/>
         </p:xfrm>
         <a:graphic>
           <a:graphicData uri="http://schemas.openxmlformats.org/drawingml/2006/table">
@@ -4136,21 +4104,21 @@
                 <a:tableStyleId>{5C22544A-7EE6-4342-B048-85BDC9FD1C3A}</a:tableStyleId>
               </a:tblPr>
               <a:tblGrid>
-                <a:gridCol w="749808"/>
-                <a:gridCol w="1755648"/>
+                <a:gridCol w="896112"/>
+                <a:gridCol w="1792224"/>
               </a:tblGrid>
-              <a:tr h="182879">
+              <a:tr h="261257">
                 <a:tc>
                   <a:txBody>
                     <a:bodyPr/>
                     <a:lstStyle/>
                     <a:p>
                       <a:r>
-                        <a:rPr sz="660" b="1">
+                        <a:rPr sz="900" b="1">
                           <a:solidFill>
                             <a:srgbClr val="2B2B2B"/>
                           </a:solidFill>
-                          <a:latin typeface="Arial"/>
+                          <a:latin typeface="Verdana"/>
                         </a:rPr>
                         <a:t>Precedes</a:t>
                       </a:r>
@@ -4168,11 +4136,11 @@
                     <a:lstStyle/>
                     <a:p>
                       <a:r>
-                        <a:rPr sz="660" b="0">
+                        <a:rPr sz="900" b="0">
                           <a:solidFill>
                             <a:srgbClr val="2B2B2B"/>
                           </a:solidFill>
-                          <a:latin typeface="Arial"/>
+                          <a:latin typeface="Verdana"/>
                         </a:rPr>
                         <a:t>A tends to precede B</a:t>
                       </a:r>
@@ -4185,18 +4153,18 @@
                   </a:tcPr>
                 </a:tc>
               </a:tr>
-              <a:tr h="182879">
+              <a:tr h="261257">
                 <a:tc>
                   <a:txBody>
                     <a:bodyPr/>
                     <a:lstStyle/>
                     <a:p>
                       <a:r>
-                        <a:rPr sz="660" b="1">
+                        <a:rPr sz="900" b="1">
                           <a:solidFill>
                             <a:srgbClr val="2B2B2B"/>
                           </a:solidFill>
-                          <a:latin typeface="Arial"/>
+                          <a:latin typeface="Verdana"/>
                         </a:rPr>
                         <a:t>Co-occurs</a:t>
                       </a:r>
@@ -4214,11 +4182,11 @@
                     <a:lstStyle/>
                     <a:p>
                       <a:r>
-                        <a:rPr sz="660" b="0">
+                        <a:rPr sz="900" b="0">
                           <a:solidFill>
                             <a:srgbClr val="2B2B2B"/>
                           </a:solidFill>
-                          <a:latin typeface="Arial"/>
+                          <a:latin typeface="Verdana"/>
                         </a:rPr>
                         <a:t>A and B tend to co-occur</a:t>
                       </a:r>
@@ -4231,18 +4199,18 @@
                   </a:tcPr>
                 </a:tc>
               </a:tr>
-              <a:tr h="182879">
+              <a:tr h="261257">
                 <a:tc>
                   <a:txBody>
                     <a:bodyPr/>
                     <a:lstStyle/>
                     <a:p>
                       <a:r>
-                        <a:rPr sz="660" b="1">
+                        <a:rPr sz="900" b="1">
                           <a:solidFill>
                             <a:srgbClr val="2B2B2B"/>
                           </a:solidFill>
-                          <a:latin typeface="Arial"/>
+                          <a:latin typeface="Verdana"/>
                         </a:rPr>
                         <a:t>Sequence</a:t>
                       </a:r>
@@ -4260,11 +4228,11 @@
                     <a:lstStyle/>
                     <a:p>
                       <a:r>
-                        <a:rPr sz="660" b="0">
+                        <a:rPr sz="900" b="0">
                           <a:solidFill>
                             <a:srgbClr val="2B2B2B"/>
                           </a:solidFill>
-                          <a:latin typeface="Arial"/>
+                          <a:latin typeface="Verdana"/>
                         </a:rPr>
                         <a:t>A, then B, then C</a:t>
                       </a:r>
@@ -4277,18 +4245,18 @@
                   </a:tcPr>
                 </a:tc>
               </a:tr>
-              <a:tr h="182879">
+              <a:tr h="261257">
                 <a:tc>
                   <a:txBody>
                     <a:bodyPr/>
                     <a:lstStyle/>
                     <a:p>
                       <a:r>
-                        <a:rPr sz="660" b="1">
+                        <a:rPr sz="900" b="1">
                           <a:solidFill>
                             <a:srgbClr val="2B2B2B"/>
                           </a:solidFill>
-                          <a:latin typeface="Arial"/>
+                          <a:latin typeface="Verdana"/>
                         </a:rPr>
                         <a:t>First / Last</a:t>
                       </a:r>
@@ -4306,11 +4274,11 @@
                     <a:lstStyle/>
                     <a:p>
                       <a:r>
-                        <a:rPr sz="660" b="0">
+                        <a:rPr sz="900" b="0">
                           <a:solidFill>
                             <a:srgbClr val="2B2B2B"/>
                           </a:solidFill>
-                          <a:latin typeface="Arial"/>
+                          <a:latin typeface="Verdana"/>
                         </a:rPr>
                         <a:t>A is most often first (last)</a:t>
                       </a:r>
@@ -4323,18 +4291,18 @@
                   </a:tcPr>
                 </a:tc>
               </a:tr>
-              <a:tr h="182879">
+              <a:tr h="261257">
                 <a:tc>
                   <a:txBody>
                     <a:bodyPr/>
                     <a:lstStyle/>
                     <a:p>
                       <a:r>
-                        <a:rPr sz="660" b="1">
+                        <a:rPr sz="900" b="1">
                           <a:solidFill>
                             <a:srgbClr val="2B2B2B"/>
                           </a:solidFill>
-                          <a:latin typeface="Arial"/>
+                          <a:latin typeface="Verdana"/>
                         </a:rPr>
                         <a:t>Position</a:t>
                       </a:r>
@@ -4352,11 +4320,11 @@
                     <a:lstStyle/>
                     <a:p>
                       <a:r>
-                        <a:rPr sz="660" b="0">
+                        <a:rPr sz="900" b="0">
                           <a:solidFill>
                             <a:srgbClr val="2B2B2B"/>
                           </a:solidFill>
-                          <a:latin typeface="Arial"/>
+                          <a:latin typeface="Verdana"/>
                         </a:rPr>
                         <a:t>A falls in the earlier half</a:t>
                       </a:r>
@@ -4369,18 +4337,18 @@
                   </a:tcPr>
                 </a:tc>
               </a:tr>
-              <a:tr h="182879">
+              <a:tr h="261257">
                 <a:tc>
                   <a:txBody>
                     <a:bodyPr/>
                     <a:lstStyle/>
                     <a:p>
                       <a:r>
-                        <a:rPr sz="660" b="1">
+                        <a:rPr sz="900" b="1">
                           <a:solidFill>
                             <a:srgbClr val="2B2B2B"/>
                           </a:solidFill>
-                          <a:latin typeface="Arial"/>
+                          <a:latin typeface="Verdana"/>
                         </a:rPr>
                         <a:t>Proximity</a:t>
                       </a:r>
@@ -4398,11 +4366,11 @@
                     <a:lstStyle/>
                     <a:p>
                       <a:r>
-                        <a:rPr sz="660" b="0">
+                        <a:rPr sz="900" b="0">
                           <a:solidFill>
                             <a:srgbClr val="2B2B2B"/>
                           </a:solidFill>
-                          <a:latin typeface="Arial"/>
+                          <a:latin typeface="Verdana"/>
                         </a:rPr>
                         <a:t>A occurs right before B</a:t>
                       </a:r>
@@ -4415,18 +4383,18 @@
                   </a:tcPr>
                 </a:tc>
               </a:tr>
-              <a:tr h="182879">
+              <a:tr h="261257">
                 <a:tc>
                   <a:txBody>
                     <a:bodyPr/>
                     <a:lstStyle/>
                     <a:p>
                       <a:r>
-                        <a:rPr sz="660" b="1">
+                        <a:rPr sz="900" b="1">
                           <a:solidFill>
                             <a:srgbClr val="2B2B2B"/>
                           </a:solidFill>
-                          <a:latin typeface="Arial"/>
+                          <a:latin typeface="Verdana"/>
                         </a:rPr>
                         <a:t>Threshold</a:t>
                       </a:r>
@@ -4444,13 +4412,13 @@
                     <a:lstStyle/>
                     <a:p>
                       <a:r>
-                        <a:rPr sz="660" b="0">
+                        <a:rPr sz="900" b="0">
                           <a:solidFill>
                             <a:srgbClr val="2B2B2B"/>
                           </a:solidFill>
-                          <a:latin typeface="Arial"/>
+                          <a:latin typeface="Verdana"/>
                         </a:rPr>
-                        <a:t>A precedes B in ≥ 2/3 of reports</a:t>
+                        <a:t>A precedes B in ≥ 2/3</a:t>
                       </a:r>
                     </a:p>
                   </a:txBody>
@@ -4467,21 +4435,21 @@
       </p:graphicFrame>
       <p:cxnSp>
         <p:nvCxnSpPr>
-          <p:cNvPr id="27" name="Connector 26"/>
+          <p:cNvPr id="26" name="Connector 25"/>
           <p:cNvCxnSpPr/>
           <p:nvPr/>
         </p:nvCxnSpPr>
         <p:spPr>
           <a:xfrm>
-            <a:off x="6016752" y="1444752"/>
-            <a:ext cx="201168" cy="0"/>
+            <a:off x="6217920" y="1773936"/>
+            <a:ext cx="219456" cy="0"/>
           </a:xfrm>
           <a:prstGeom prst="line">
             <a:avLst/>
           </a:prstGeom>
-          <a:ln w="19050">
+          <a:ln w="22225">
             <a:solidFill>
-              <a:srgbClr val="6B6B6B"/>
+              <a:srgbClr val="5F5F5F"/>
             </a:solidFill>
             <a:tailEnd type="triangle" w="med" len="med"/>
           </a:ln>
@@ -4503,14 +4471,14 @@
       </p:cxnSp>
       <p:sp>
         <p:nvSpPr>
-          <p:cNvPr id="28" name="Rounded Rectangle 27"/>
+          <p:cNvPr id="27" name="Rounded Rectangle 26"/>
           <p:cNvSpPr/>
           <p:nvPr/>
         </p:nvSpPr>
         <p:spPr>
           <a:xfrm>
-            <a:off x="6254496" y="621792"/>
-            <a:ext cx="2697480" cy="1682496"/>
+            <a:off x="6473952" y="676656"/>
+            <a:ext cx="2743200" cy="2340864"/>
           </a:xfrm>
           <a:prstGeom prst="roundRect">
             <a:avLst>
@@ -4549,14 +4517,14 @@
       </p:sp>
       <p:sp>
         <p:nvSpPr>
-          <p:cNvPr id="29" name="Rounded Rectangle 28"/>
+          <p:cNvPr id="28" name="Rounded Rectangle 27"/>
           <p:cNvSpPr/>
           <p:nvPr/>
         </p:nvSpPr>
         <p:spPr>
           <a:xfrm>
-            <a:off x="6318504" y="685800"/>
-            <a:ext cx="365760" cy="182880"/>
+            <a:off x="6547104" y="749808"/>
+            <a:ext cx="457200" cy="237744"/>
           </a:xfrm>
           <a:prstGeom prst="roundRect">
             <a:avLst>
@@ -4591,11 +4559,11 @@
           <a:p>
             <a:pPr algn="ctr"/>
             <a:r>
-              <a:rPr sz="750" b="1">
+              <a:rPr sz="1000" b="1">
                 <a:solidFill>
                   <a:srgbClr val="FFFFFF"/>
                 </a:solidFill>
-                <a:latin typeface="Arial"/>
+                <a:latin typeface="Verdana"/>
               </a:rPr>
               <a:t>1.3</a:t>
             </a:r>
@@ -4604,14 +4572,14 @@
       </p:sp>
       <p:sp>
         <p:nvSpPr>
-          <p:cNvPr id="30" name="TextBox 29"/>
+          <p:cNvPr id="29" name="TextBox 28"/>
           <p:cNvSpPr txBox="1"/>
           <p:nvPr/>
         </p:nvSpPr>
         <p:spPr>
           <a:xfrm>
-            <a:off x="6711696" y="649224"/>
-            <a:ext cx="2194560" cy="256032"/>
+            <a:off x="7040880" y="713232"/>
+            <a:ext cx="2121408" cy="310896"/>
           </a:xfrm>
           <a:prstGeom prst="rect">
             <a:avLst/>
@@ -4630,11 +4598,11 @@
               </a:lnSpc>
             </a:pPr>
             <a:r>
-              <a:rPr sz="900" b="1" i="0">
+              <a:rPr sz="1200" b="1" i="0">
                 <a:solidFill>
                   <a:srgbClr val="2B2B2B"/>
                 </a:solidFill>
-                <a:latin typeface="Arial"/>
+                <a:latin typeface="Verdana"/>
               </a:rPr>
               <a:t>Groups, families, levels</a:t>
             </a:r>
@@ -4643,14 +4611,14 @@
       </p:sp>
       <p:sp>
         <p:nvSpPr>
-          <p:cNvPr id="31" name="Rounded Rectangle 30"/>
+          <p:cNvPr id="30" name="Rounded Rectangle 29"/>
           <p:cNvSpPr/>
           <p:nvPr/>
         </p:nvSpPr>
         <p:spPr>
           <a:xfrm>
-            <a:off x="6327648" y="950976"/>
-            <a:ext cx="2551176" cy="402336"/>
+            <a:off x="6547104" y="1078992"/>
+            <a:ext cx="2596896" cy="548640"/>
           </a:xfrm>
           <a:prstGeom prst="roundRect">
             <a:avLst>
@@ -4687,7 +4655,7 @@
       </p:sp>
       <p:pic>
         <p:nvPicPr>
-          <p:cNvPr id="32" name="Picture 31" descr="brain_4F6B75.png"/>
+          <p:cNvPr id="31" name="Picture 30" descr="brain_4F6B75.png"/>
           <p:cNvPicPr>
             <a:picLocks noChangeAspect="1"/>
           </p:cNvPicPr>
@@ -4701,8 +4669,8 @@
         </p:blipFill>
         <p:spPr>
           <a:xfrm>
-            <a:off x="6382512" y="1005840"/>
-            <a:ext cx="292608" cy="292608"/>
+            <a:off x="6601968" y="1188719"/>
+            <a:ext cx="329184" cy="329184"/>
           </a:xfrm>
           <a:prstGeom prst="rect">
             <a:avLst/>
@@ -4711,14 +4679,14 @@
       </p:pic>
       <p:sp>
         <p:nvSpPr>
-          <p:cNvPr id="33" name="TextBox 32"/>
+          <p:cNvPr id="32" name="TextBox 31"/>
           <p:cNvSpPr txBox="1"/>
           <p:nvPr/>
         </p:nvSpPr>
         <p:spPr>
           <a:xfrm>
-            <a:off x="6711696" y="960120"/>
-            <a:ext cx="2148840" cy="384048"/>
+            <a:off x="6967728" y="1097280"/>
+            <a:ext cx="2157984" cy="512063"/>
           </a:xfrm>
           <a:prstGeom prst="rect">
             <a:avLst/>
@@ -4733,15 +4701,15 @@
           <a:p>
             <a:pPr algn="l">
               <a:lnSpc>
-                <a:spcPct val="100000"/>
+                <a:spcPct val="95000"/>
               </a:lnSpc>
             </a:pPr>
             <a:r>
-              <a:rPr sz="780" b="1" i="0">
+              <a:rPr sz="1100" b="1" i="0">
                 <a:solidFill>
                   <a:srgbClr val="2B2B2B"/>
                 </a:solidFill>
-                <a:latin typeface="Arial"/>
+                <a:latin typeface="Verdana"/>
               </a:rPr>
               <a:t>26 groups</a:t>
             </a:r>
@@ -4749,31 +4717,31 @@
           <a:p>
             <a:pPr algn="l">
               <a:lnSpc>
-                <a:spcPct val="100000"/>
+                <a:spcPct val="95000"/>
               </a:lnSpc>
             </a:pPr>
             <a:r>
-              <a:rPr sz="620" b="0" i="0">
-                <a:solidFill>
-                  <a:srgbClr val="6B6B6B"/>
-                </a:solidFill>
-                <a:latin typeface="Arial"/>
+              <a:rPr sz="900" b="0" i="0">
+                <a:solidFill>
+                  <a:srgbClr val="5F5F5F"/>
+                </a:solidFill>
+                <a:latin typeface="Verdana"/>
               </a:rPr>
-              <a:t>template × scope: 9 report, 16 cohort, 1 two-cohort</a:t>
-            </a:r>
-          </a:p>
-        </p:txBody>
-      </p:sp>
-      <p:sp>
-        <p:nvSpPr>
-          <p:cNvPr id="34" name="Rounded Rectangle 33"/>
+              <a:t>9 report, 16 cohort, 1 two-cohort</a:t>
+            </a:r>
+          </a:p>
+        </p:txBody>
+      </p:sp>
+      <p:sp>
+        <p:nvSpPr>
+          <p:cNvPr id="33" name="Rounded Rectangle 32"/>
           <p:cNvSpPr/>
           <p:nvPr/>
         </p:nvSpPr>
         <p:spPr>
           <a:xfrm>
-            <a:off x="6327648" y="1389888"/>
-            <a:ext cx="2551176" cy="402336"/>
+            <a:off x="6547104" y="1682496"/>
+            <a:ext cx="2596896" cy="621792"/>
           </a:xfrm>
           <a:prstGeom prst="roundRect">
             <a:avLst>
@@ -4810,7 +4778,7 @@
       </p:sp>
       <p:pic>
         <p:nvPicPr>
-          <p:cNvPr id="35" name="Picture 34" descr="network_4F6B75.png"/>
+          <p:cNvPr id="34" name="Picture 33" descr="network_4F6B75.png"/>
           <p:cNvPicPr>
             <a:picLocks noChangeAspect="1"/>
           </p:cNvPicPr>
@@ -4824,8 +4792,8 @@
         </p:blipFill>
         <p:spPr>
           <a:xfrm>
-            <a:off x="6382512" y="1444752"/>
-            <a:ext cx="292608" cy="292608"/>
+            <a:off x="6601968" y="1828800"/>
+            <a:ext cx="329184" cy="329184"/>
           </a:xfrm>
           <a:prstGeom prst="rect">
             <a:avLst/>
@@ -4834,14 +4802,14 @@
       </p:pic>
       <p:sp>
         <p:nvSpPr>
-          <p:cNvPr id="36" name="TextBox 35"/>
+          <p:cNvPr id="35" name="TextBox 34"/>
           <p:cNvSpPr txBox="1"/>
           <p:nvPr/>
         </p:nvSpPr>
         <p:spPr>
           <a:xfrm>
-            <a:off x="6711696" y="1399032"/>
-            <a:ext cx="2148840" cy="384048"/>
+            <a:off x="6967728" y="1700784"/>
+            <a:ext cx="2157984" cy="585216"/>
           </a:xfrm>
           <a:prstGeom prst="rect">
             <a:avLst/>
@@ -4856,15 +4824,15 @@
           <a:p>
             <a:pPr algn="l">
               <a:lnSpc>
-                <a:spcPct val="100000"/>
+                <a:spcPct val="95000"/>
               </a:lnSpc>
             </a:pPr>
             <a:r>
-              <a:rPr sz="780" b="1" i="0">
+              <a:rPr sz="1100" b="1" i="0">
                 <a:solidFill>
                   <a:srgbClr val="2B2B2B"/>
                 </a:solidFill>
-                <a:latin typeface="Arial"/>
+                <a:latin typeface="Verdana"/>
               </a:rPr>
               <a:t>7 claim families</a:t>
             </a:r>
@@ -4872,15 +4840,15 @@
           <a:p>
             <a:pPr algn="l">
               <a:lnSpc>
-                <a:spcPct val="100000"/>
+                <a:spcPct val="95000"/>
               </a:lnSpc>
             </a:pPr>
             <a:r>
-              <a:rPr sz="620" b="0" i="0">
-                <a:solidFill>
-                  <a:srgbClr val="6B6B6B"/>
-                </a:solidFill>
-                <a:latin typeface="Arial"/>
+              <a:rPr sz="900" b="0" i="0">
+                <a:solidFill>
+                  <a:srgbClr val="5F5F5F"/>
+                </a:solidFill>
+                <a:latin typeface="Verdana"/>
               </a:rPr>
               <a:t>precedes, co-occurs, sequence, first/last, position, proximity, threshold</a:t>
             </a:r>
@@ -4889,14 +4857,14 @@
       </p:sp>
       <p:sp>
         <p:nvSpPr>
-          <p:cNvPr id="37" name="Rounded Rectangle 36"/>
+          <p:cNvPr id="36" name="Rounded Rectangle 35"/>
           <p:cNvSpPr/>
           <p:nvPr/>
         </p:nvSpPr>
         <p:spPr>
           <a:xfrm>
-            <a:off x="6327648" y="1828800"/>
-            <a:ext cx="2551176" cy="402336"/>
+            <a:off x="6547104" y="2359152"/>
+            <a:ext cx="2596896" cy="566928"/>
           </a:xfrm>
           <a:prstGeom prst="roundRect">
             <a:avLst>
@@ -4933,7 +4901,7 @@
       </p:sp>
       <p:pic>
         <p:nvPicPr>
-          <p:cNvPr id="38" name="Picture 37" descr="chart-no-axes-column_A0522D.png"/>
+          <p:cNvPr id="37" name="Picture 36" descr="chart-no-axes-column_A0522D.png"/>
           <p:cNvPicPr>
             <a:picLocks noChangeAspect="1"/>
           </p:cNvPicPr>
@@ -4947,8 +4915,8 @@
         </p:blipFill>
         <p:spPr>
           <a:xfrm>
-            <a:off x="6382512" y="1883664"/>
-            <a:ext cx="292608" cy="292608"/>
+            <a:off x="6601968" y="2478024"/>
+            <a:ext cx="329184" cy="329184"/>
           </a:xfrm>
           <a:prstGeom prst="rect">
             <a:avLst/>
@@ -4957,14 +4925,14 @@
       </p:pic>
       <p:sp>
         <p:nvSpPr>
-          <p:cNvPr id="39" name="TextBox 38"/>
+          <p:cNvPr id="38" name="TextBox 37"/>
           <p:cNvSpPr txBox="1"/>
           <p:nvPr/>
         </p:nvSpPr>
         <p:spPr>
           <a:xfrm>
-            <a:off x="6711696" y="1837943"/>
-            <a:ext cx="2148840" cy="384048"/>
+            <a:off x="6967728" y="2377440"/>
+            <a:ext cx="2157984" cy="530352"/>
           </a:xfrm>
           <a:prstGeom prst="rect">
             <a:avLst/>
@@ -4979,15 +4947,15 @@
           <a:p>
             <a:pPr algn="l">
               <a:lnSpc>
-                <a:spcPct val="100000"/>
+                <a:spcPct val="95000"/>
               </a:lnSpc>
             </a:pPr>
             <a:r>
-              <a:rPr sz="780" b="1" i="0">
+              <a:rPr sz="1100" b="1" i="0">
                 <a:solidFill>
                   <a:srgbClr val="2B2B2B"/>
                 </a:solidFill>
-                <a:latin typeface="Arial"/>
+                <a:latin typeface="Verdana"/>
               </a:rPr>
               <a:t>3 difficulty levels</a:t>
             </a:r>
@@ -4995,38 +4963,38 @@
           <a:p>
             <a:pPr algn="l">
               <a:lnSpc>
-                <a:spcPct val="100000"/>
+                <a:spcPct val="95000"/>
               </a:lnSpc>
             </a:pPr>
             <a:r>
-              <a:rPr sz="620" b="0" i="0">
-                <a:solidFill>
-                  <a:srgbClr val="6B6B6B"/>
-                </a:solidFill>
-                <a:latin typeface="Arial"/>
+              <a:rPr sz="900" b="0" i="0">
+                <a:solidFill>
+                  <a:srgbClr val="5F5F5F"/>
+                </a:solidFill>
+                <a:latin typeface="Verdana"/>
               </a:rPr>
-              <a:t>Easy: one report · Medium: one cohort · Hard: two cohorts</a:t>
+              <a:t>Easy one report; Medium one cohort; Hard two cohorts</a:t>
             </a:r>
           </a:p>
         </p:txBody>
       </p:sp>
       <p:cxnSp>
         <p:nvCxnSpPr>
-          <p:cNvPr id="40" name="Connector 39"/>
+          <p:cNvPr id="39" name="Connector 38"/>
           <p:cNvCxnSpPr/>
           <p:nvPr/>
         </p:nvCxnSpPr>
         <p:spPr>
           <a:xfrm>
-            <a:off x="8988552" y="1444752"/>
-            <a:ext cx="201168" cy="0"/>
+            <a:off x="9253728" y="1773936"/>
+            <a:ext cx="219456" cy="0"/>
           </a:xfrm>
           <a:prstGeom prst="line">
             <a:avLst/>
           </a:prstGeom>
-          <a:ln w="19050">
+          <a:ln w="22225">
             <a:solidFill>
-              <a:srgbClr val="6B6B6B"/>
+              <a:srgbClr val="5F5F5F"/>
             </a:solidFill>
             <a:tailEnd type="triangle" w="med" len="med"/>
           </a:ln>
@@ -5048,14 +5016,14 @@
       </p:cxnSp>
       <p:sp>
         <p:nvSpPr>
-          <p:cNvPr id="41" name="Rounded Rectangle 40"/>
+          <p:cNvPr id="40" name="Rounded Rectangle 39"/>
           <p:cNvSpPr/>
           <p:nvPr/>
         </p:nvSpPr>
         <p:spPr>
           <a:xfrm>
-            <a:off x="9226296" y="621792"/>
-            <a:ext cx="2852928" cy="1682496"/>
+            <a:off x="9509760" y="676656"/>
+            <a:ext cx="2569464" cy="2340864"/>
           </a:xfrm>
           <a:prstGeom prst="roundRect">
             <a:avLst>
@@ -5094,14 +5062,14 @@
       </p:sp>
       <p:sp>
         <p:nvSpPr>
-          <p:cNvPr id="42" name="Rounded Rectangle 41"/>
+          <p:cNvPr id="41" name="Rounded Rectangle 40"/>
           <p:cNvSpPr/>
           <p:nvPr/>
         </p:nvSpPr>
         <p:spPr>
           <a:xfrm>
-            <a:off x="9290304" y="685800"/>
-            <a:ext cx="365760" cy="182880"/>
+            <a:off x="9582912" y="749808"/>
+            <a:ext cx="457200" cy="237744"/>
           </a:xfrm>
           <a:prstGeom prst="roundRect">
             <a:avLst>
@@ -5136,11 +5104,11 @@
           <a:p>
             <a:pPr algn="ctr"/>
             <a:r>
-              <a:rPr sz="750" b="1">
+              <a:rPr sz="1000" b="1">
                 <a:solidFill>
                   <a:srgbClr val="FFFFFF"/>
                 </a:solidFill>
-                <a:latin typeface="Arial"/>
+                <a:latin typeface="Verdana"/>
               </a:rPr>
               <a:t>1.4</a:t>
             </a:r>
@@ -5149,14 +5117,14 @@
       </p:sp>
       <p:sp>
         <p:nvSpPr>
-          <p:cNvPr id="43" name="TextBox 42"/>
+          <p:cNvPr id="42" name="TextBox 41"/>
           <p:cNvSpPr txBox="1"/>
           <p:nvPr/>
         </p:nvSpPr>
         <p:spPr>
           <a:xfrm>
-            <a:off x="9683496" y="649224"/>
-            <a:ext cx="2350008" cy="256032"/>
+            <a:off x="10076688" y="713232"/>
+            <a:ext cx="1947672" cy="310896"/>
           </a:xfrm>
           <a:prstGeom prst="rect">
             <a:avLst/>
@@ -5175,36 +5143,27 @@
               </a:lnSpc>
             </a:pPr>
             <a:r>
-              <a:rPr sz="900" b="1" i="0">
+              <a:rPr sz="1200" b="1" i="0">
                 <a:solidFill>
                   <a:srgbClr val="2B2B2B"/>
                 </a:solidFill>
-                <a:latin typeface="Arial"/>
+                <a:latin typeface="Verdana"/>
               </a:rPr>
               <a:t>Gold annotations</a:t>
             </a:r>
-            <a:r>
-              <a:rPr sz="620" b="0" i="0">
-                <a:solidFill>
-                  <a:srgbClr val="6B6B6B"/>
-                </a:solidFill>
-                <a:latin typeface="Arial"/>
-              </a:rPr>
-              <a:t> (computed mechanically)</a:t>
-            </a:r>
-          </a:p>
-        </p:txBody>
-      </p:sp>
-      <p:sp>
-        <p:nvSpPr>
-          <p:cNvPr id="44" name="Rounded Rectangle 43"/>
+          </a:p>
+        </p:txBody>
+      </p:sp>
+      <p:sp>
+        <p:nvSpPr>
+          <p:cNvPr id="43" name="Rounded Rectangle 42"/>
           <p:cNvSpPr/>
           <p:nvPr/>
         </p:nvSpPr>
         <p:spPr>
           <a:xfrm>
-            <a:off x="9299448" y="950976"/>
-            <a:ext cx="877824" cy="1097280"/>
+            <a:off x="9582912" y="1078992"/>
+            <a:ext cx="2423160" cy="548640"/>
           </a:xfrm>
           <a:prstGeom prst="roundRect">
             <a:avLst>
@@ -5241,7 +5200,7 @@
       </p:sp>
       <p:pic>
         <p:nvPicPr>
-          <p:cNvPr id="45" name="Picture 44" descr="file-check_A8812E.png"/>
+          <p:cNvPr id="44" name="Picture 43" descr="file-check_A8812E.png"/>
           <p:cNvPicPr>
             <a:picLocks noChangeAspect="1"/>
           </p:cNvPicPr>
@@ -5255,8 +5214,8 @@
         </p:blipFill>
         <p:spPr>
           <a:xfrm>
-            <a:off x="9336024" y="987552"/>
-            <a:ext cx="237744" cy="237744"/>
+            <a:off x="9637776" y="1197863"/>
+            <a:ext cx="310896" cy="310896"/>
           </a:xfrm>
           <a:prstGeom prst="rect">
             <a:avLst/>
@@ -5265,14 +5224,14 @@
       </p:pic>
       <p:sp>
         <p:nvSpPr>
-          <p:cNvPr id="46" name="TextBox 45"/>
+          <p:cNvPr id="45" name="TextBox 44"/>
           <p:cNvSpPr txBox="1"/>
           <p:nvPr/>
         </p:nvSpPr>
         <p:spPr>
           <a:xfrm>
-            <a:off x="9573768" y="969264"/>
-            <a:ext cx="603504" cy="274320"/>
+            <a:off x="9985248" y="1097280"/>
+            <a:ext cx="2011680" cy="512063"/>
           </a:xfrm>
           <a:prstGeom prst="rect">
             <a:avLst/>
@@ -5287,118 +5246,47 @@
           <a:p>
             <a:pPr algn="l">
               <a:lnSpc>
-                <a:spcPct val="100000"/>
+                <a:spcPct val="95000"/>
               </a:lnSpc>
             </a:pPr>
             <a:r>
-              <a:rPr sz="660" b="1" i="0">
+              <a:rPr sz="1100" b="1" i="0">
                 <a:solidFill>
                   <a:srgbClr val="2B2B2B"/>
                 </a:solidFill>
-                <a:latin typeface="Arial"/>
+                <a:latin typeface="Verdana"/>
               </a:rPr>
               <a:t>Plan</a:t>
             </a:r>
           </a:p>
-        </p:txBody>
-      </p:sp>
-      <p:sp>
-        <p:nvSpPr>
-          <p:cNvPr id="47" name="TextBox 46"/>
-          <p:cNvSpPr txBox="1"/>
-          <p:nvPr/>
-        </p:nvSpPr>
-        <p:spPr>
-          <a:xfrm>
-            <a:off x="9326880" y="1225296"/>
-            <a:ext cx="841248" cy="822960"/>
-          </a:xfrm>
-          <a:prstGeom prst="rect">
-            <a:avLst/>
-          </a:prstGeom>
-          <a:noFill/>
-        </p:spPr>
-        <p:txBody>
-          <a:bodyPr wrap="square" lIns="27432" rIns="27432" tIns="9144" bIns="9144" anchor="t">
-            <a:spAutoFit/>
-          </a:bodyPr>
-          <a:lstStyle/>
           <a:p>
             <a:pPr algn="l">
               <a:lnSpc>
-                <a:spcPct val="100000"/>
+                <a:spcPct val="95000"/>
               </a:lnSpc>
             </a:pPr>
             <a:r>
-              <a:rPr sz="620" b="0" i="0">
-                <a:solidFill>
-                  <a:srgbClr val="2B2B2B"/>
-                </a:solidFill>
-                <a:latin typeface="Arial"/>
+              <a:rPr sz="900" b="0" i="0">
+                <a:solidFill>
+                  <a:srgbClr val="5F5F5F"/>
+                </a:solidFill>
+                <a:latin typeface="Verdana"/>
               </a:rPr>
-              <a:t>• events, quantity</a:t>
-            </a:r>
-          </a:p>
-          <a:p>
-            <a:pPr algn="l">
-              <a:lnSpc>
-                <a:spcPct val="100000"/>
-              </a:lnSpc>
-            </a:pPr>
-            <a:r>
-              <a:rPr sz="620" b="0" i="0">
-                <a:solidFill>
-                  <a:srgbClr val="2B2B2B"/>
-                </a:solidFill>
-                <a:latin typeface="Arial"/>
-              </a:rPr>
-              <a:t>• denominator primitive, arms</a:t>
-            </a:r>
-          </a:p>
-          <a:p>
-            <a:pPr algn="l">
-              <a:lnSpc>
-                <a:spcPct val="100000"/>
-              </a:lnSpc>
-            </a:pPr>
-            <a:r>
-              <a:rPr sz="620" b="0" i="0">
-                <a:solidFill>
-                  <a:srgbClr val="2B2B2B"/>
-                </a:solidFill>
-                <a:latin typeface="Arial"/>
-              </a:rPr>
-              <a:t>• null kind, p0, tail</a:t>
-            </a:r>
-          </a:p>
-          <a:p>
-            <a:pPr algn="l">
-              <a:lnSpc>
-                <a:spcPct val="100000"/>
-              </a:lnSpc>
-            </a:pPr>
-            <a:r>
-              <a:rPr sz="620" b="0" i="0">
-                <a:solidFill>
-                  <a:srgbClr val="2B2B2B"/>
-                </a:solidFill>
-                <a:latin typeface="Arial"/>
-              </a:rPr>
-              <a:t>• test family, floor</a:t>
-            </a:r>
-          </a:p>
-        </p:txBody>
-      </p:sp>
-      <p:sp>
-        <p:nvSpPr>
-          <p:cNvPr id="48" name="Rounded Rectangle 47"/>
+              <a:t>events, quantity, denominator primitive, arms, null, p0, tail, test, floor</a:t>
+            </a:r>
+          </a:p>
+        </p:txBody>
+      </p:sp>
+      <p:sp>
+        <p:nvSpPr>
+          <p:cNvPr id="46" name="Rounded Rectangle 45"/>
           <p:cNvSpPr/>
           <p:nvPr/>
         </p:nvSpPr>
         <p:spPr>
           <a:xfrm>
-            <a:off x="10213848" y="950976"/>
-            <a:ext cx="877824" cy="1097280"/>
+            <a:off x="9582912" y="1682496"/>
+            <a:ext cx="2423160" cy="475488"/>
           </a:xfrm>
           <a:prstGeom prst="roundRect">
             <a:avLst>
@@ -5435,7 +5323,7 @@
       </p:sp>
       <p:pic>
         <p:nvPicPr>
-          <p:cNvPr id="49" name="Picture 48" descr="database_A8812E.png"/>
+          <p:cNvPr id="47" name="Picture 46" descr="database_A8812E.png"/>
           <p:cNvPicPr>
             <a:picLocks noChangeAspect="1"/>
           </p:cNvPicPr>
@@ -5449,8 +5337,8 @@
         </p:blipFill>
         <p:spPr>
           <a:xfrm>
-            <a:off x="10250424" y="987552"/>
-            <a:ext cx="237744" cy="237744"/>
+            <a:off x="9637776" y="1764792"/>
+            <a:ext cx="310896" cy="310896"/>
           </a:xfrm>
           <a:prstGeom prst="rect">
             <a:avLst/>
@@ -5459,14 +5347,14 @@
       </p:pic>
       <p:sp>
         <p:nvSpPr>
-          <p:cNvPr id="50" name="TextBox 49"/>
+          <p:cNvPr id="48" name="TextBox 47"/>
           <p:cNvSpPr txBox="1"/>
           <p:nvPr/>
         </p:nvSpPr>
         <p:spPr>
           <a:xfrm>
-            <a:off x="10488168" y="969264"/>
-            <a:ext cx="603504" cy="274320"/>
+            <a:off x="9985248" y="1700784"/>
+            <a:ext cx="2011680" cy="438912"/>
           </a:xfrm>
           <a:prstGeom prst="rect">
             <a:avLst/>
@@ -5481,118 +5369,47 @@
           <a:p>
             <a:pPr algn="l">
               <a:lnSpc>
-                <a:spcPct val="100000"/>
+                <a:spcPct val="95000"/>
               </a:lnSpc>
             </a:pPr>
             <a:r>
-              <a:rPr sz="660" b="1" i="0">
+              <a:rPr sz="1100" b="1" i="0">
                 <a:solidFill>
                   <a:srgbClr val="2B2B2B"/>
                 </a:solidFill>
-                <a:latin typeface="Arial"/>
+                <a:latin typeface="Verdana"/>
               </a:rPr>
               <a:t>Evidence sets</a:t>
             </a:r>
           </a:p>
-        </p:txBody>
-      </p:sp>
-      <p:sp>
-        <p:nvSpPr>
-          <p:cNvPr id="51" name="TextBox 50"/>
-          <p:cNvSpPr txBox="1"/>
-          <p:nvPr/>
-        </p:nvSpPr>
-        <p:spPr>
-          <a:xfrm>
-            <a:off x="10241280" y="1225296"/>
-            <a:ext cx="841248" cy="822960"/>
-          </a:xfrm>
-          <a:prstGeom prst="rect">
-            <a:avLst/>
-          </a:prstGeom>
-          <a:noFill/>
-        </p:spPr>
-        <p:txBody>
-          <a:bodyPr wrap="square" lIns="27432" rIns="27432" tIns="9144" bIns="9144" anchor="t">
-            <a:spAutoFit/>
-          </a:bodyPr>
-          <a:lstStyle/>
           <a:p>
             <a:pPr algn="l">
               <a:lnSpc>
-                <a:spcPct val="100000"/>
+                <a:spcPct val="95000"/>
               </a:lnSpc>
             </a:pPr>
             <a:r>
-              <a:rPr sz="620" b="0" i="0">
-                <a:solidFill>
-                  <a:srgbClr val="2B2B2B"/>
-                </a:solidFill>
-                <a:latin typeface="Arial"/>
+              <a:rPr sz="900" b="0" i="0">
+                <a:solidFill>
+                  <a:srgbClr val="5F5F5F"/>
+                </a:solidFill>
+                <a:latin typeface="Verdana"/>
               </a:rPr>
-              <a:t>• denominator ids</a:t>
-            </a:r>
-          </a:p>
-          <a:p>
-            <a:pPr algn="l">
-              <a:lnSpc>
-                <a:spcPct val="100000"/>
-              </a:lnSpc>
-            </a:pPr>
-            <a:r>
-              <a:rPr sz="620" b="0" i="0">
-                <a:solidFill>
-                  <a:srgbClr val="2B2B2B"/>
-                </a:solidFill>
-                <a:latin typeface="Arial"/>
-              </a:rPr>
-              <a:t>• numerator ids</a:t>
-            </a:r>
-          </a:p>
-          <a:p>
-            <a:pPr algn="l">
-              <a:lnSpc>
-                <a:spcPct val="100000"/>
-              </a:lnSpc>
-            </a:pPr>
-            <a:r>
-              <a:rPr sz="620" b="0" i="0">
-                <a:solidFill>
-                  <a:srgbClr val="2B2B2B"/>
-                </a:solidFill>
-                <a:latin typeface="Arial"/>
-              </a:rPr>
-              <a:t>• excluded ids</a:t>
-            </a:r>
-          </a:p>
-          <a:p>
-            <a:pPr algn="l">
-              <a:lnSpc>
-                <a:spcPct val="100000"/>
-              </a:lnSpc>
-            </a:pPr>
-            <a:r>
-              <a:rPr sz="620" b="0" i="0">
-                <a:solidFill>
-                  <a:srgbClr val="2B2B2B"/>
-                </a:solidFill>
-                <a:latin typeface="Arial"/>
-              </a:rPr>
-              <a:t>• n, k per arm</a:t>
-            </a:r>
-          </a:p>
-        </p:txBody>
-      </p:sp>
-      <p:sp>
-        <p:nvSpPr>
-          <p:cNvPr id="52" name="Rounded Rectangle 51"/>
+              <a:t>denominator, numerator and excluded ids; n, k per arm</a:t>
+            </a:r>
+          </a:p>
+        </p:txBody>
+      </p:sp>
+      <p:sp>
+        <p:nvSpPr>
+          <p:cNvPr id="49" name="Rounded Rectangle 48"/>
           <p:cNvSpPr/>
           <p:nvPr/>
         </p:nvSpPr>
         <p:spPr>
           <a:xfrm>
-            <a:off x="11128248" y="950976"/>
-            <a:ext cx="877824" cy="1097280"/>
+            <a:off x="9582912" y="2212848"/>
+            <a:ext cx="2423160" cy="548640"/>
           </a:xfrm>
           <a:prstGeom prst="roundRect">
             <a:avLst>
@@ -5629,7 +5446,7 @@
       </p:sp>
       <p:pic>
         <p:nvPicPr>
-          <p:cNvPr id="53" name="Picture 52" descr="chart-bar_A8812E.png"/>
+          <p:cNvPr id="50" name="Picture 49" descr="chart-bar_A8812E.png"/>
           <p:cNvPicPr>
             <a:picLocks noChangeAspect="1"/>
           </p:cNvPicPr>
@@ -5643,8 +5460,8 @@
         </p:blipFill>
         <p:spPr>
           <a:xfrm>
-            <a:off x="11164824" y="987552"/>
-            <a:ext cx="237744" cy="237744"/>
+            <a:off x="9637776" y="2331720"/>
+            <a:ext cx="310896" cy="310896"/>
           </a:xfrm>
           <a:prstGeom prst="rect">
             <a:avLst/>
@@ -5653,14 +5470,14 @@
       </p:pic>
       <p:sp>
         <p:nvSpPr>
-          <p:cNvPr id="54" name="TextBox 53"/>
+          <p:cNvPr id="51" name="TextBox 50"/>
           <p:cNvSpPr txBox="1"/>
           <p:nvPr/>
         </p:nvSpPr>
         <p:spPr>
           <a:xfrm>
-            <a:off x="11402568" y="969264"/>
-            <a:ext cx="603504" cy="274320"/>
+            <a:off x="9985248" y="2231136"/>
+            <a:ext cx="2011680" cy="512063"/>
           </a:xfrm>
           <a:prstGeom prst="rect">
             <a:avLst/>
@@ -5669,6 +5486,61 @@
         </p:spPr>
         <p:txBody>
           <a:bodyPr wrap="square" lIns="27432" rIns="27432" tIns="9144" bIns="9144" anchor="ctr">
+            <a:spAutoFit/>
+          </a:bodyPr>
+          <a:lstStyle/>
+          <a:p>
+            <a:pPr algn="l">
+              <a:lnSpc>
+                <a:spcPct val="95000"/>
+              </a:lnSpc>
+            </a:pPr>
+            <a:r>
+              <a:rPr sz="1100" b="1" i="0">
+                <a:solidFill>
+                  <a:srgbClr val="2B2B2B"/>
+                </a:solidFill>
+                <a:latin typeface="Verdana"/>
+              </a:rPr>
+              <a:t>Statistics, verdict</a:t>
+            </a:r>
+          </a:p>
+          <a:p>
+            <a:pPr algn="l">
+              <a:lnSpc>
+                <a:spcPct val="95000"/>
+              </a:lnSpc>
+            </a:pPr>
+            <a:r>
+              <a:rPr sz="900" b="0" i="0">
+                <a:solidFill>
+                  <a:srgbClr val="5F5F5F"/>
+                </a:solidFill>
+                <a:latin typeface="Verdana"/>
+              </a:rPr>
+              <a:t>p on both tails, Wilson CI, Cohen's h; supported / refuted / insufficient</a:t>
+            </a:r>
+          </a:p>
+        </p:txBody>
+      </p:sp>
+      <p:sp>
+        <p:nvSpPr>
+          <p:cNvPr id="52" name="TextBox 51"/>
+          <p:cNvSpPr txBox="1"/>
+          <p:nvPr/>
+        </p:nvSpPr>
+        <p:spPr>
+          <a:xfrm>
+            <a:off x="9582912" y="2779776"/>
+            <a:ext cx="2423160" cy="219456"/>
+          </a:xfrm>
+          <a:prstGeom prst="rect">
+            <a:avLst/>
+          </a:prstGeom>
+          <a:noFill/>
+        </p:spPr>
+        <p:txBody>
+          <a:bodyPr wrap="square" lIns="27432" rIns="27432" tIns="9144" bIns="9144" anchor="t">
             <a:spAutoFit/>
           </a:bodyPr>
           <a:lstStyle/>
@@ -5679,153 +5551,27 @@
               </a:lnSpc>
             </a:pPr>
             <a:r>
-              <a:rPr sz="660" b="1" i="0">
-                <a:solidFill>
-                  <a:srgbClr val="2B2B2B"/>
-                </a:solidFill>
-                <a:latin typeface="Arial"/>
+              <a:rPr sz="750" b="0" i="1">
+                <a:solidFill>
+                  <a:srgbClr val="5F5F5F"/>
+                </a:solidFill>
+                <a:latin typeface="Verdana"/>
               </a:rPr>
-              <a:t>Statistics, verdict</a:t>
-            </a:r>
-          </a:p>
-        </p:txBody>
-      </p:sp>
-      <p:sp>
-        <p:nvSpPr>
-          <p:cNvPr id="55" name="TextBox 54"/>
-          <p:cNvSpPr txBox="1"/>
-          <p:nvPr/>
-        </p:nvSpPr>
-        <p:spPr>
-          <a:xfrm>
-            <a:off x="11155680" y="1225296"/>
-            <a:ext cx="841248" cy="822960"/>
-          </a:xfrm>
-          <a:prstGeom prst="rect">
-            <a:avLst/>
-          </a:prstGeom>
-          <a:noFill/>
-        </p:spPr>
-        <p:txBody>
-          <a:bodyPr wrap="square" lIns="27432" rIns="27432" tIns="9144" bIns="9144" anchor="t">
-            <a:spAutoFit/>
-          </a:bodyPr>
-          <a:lstStyle/>
-          <a:p>
-            <a:pPr algn="l">
-              <a:lnSpc>
-                <a:spcPct val="100000"/>
-              </a:lnSpc>
-            </a:pPr>
-            <a:r>
-              <a:rPr sz="620" b="0" i="0">
-                <a:solidFill>
-                  <a:srgbClr val="2B2B2B"/>
-                </a:solidFill>
-                <a:latin typeface="Arial"/>
-              </a:rPr>
-              <a:t>• p on both tails</a:t>
-            </a:r>
-          </a:p>
-          <a:p>
-            <a:pPr algn="l">
-              <a:lnSpc>
-                <a:spcPct val="100000"/>
-              </a:lnSpc>
-            </a:pPr>
-            <a:r>
-              <a:rPr sz="620" b="0" i="0">
-                <a:solidFill>
-                  <a:srgbClr val="2B2B2B"/>
-                </a:solidFill>
-                <a:latin typeface="Arial"/>
-              </a:rPr>
-              <a:t>• Wilson CI, Cohen's h</a:t>
-            </a:r>
-          </a:p>
-          <a:p>
-            <a:pPr algn="l">
-              <a:lnSpc>
-                <a:spcPct val="100000"/>
-              </a:lnSpc>
-            </a:pPr>
-            <a:r>
-              <a:rPr sz="620" b="0" i="0">
-                <a:solidFill>
-                  <a:srgbClr val="2B2B2B"/>
-                </a:solidFill>
-                <a:latin typeface="Arial"/>
-              </a:rPr>
-              <a:t>• supported / refuted /</a:t>
-            </a:r>
-          </a:p>
-          <a:p>
-            <a:pPr algn="l">
-              <a:lnSpc>
-                <a:spcPct val="100000"/>
-              </a:lnSpc>
-            </a:pPr>
-            <a:r>
-              <a:rPr sz="620" b="0" i="0">
-                <a:solidFill>
-                  <a:srgbClr val="2B2B2B"/>
-                </a:solidFill>
-                <a:latin typeface="Arial"/>
-              </a:rPr>
-              <a:t>• insufficient (sub-typed)</a:t>
-            </a:r>
-          </a:p>
-        </p:txBody>
-      </p:sp>
-      <p:sp>
-        <p:nvSpPr>
-          <p:cNvPr id="56" name="TextBox 55"/>
-          <p:cNvSpPr txBox="1"/>
-          <p:nvPr/>
-        </p:nvSpPr>
-        <p:spPr>
-          <a:xfrm>
-            <a:off x="9299448" y="2066544"/>
-            <a:ext cx="2724912" cy="219456"/>
-          </a:xfrm>
-          <a:prstGeom prst="rect">
-            <a:avLst/>
-          </a:prstGeom>
-          <a:noFill/>
-        </p:spPr>
-        <p:txBody>
-          <a:bodyPr wrap="square" lIns="27432" rIns="27432" tIns="9144" bIns="9144" anchor="t">
-            <a:spAutoFit/>
-          </a:bodyPr>
-          <a:lstStyle/>
-          <a:p>
-            <a:pPr algn="l">
-              <a:lnSpc>
-                <a:spcPct val="100000"/>
-              </a:lnSpc>
-            </a:pPr>
-            <a:r>
-              <a:rPr sz="620" b="0" i="1">
-                <a:solidFill>
-                  <a:srgbClr val="6B6B6B"/>
-                </a:solidFill>
-                <a:latin typeface="Arial"/>
-              </a:rPr>
-              <a:t>validated by six invariant families and a deterministic oracle; screened against permutation nulls</a:t>
-            </a:r>
-          </a:p>
-        </p:txBody>
-      </p:sp>
-      <p:sp>
-        <p:nvSpPr>
-          <p:cNvPr id="57" name="Rounded Rectangle 56"/>
+              <a:t>validated by invariants and an oracle; permutation-screened</a:t>
+            </a:r>
+          </a:p>
+        </p:txBody>
+      </p:sp>
+      <p:sp>
+        <p:nvSpPr>
+          <p:cNvPr id="53" name="Rounded Rectangle 52"/>
           <p:cNvSpPr/>
           <p:nvPr/>
         </p:nvSpPr>
         <p:spPr>
           <a:xfrm>
-            <a:off x="109728" y="2450592"/>
-            <a:ext cx="11969496" cy="2523744"/>
+            <a:off x="109728" y="3200400"/>
+            <a:ext cx="11972239" cy="3017520"/>
           </a:xfrm>
           <a:prstGeom prst="roundRect">
             <a:avLst>
@@ -5862,14 +5608,14 @@
       </p:sp>
       <p:sp>
         <p:nvSpPr>
-          <p:cNvPr id="58" name="Oval 57"/>
+          <p:cNvPr id="54" name="Oval 53"/>
           <p:cNvSpPr/>
           <p:nvPr/>
         </p:nvSpPr>
         <p:spPr>
           <a:xfrm>
-            <a:off x="219456" y="2514600"/>
-            <a:ext cx="365760" cy="365760"/>
+            <a:off x="237744" y="3264408"/>
+            <a:ext cx="420624" cy="420624"/>
           </a:xfrm>
           <a:prstGeom prst="ellipse">
             <a:avLst/>
@@ -5902,11 +5648,11 @@
           <a:p>
             <a:pPr algn="ctr"/>
             <a:r>
-              <a:rPr sz="1300" b="1">
+              <a:rPr sz="1500" b="1">
                 <a:solidFill>
                   <a:srgbClr val="FFFFFF"/>
                 </a:solidFill>
-                <a:latin typeface="Arial"/>
+                <a:latin typeface="Verdana"/>
               </a:rPr>
               <a:t>2</a:t>
             </a:r>
@@ -5915,14 +5661,14 @@
       </p:sp>
       <p:sp>
         <p:nvSpPr>
-          <p:cNvPr id="59" name="TextBox 58"/>
+          <p:cNvPr id="55" name="TextBox 54"/>
           <p:cNvSpPr txBox="1"/>
           <p:nvPr/>
         </p:nvSpPr>
         <p:spPr>
           <a:xfrm>
-            <a:off x="640080" y="2487168"/>
-            <a:ext cx="4023360" cy="420624"/>
+            <a:off x="731520" y="3236976"/>
+            <a:ext cx="6400800" cy="475488"/>
           </a:xfrm>
           <a:prstGeom prst="rect">
             <a:avLst/>
@@ -5941,11 +5687,11 @@
               </a:lnSpc>
             </a:pPr>
             <a:r>
-              <a:rPr sz="1500" b="1" i="0">
+              <a:rPr sz="1800" b="1" i="0">
                 <a:solidFill>
                   <a:srgbClr val="A0522D"/>
                 </a:solidFill>
-                <a:latin typeface="Arial"/>
+                <a:latin typeface="Verdana"/>
               </a:rPr>
               <a:t>ART Verification Pipeline</a:t>
             </a:r>
@@ -5954,53 +5700,14 @@
       </p:sp>
       <p:sp>
         <p:nvSpPr>
-          <p:cNvPr id="60" name="TextBox 59"/>
-          <p:cNvSpPr txBox="1"/>
-          <p:nvPr/>
-        </p:nvSpPr>
-        <p:spPr>
-          <a:xfrm>
-            <a:off x="4297680" y="2487168"/>
-            <a:ext cx="7680960" cy="420624"/>
-          </a:xfrm>
-          <a:prstGeom prst="rect">
-            <a:avLst/>
-          </a:prstGeom>
-          <a:noFill/>
-        </p:spPr>
-        <p:txBody>
-          <a:bodyPr wrap="square" lIns="27432" rIns="27432" tIns="9144" bIns="9144" anchor="ctr">
-            <a:spAutoFit/>
-          </a:bodyPr>
-          <a:lstStyle/>
-          <a:p>
-            <a:pPr algn="l">
-              <a:lnSpc>
-                <a:spcPct val="100000"/>
-              </a:lnSpc>
-            </a:pPr>
-            <a:r>
-              <a:rPr sz="900" b="0" i="0">
-                <a:solidFill>
-                  <a:srgbClr val="6B6B6B"/>
-                </a:solidFill>
-                <a:latin typeface="Arial"/>
-              </a:rPr>
-              <a:t>from a natural-language claim to a verified verdict with auditable evidence</a:t>
-            </a:r>
-          </a:p>
-        </p:txBody>
-      </p:sp>
-      <p:sp>
-        <p:nvSpPr>
-          <p:cNvPr id="61" name="Rounded Rectangle 60"/>
+          <p:cNvPr id="56" name="Rounded Rectangle 55"/>
           <p:cNvSpPr/>
           <p:nvPr/>
         </p:nvSpPr>
         <p:spPr>
           <a:xfrm>
-            <a:off x="219456" y="2971800"/>
-            <a:ext cx="2103120" cy="1920240"/>
+            <a:off x="219456" y="3785615"/>
+            <a:ext cx="2212848" cy="2340864"/>
           </a:xfrm>
           <a:prstGeom prst="roundRect">
             <a:avLst>
@@ -6039,14 +5746,14 @@
       </p:sp>
       <p:sp>
         <p:nvSpPr>
-          <p:cNvPr id="62" name="TextBox 61"/>
+          <p:cNvPr id="57" name="TextBox 56"/>
           <p:cNvSpPr txBox="1"/>
           <p:nvPr/>
         </p:nvSpPr>
         <p:spPr>
           <a:xfrm>
-            <a:off x="274320" y="3008376"/>
-            <a:ext cx="2011680" cy="219456"/>
+            <a:off x="274320" y="3831335"/>
+            <a:ext cx="2103120" cy="274320"/>
           </a:xfrm>
           <a:prstGeom prst="rect">
             <a:avLst/>
@@ -6065,20 +5772,20 @@
               </a:lnSpc>
             </a:pPr>
             <a:r>
-              <a:rPr sz="900" b="1" i="0">
+              <a:rPr sz="1200" b="1" i="0">
                 <a:solidFill>
                   <a:srgbClr val="2B2B2B"/>
                 </a:solidFill>
-                <a:latin typeface="Arial"/>
+                <a:latin typeface="Verdana"/>
               </a:rPr>
-              <a:t>Inputs to the system</a:t>
+              <a:t>Inputs</a:t>
             </a:r>
           </a:p>
         </p:txBody>
       </p:sp>
       <p:pic>
         <p:nvPicPr>
-          <p:cNvPr id="63" name="Picture 62" descr="file-text_4F6B75.png"/>
+          <p:cNvPr id="58" name="Picture 57" descr="file-text_4F6B75.png"/>
           <p:cNvPicPr>
             <a:picLocks noChangeAspect="1"/>
           </p:cNvPicPr>
@@ -6092,8 +5799,8 @@
         </p:blipFill>
         <p:spPr>
           <a:xfrm>
-            <a:off x="292608" y="3264408"/>
-            <a:ext cx="310896" cy="310896"/>
+            <a:off x="292608" y="4169663"/>
+            <a:ext cx="329184" cy="329184"/>
           </a:xfrm>
           <a:prstGeom prst="rect">
             <a:avLst/>
@@ -6102,14 +5809,53 @@
       </p:pic>
       <p:sp>
         <p:nvSpPr>
-          <p:cNvPr id="64" name="TextBox 63"/>
+          <p:cNvPr id="59" name="TextBox 58"/>
           <p:cNvSpPr txBox="1"/>
           <p:nvPr/>
         </p:nvSpPr>
         <p:spPr>
           <a:xfrm>
-            <a:off x="658368" y="3246120"/>
-            <a:ext cx="1627632" cy="402336"/>
+            <a:off x="676656" y="4133087"/>
+            <a:ext cx="1737360" cy="457200"/>
+          </a:xfrm>
+          <a:prstGeom prst="rect">
+            <a:avLst/>
+          </a:prstGeom>
+          <a:noFill/>
+        </p:spPr>
+        <p:txBody>
+          <a:bodyPr wrap="square" lIns="27432" rIns="27432" tIns="9144" bIns="9144" anchor="t">
+            <a:spAutoFit/>
+          </a:bodyPr>
+          <a:lstStyle/>
+          <a:p>
+            <a:pPr algn="l">
+              <a:lnSpc>
+                <a:spcPct val="95000"/>
+              </a:lnSpc>
+            </a:pPr>
+            <a:r>
+              <a:rPr sz="1000" b="0" i="0">
+                <a:solidFill>
+                  <a:srgbClr val="2B2B2B"/>
+                </a:solidFill>
+                <a:latin typeface="Verdana"/>
+              </a:rPr>
+              <a:t>a claim in natural language, with its cohort and level</a:t>
+            </a:r>
+          </a:p>
+        </p:txBody>
+      </p:sp>
+      <p:sp>
+        <p:nvSpPr>
+          <p:cNvPr id="60" name="TextBox 59"/>
+          <p:cNvSpPr txBox="1"/>
+          <p:nvPr/>
+        </p:nvSpPr>
+        <p:spPr>
+          <a:xfrm>
+            <a:off x="274320" y="4700016"/>
+            <a:ext cx="2103120" cy="274320"/>
           </a:xfrm>
           <a:prstGeom prst="rect">
             <a:avLst/>
@@ -6128,59 +5874,20 @@
               </a:lnSpc>
             </a:pPr>
             <a:r>
-              <a:rPr sz="700" b="0" i="0">
+              <a:rPr sz="1200" b="1" i="0">
                 <a:solidFill>
                   <a:srgbClr val="2B2B2B"/>
                 </a:solidFill>
-                <a:latin typeface="Arial"/>
+                <a:latin typeface="Verdana"/>
               </a:rPr>
-              <a:t>a claim in natural language, with its cohort and level</a:t>
-            </a:r>
-          </a:p>
-        </p:txBody>
-      </p:sp>
-      <p:sp>
-        <p:nvSpPr>
-          <p:cNvPr id="65" name="TextBox 64"/>
-          <p:cNvSpPr txBox="1"/>
-          <p:nvPr/>
-        </p:nvSpPr>
-        <p:spPr>
-          <a:xfrm>
-            <a:off x="274320" y="3703320"/>
-            <a:ext cx="2011680" cy="219456"/>
-          </a:xfrm>
-          <a:prstGeom prst="rect">
-            <a:avLst/>
-          </a:prstGeom>
-          <a:noFill/>
-        </p:spPr>
-        <p:txBody>
-          <a:bodyPr wrap="square" lIns="27432" rIns="27432" tIns="9144" bIns="9144" anchor="t">
-            <a:spAutoFit/>
-          </a:bodyPr>
-          <a:lstStyle/>
-          <a:p>
-            <a:pPr algn="l">
-              <a:lnSpc>
-                <a:spcPct val="100000"/>
-              </a:lnSpc>
-            </a:pPr>
-            <a:r>
-              <a:rPr sz="900" b="1" i="0">
-                <a:solidFill>
-                  <a:srgbClr val="2B2B2B"/>
-                </a:solidFill>
-                <a:latin typeface="Arial"/>
-              </a:rPr>
-              <a:t>Auxiliary resources (to S1)</a:t>
+              <a:t>Resources (to S1)</a:t>
             </a:r>
           </a:p>
         </p:txBody>
       </p:sp>
       <p:pic>
         <p:nvPicPr>
-          <p:cNvPr id="66" name="Picture 65" descr="list-checks_4F6B75.png"/>
+          <p:cNvPr id="61" name="Picture 60" descr="list-checks_4F6B75.png"/>
           <p:cNvPicPr>
             <a:picLocks noChangeAspect="1"/>
           </p:cNvPicPr>
@@ -6194,8 +5901,8 @@
         </p:blipFill>
         <p:spPr>
           <a:xfrm>
-            <a:off x="292608" y="3959352"/>
-            <a:ext cx="310896" cy="310896"/>
+            <a:off x="292608" y="5065775"/>
+            <a:ext cx="329184" cy="329184"/>
           </a:xfrm>
           <a:prstGeom prst="rect">
             <a:avLst/>
@@ -6204,14 +5911,14 @@
       </p:pic>
       <p:sp>
         <p:nvSpPr>
-          <p:cNvPr id="67" name="TextBox 66"/>
+          <p:cNvPr id="62" name="TextBox 61"/>
           <p:cNvSpPr txBox="1"/>
           <p:nvPr/>
         </p:nvSpPr>
         <p:spPr>
           <a:xfrm>
-            <a:off x="658368" y="3922776"/>
-            <a:ext cx="1627632" cy="457200"/>
+            <a:off x="676656" y="5010912"/>
+            <a:ext cx="1737360" cy="548640"/>
           </a:xfrm>
           <a:prstGeom prst="rect">
             <a:avLst/>
@@ -6226,24 +5933,24 @@
           <a:p>
             <a:pPr algn="l">
               <a:lnSpc>
-                <a:spcPct val="100000"/>
+                <a:spcPct val="95000"/>
               </a:lnSpc>
             </a:pPr>
             <a:r>
-              <a:rPr sz="700" b="0" i="0">
+              <a:rPr sz="1000" b="0" i="0">
                 <a:solidFill>
                   <a:srgbClr val="2B2B2B"/>
                 </a:solidFill>
-                <a:latin typeface="Arial"/>
+                <a:latin typeface="Verdana"/>
               </a:rPr>
-              <a:t>codebook: the corpus stipulations as text; null sources; test definitions; dataset card</a:t>
+              <a:t>codebook: the corpus stipulations as text; null sources; test definitions</a:t>
             </a:r>
           </a:p>
         </p:txBody>
       </p:sp>
       <p:pic>
         <p:nvPicPr>
-          <p:cNvPr id="68" name="Picture 67" descr="database_4F6B75.png"/>
+          <p:cNvPr id="63" name="Picture 62" descr="database_4F6B75.png"/>
           <p:cNvPicPr>
             <a:picLocks noChangeAspect="1"/>
           </p:cNvPicPr>
@@ -6257,8 +5964,8 @@
         </p:blipFill>
         <p:spPr>
           <a:xfrm>
-            <a:off x="292608" y="4434840"/>
-            <a:ext cx="310896" cy="310896"/>
+            <a:off x="292608" y="5632704"/>
+            <a:ext cx="329184" cy="329184"/>
           </a:xfrm>
           <a:prstGeom prst="rect">
             <a:avLst/>
@@ -6267,14 +5974,14 @@
       </p:pic>
       <p:sp>
         <p:nvSpPr>
-          <p:cNvPr id="69" name="TextBox 68"/>
+          <p:cNvPr id="64" name="TextBox 63"/>
           <p:cNvSpPr txBox="1"/>
           <p:nvPr/>
         </p:nvSpPr>
         <p:spPr>
           <a:xfrm>
-            <a:off x="658368" y="4398264"/>
-            <a:ext cx="1627632" cy="457200"/>
+            <a:off x="676656" y="5596127"/>
+            <a:ext cx="1737360" cy="512064"/>
           </a:xfrm>
           <a:prstGeom prst="rect">
             <a:avLst/>
@@ -6289,38 +5996,38 @@
           <a:p>
             <a:pPr algn="l">
               <a:lnSpc>
-                <a:spcPct val="100000"/>
+                <a:spcPct val="95000"/>
               </a:lnSpc>
             </a:pPr>
             <a:r>
-              <a:rPr sz="700" b="0" i="0">
+              <a:rPr sz="1000" b="0" i="0">
                 <a:solidFill>
                   <a:srgbClr val="2B2B2B"/>
                 </a:solidFill>
-                <a:latin typeface="Arial"/>
+                <a:latin typeface="Verdana"/>
               </a:rPr>
-              <a:t>annotation DB: report, vaccine, term, first-mention stage (ids pseudonymised)</a:t>
+              <a:t>annotation DB: report, vaccine, term, first-mention stage</a:t>
             </a:r>
           </a:p>
         </p:txBody>
       </p:sp>
       <p:cxnSp>
         <p:nvCxnSpPr>
-          <p:cNvPr id="70" name="Connector 69"/>
+          <p:cNvPr id="65" name="Connector 64"/>
           <p:cNvCxnSpPr/>
           <p:nvPr/>
         </p:nvCxnSpPr>
         <p:spPr>
           <a:xfrm>
-            <a:off x="2340864" y="3429000"/>
-            <a:ext cx="201168" cy="0"/>
+            <a:off x="2450592" y="4334255"/>
+            <a:ext cx="219456" cy="0"/>
           </a:xfrm>
           <a:prstGeom prst="line">
             <a:avLst/>
           </a:prstGeom>
-          <a:ln w="19050">
+          <a:ln w="22225">
             <a:solidFill>
-              <a:srgbClr val="6B6B6B"/>
+              <a:srgbClr val="5F5F5F"/>
             </a:solidFill>
             <a:tailEnd type="triangle" w="med" len="med"/>
           </a:ln>
@@ -6342,21 +6049,21 @@
       </p:cxnSp>
       <p:cxnSp>
         <p:nvCxnSpPr>
-          <p:cNvPr id="71" name="Connector 70"/>
+          <p:cNvPr id="66" name="Connector 65"/>
           <p:cNvCxnSpPr/>
           <p:nvPr/>
         </p:nvCxnSpPr>
         <p:spPr>
           <a:xfrm>
-            <a:off x="2340864" y="4160520"/>
-            <a:ext cx="201168" cy="0"/>
+            <a:off x="2450592" y="5248656"/>
+            <a:ext cx="219456" cy="0"/>
           </a:xfrm>
           <a:prstGeom prst="line">
             <a:avLst/>
           </a:prstGeom>
-          <a:ln w="19050">
+          <a:ln w="22225">
             <a:solidFill>
-              <a:srgbClr val="6B6B6B"/>
+              <a:srgbClr val="5F5F5F"/>
             </a:solidFill>
             <a:tailEnd type="triangle" w="med" len="med"/>
           </a:ln>
@@ -6378,14 +6085,14 @@
       </p:cxnSp>
       <p:sp>
         <p:nvSpPr>
-          <p:cNvPr id="72" name="Rounded Rectangle 71"/>
+          <p:cNvPr id="67" name="Rounded Rectangle 66"/>
           <p:cNvSpPr/>
           <p:nvPr/>
         </p:nvSpPr>
         <p:spPr>
           <a:xfrm>
-            <a:off x="2578608" y="2971800"/>
-            <a:ext cx="4389120" cy="1920240"/>
+            <a:off x="2706624" y="3785615"/>
+            <a:ext cx="4443984" cy="2340864"/>
           </a:xfrm>
           <a:prstGeom prst="roundRect">
             <a:avLst>
@@ -6422,14 +6129,14 @@
       </p:sp>
       <p:sp>
         <p:nvSpPr>
-          <p:cNvPr id="73" name="Oval 72"/>
+          <p:cNvPr id="68" name="Oval 67"/>
           <p:cNvSpPr/>
           <p:nvPr/>
         </p:nvSpPr>
         <p:spPr>
           <a:xfrm>
-            <a:off x="2651760" y="3026664"/>
-            <a:ext cx="438912" cy="438912"/>
+            <a:off x="2779776" y="3849624"/>
+            <a:ext cx="493776" cy="493776"/>
           </a:xfrm>
           <a:prstGeom prst="ellipse">
             <a:avLst/>
@@ -6462,11 +6169,11 @@
           <a:p>
             <a:pPr algn="ctr"/>
             <a:r>
-              <a:rPr sz="1100" b="1">
+              <a:rPr sz="1300" b="1">
                 <a:solidFill>
                   <a:srgbClr val="FFFFFF"/>
                 </a:solidFill>
-                <a:latin typeface="Arial"/>
+                <a:latin typeface="Verdana"/>
               </a:rPr>
               <a:t>S1</a:t>
             </a:r>
@@ -6474,11 +6181,11 @@
           <a:p>
             <a:pPr algn="ctr"/>
             <a:r>
-              <a:rPr sz="550">
+              <a:rPr sz="650">
                 <a:solidFill>
                   <a:srgbClr val="FFFFFF"/>
                 </a:solidFill>
-                <a:latin typeface="Arial"/>
+                <a:latin typeface="Verdana"/>
               </a:rPr>
               <a:t>LLM</a:t>
             </a:r>
@@ -6487,14 +6194,14 @@
       </p:sp>
       <p:sp>
         <p:nvSpPr>
-          <p:cNvPr id="74" name="TextBox 73"/>
+          <p:cNvPr id="69" name="TextBox 68"/>
           <p:cNvSpPr txBox="1"/>
           <p:nvPr/>
         </p:nvSpPr>
         <p:spPr>
           <a:xfrm>
-            <a:off x="3127248" y="2999232"/>
-            <a:ext cx="3794760" cy="475488"/>
+            <a:off x="3328416" y="3822191"/>
+            <a:ext cx="3794760" cy="548640"/>
           </a:xfrm>
           <a:prstGeom prst="rect">
             <a:avLst/>
@@ -6509,15 +6216,15 @@
           <a:p>
             <a:pPr algn="l">
               <a:lnSpc>
-                <a:spcPct val="100000"/>
+                <a:spcPct val="95000"/>
               </a:lnSpc>
             </a:pPr>
             <a:r>
-              <a:rPr sz="1100" b="1" i="0">
+              <a:rPr sz="1400" b="1" i="0">
                 <a:solidFill>
                   <a:srgbClr val="4F6B75"/>
                 </a:solidFill>
-                <a:latin typeface="Arial"/>
+                <a:latin typeface="Verdana"/>
               </a:rPr>
               <a:t>Articulate</a:t>
             </a:r>
@@ -6525,15 +6232,15 @@
           <a:p>
             <a:pPr algn="l">
               <a:lnSpc>
-                <a:spcPct val="100000"/>
+                <a:spcPct val="95000"/>
               </a:lnSpc>
             </a:pPr>
             <a:r>
-              <a:rPr sz="750" b="0" i="0">
-                <a:solidFill>
-                  <a:srgbClr val="6B6B6B"/>
-                </a:solidFill>
-                <a:latin typeface="Arial"/>
+              <a:rPr sz="1050" b="0" i="0">
+                <a:solidFill>
+                  <a:srgbClr val="5F5F5F"/>
+                </a:solidFill>
+                <a:latin typeface="Verdana"/>
               </a:rPr>
               <a:t>form a structured plan; the claim-type mapping is withheld</a:t>
             </a:r>
@@ -6542,14 +6249,14 @@
       </p:sp>
       <p:sp>
         <p:nvSpPr>
-          <p:cNvPr id="75" name="Rounded Rectangle 74"/>
+          <p:cNvPr id="70" name="Rounded Rectangle 69"/>
           <p:cNvSpPr/>
           <p:nvPr/>
         </p:nvSpPr>
         <p:spPr>
           <a:xfrm>
-            <a:off x="2651760" y="3502152"/>
-            <a:ext cx="1005840" cy="896112"/>
+            <a:off x="2779776" y="4425696"/>
+            <a:ext cx="1033271" cy="1188720"/>
           </a:xfrm>
           <a:prstGeom prst="roundRect">
             <a:avLst>
@@ -6586,14 +6293,14 @@
       </p:sp>
       <p:sp>
         <p:nvSpPr>
-          <p:cNvPr id="76" name="Oval 75"/>
+          <p:cNvPr id="71" name="Oval 70"/>
           <p:cNvSpPr/>
           <p:nvPr/>
         </p:nvSpPr>
         <p:spPr>
           <a:xfrm>
-            <a:off x="2697479" y="3547872"/>
-            <a:ext cx="201168" cy="201168"/>
+            <a:off x="2834640" y="4480559"/>
+            <a:ext cx="237744" cy="237744"/>
           </a:xfrm>
           <a:prstGeom prst="ellipse">
             <a:avLst/>
@@ -6626,11 +6333,11 @@
           <a:p>
             <a:pPr algn="ctr"/>
             <a:r>
-              <a:rPr sz="750" b="1">
+              <a:rPr sz="900" b="1">
                 <a:solidFill>
                   <a:srgbClr val="FFFFFF"/>
                 </a:solidFill>
-                <a:latin typeface="Arial"/>
+                <a:latin typeface="Verdana"/>
               </a:rPr>
               <a:t>1</a:t>
             </a:r>
@@ -6639,14 +6346,14 @@
       </p:sp>
       <p:sp>
         <p:nvSpPr>
-          <p:cNvPr id="77" name="TextBox 76"/>
+          <p:cNvPr id="72" name="TextBox 71"/>
           <p:cNvSpPr txBox="1"/>
           <p:nvPr/>
         </p:nvSpPr>
         <p:spPr>
           <a:xfrm>
-            <a:off x="2926079" y="3520440"/>
-            <a:ext cx="731520" cy="256032"/>
+            <a:off x="3090672" y="4443983"/>
+            <a:ext cx="713232" cy="457200"/>
           </a:xfrm>
           <a:prstGeom prst="rect">
             <a:avLst/>
@@ -6661,15 +6368,15 @@
           <a:p>
             <a:pPr algn="l">
               <a:lnSpc>
-                <a:spcPct val="100000"/>
+                <a:spcPct val="90000"/>
               </a:lnSpc>
             </a:pPr>
             <a:r>
-              <a:rPr sz="700" b="1" i="0">
+              <a:rPr sz="1000" b="1" i="0">
                 <a:solidFill>
                   <a:srgbClr val="2B2B2B"/>
                 </a:solidFill>
-                <a:latin typeface="Arial"/>
+                <a:latin typeface="Verdana"/>
               </a:rPr>
               <a:t>Parse the claim</a:t>
             </a:r>
@@ -6678,7 +6385,7 @@
       </p:sp>
       <p:pic>
         <p:nvPicPr>
-          <p:cNvPr id="78" name="Picture 77" descr="file-search_4F6B75.png"/>
+          <p:cNvPr id="73" name="Picture 72" descr="file-search_4F6B75.png"/>
           <p:cNvPicPr>
             <a:picLocks noChangeAspect="1"/>
           </p:cNvPicPr>
@@ -6692,8 +6399,8 @@
         </p:blipFill>
         <p:spPr>
           <a:xfrm>
-            <a:off x="2706624" y="3794760"/>
-            <a:ext cx="237744" cy="237744"/>
+            <a:off x="2843784" y="4974336"/>
+            <a:ext cx="274320" cy="274320"/>
           </a:xfrm>
           <a:prstGeom prst="rect">
             <a:avLst/>
@@ -6702,14 +6409,14 @@
       </p:pic>
       <p:sp>
         <p:nvSpPr>
-          <p:cNvPr id="79" name="TextBox 78"/>
+          <p:cNvPr id="74" name="TextBox 73"/>
           <p:cNvSpPr txBox="1"/>
           <p:nvPr/>
         </p:nvSpPr>
         <p:spPr>
           <a:xfrm>
-            <a:off x="2962656" y="3776472"/>
-            <a:ext cx="694944" cy="603504"/>
+            <a:off x="3136392" y="4919472"/>
+            <a:ext cx="676656" cy="676656"/>
           </a:xfrm>
           <a:prstGeom prst="rect">
             <a:avLst/>
@@ -6724,54 +6431,38 @@
           <a:p>
             <a:pPr algn="l">
               <a:lnSpc>
-                <a:spcPct val="100000"/>
+                <a:spcPct val="95000"/>
               </a:lnSpc>
             </a:pPr>
             <a:r>
-              <a:rPr sz="620" b="0" i="0">
+              <a:rPr sz="850" b="0" i="0">
                 <a:solidFill>
                   <a:srgbClr val="2B2B2B"/>
                 </a:solidFill>
-                <a:latin typeface="Arial"/>
+                <a:latin typeface="Verdana"/>
               </a:rPr>
-              <a:t>• events, cohort</a:t>
-            </a:r>
-          </a:p>
-          <a:p>
-            <a:pPr algn="l">
-              <a:lnSpc>
-                <a:spcPct val="100000"/>
-              </a:lnSpc>
-            </a:pPr>
-            <a:r>
-              <a:rPr sz="620" b="0" i="0">
-                <a:solidFill>
-                  <a:srgbClr val="2B2B2B"/>
-                </a:solidFill>
-                <a:latin typeface="Arial"/>
-              </a:rPr>
-              <a:t>• quantity, direction</a:t>
+              <a:t>events, cohort, quantity, direction</a:t>
             </a:r>
           </a:p>
         </p:txBody>
       </p:sp>
       <p:cxnSp>
         <p:nvCxnSpPr>
-          <p:cNvPr id="80" name="Connector 79"/>
+          <p:cNvPr id="75" name="Connector 74"/>
           <p:cNvCxnSpPr/>
           <p:nvPr/>
         </p:nvCxnSpPr>
         <p:spPr>
           <a:xfrm>
-            <a:off x="3657600" y="3950208"/>
-            <a:ext cx="54863" cy="0"/>
+            <a:off x="3813048" y="5020056"/>
+            <a:ext cx="50291" cy="0"/>
           </a:xfrm>
           <a:prstGeom prst="line">
             <a:avLst/>
           </a:prstGeom>
-          <a:ln w="12700">
+          <a:ln w="15875">
             <a:solidFill>
-              <a:srgbClr val="6B6B6B"/>
+              <a:srgbClr val="5F5F5F"/>
             </a:solidFill>
             <a:tailEnd type="triangle" w="med" len="med"/>
           </a:ln>
@@ -6793,14 +6484,14 @@
       </p:cxnSp>
       <p:sp>
         <p:nvSpPr>
-          <p:cNvPr id="81" name="Rounded Rectangle 80"/>
+          <p:cNvPr id="76" name="Rounded Rectangle 75"/>
           <p:cNvSpPr/>
           <p:nvPr/>
         </p:nvSpPr>
         <p:spPr>
           <a:xfrm>
-            <a:off x="3712463" y="3502152"/>
-            <a:ext cx="1005840" cy="896112"/>
+            <a:off x="3863339" y="4425696"/>
+            <a:ext cx="1033271" cy="1188720"/>
           </a:xfrm>
           <a:prstGeom prst="roundRect">
             <a:avLst>
@@ -6837,14 +6528,14 @@
       </p:sp>
       <p:sp>
         <p:nvSpPr>
-          <p:cNvPr id="82" name="Oval 81"/>
+          <p:cNvPr id="77" name="Oval 76"/>
           <p:cNvSpPr/>
           <p:nvPr/>
         </p:nvSpPr>
         <p:spPr>
           <a:xfrm>
-            <a:off x="3758183" y="3547872"/>
-            <a:ext cx="201168" cy="201168"/>
+            <a:off x="3918203" y="4480559"/>
+            <a:ext cx="237744" cy="237744"/>
           </a:xfrm>
           <a:prstGeom prst="ellipse">
             <a:avLst/>
@@ -6877,11 +6568,11 @@
           <a:p>
             <a:pPr algn="ctr"/>
             <a:r>
-              <a:rPr sz="750" b="1">
+              <a:rPr sz="900" b="1">
                 <a:solidFill>
                   <a:srgbClr val="FFFFFF"/>
                 </a:solidFill>
-                <a:latin typeface="Arial"/>
+                <a:latin typeface="Verdana"/>
               </a:rPr>
               <a:t>2</a:t>
             </a:r>
@@ -6890,14 +6581,14 @@
       </p:sp>
       <p:sp>
         <p:nvSpPr>
-          <p:cNvPr id="83" name="TextBox 82"/>
+          <p:cNvPr id="78" name="TextBox 77"/>
           <p:cNvSpPr txBox="1"/>
           <p:nvPr/>
         </p:nvSpPr>
         <p:spPr>
           <a:xfrm>
-            <a:off x="3986783" y="3520440"/>
-            <a:ext cx="731520" cy="256032"/>
+            <a:off x="4174235" y="4443983"/>
+            <a:ext cx="713232" cy="457200"/>
           </a:xfrm>
           <a:prstGeom prst="rect">
             <a:avLst/>
@@ -6912,15 +6603,15 @@
           <a:p>
             <a:pPr algn="l">
               <a:lnSpc>
-                <a:spcPct val="100000"/>
+                <a:spcPct val="90000"/>
               </a:lnSpc>
             </a:pPr>
             <a:r>
-              <a:rPr sz="700" b="1" i="0">
+              <a:rPr sz="1000" b="1" i="0">
                 <a:solidFill>
                   <a:srgbClr val="2B2B2B"/>
                 </a:solidFill>
-                <a:latin typeface="Arial"/>
+                <a:latin typeface="Verdana"/>
               </a:rPr>
               <a:t>Choose the primitive</a:t>
             </a:r>
@@ -6929,7 +6620,7 @@
       </p:sp>
       <p:pic>
         <p:nvPicPr>
-          <p:cNvPr id="84" name="Picture 83" descr="git-branch_4F6B75.png"/>
+          <p:cNvPr id="79" name="Picture 78" descr="git-branch_4F6B75.png"/>
           <p:cNvPicPr>
             <a:picLocks noChangeAspect="1"/>
           </p:cNvPicPr>
@@ -6943,8 +6634,8 @@
         </p:blipFill>
         <p:spPr>
           <a:xfrm>
-            <a:off x="3767327" y="3794760"/>
-            <a:ext cx="237744" cy="237744"/>
+            <a:off x="3927348" y="4974336"/>
+            <a:ext cx="274320" cy="274320"/>
           </a:xfrm>
           <a:prstGeom prst="rect">
             <a:avLst/>
@@ -6953,14 +6644,14 @@
       </p:pic>
       <p:sp>
         <p:nvSpPr>
-          <p:cNvPr id="85" name="TextBox 84"/>
+          <p:cNvPr id="80" name="TextBox 79"/>
           <p:cNvSpPr txBox="1"/>
           <p:nvPr/>
         </p:nvSpPr>
         <p:spPr>
           <a:xfrm>
-            <a:off x="4023359" y="3776472"/>
-            <a:ext cx="694944" cy="603504"/>
+            <a:off x="4219955" y="4919472"/>
+            <a:ext cx="676656" cy="676656"/>
           </a:xfrm>
           <a:prstGeom prst="rect">
             <a:avLst/>
@@ -6975,54 +6666,38 @@
           <a:p>
             <a:pPr algn="l">
               <a:lnSpc>
-                <a:spcPct val="100000"/>
+                <a:spcPct val="95000"/>
               </a:lnSpc>
             </a:pPr>
             <a:r>
-              <a:rPr sz="620" b="0" i="0">
+              <a:rPr sz="850" b="0" i="0">
                 <a:solidFill>
                   <a:srgbClr val="2B2B2B"/>
                 </a:solidFill>
-                <a:latin typeface="Arial"/>
+                <a:latin typeface="Verdana"/>
               </a:rPr>
-              <a:t>• denominator rule</a:t>
-            </a:r>
-          </a:p>
-          <a:p>
-            <a:pPr algn="l">
-              <a:lnSpc>
-                <a:spcPct val="100000"/>
-              </a:lnSpc>
-            </a:pPr>
-            <a:r>
-              <a:rPr sz="620" b="0" i="0">
-                <a:solidFill>
-                  <a:srgbClr val="2B2B2B"/>
-                </a:solidFill>
-                <a:latin typeface="Arial"/>
-              </a:rPr>
-              <a:t>• number of arms</a:t>
+              <a:t>denominator rule; arms</a:t>
             </a:r>
           </a:p>
         </p:txBody>
       </p:sp>
       <p:cxnSp>
         <p:nvCxnSpPr>
-          <p:cNvPr id="86" name="Connector 85"/>
+          <p:cNvPr id="81" name="Connector 80"/>
           <p:cNvCxnSpPr/>
           <p:nvPr/>
         </p:nvCxnSpPr>
         <p:spPr>
           <a:xfrm>
-            <a:off x="4718304" y="3950208"/>
-            <a:ext cx="54864" cy="0"/>
+            <a:off x="4896612" y="5020056"/>
+            <a:ext cx="50292" cy="0"/>
           </a:xfrm>
           <a:prstGeom prst="line">
             <a:avLst/>
           </a:prstGeom>
-          <a:ln w="12700">
+          <a:ln w="15875">
             <a:solidFill>
-              <a:srgbClr val="6B6B6B"/>
+              <a:srgbClr val="5F5F5F"/>
             </a:solidFill>
             <a:tailEnd type="triangle" w="med" len="med"/>
           </a:ln>
@@ -7044,14 +6719,14 @@
       </p:cxnSp>
       <p:sp>
         <p:nvSpPr>
-          <p:cNvPr id="87" name="Rounded Rectangle 86"/>
+          <p:cNvPr id="82" name="Rounded Rectangle 81"/>
           <p:cNvSpPr/>
           <p:nvPr/>
         </p:nvSpPr>
         <p:spPr>
           <a:xfrm>
-            <a:off x="4773168" y="3502152"/>
-            <a:ext cx="1005840" cy="896112"/>
+            <a:off x="4946904" y="4425696"/>
+            <a:ext cx="1033271" cy="1188720"/>
           </a:xfrm>
           <a:prstGeom prst="roundRect">
             <a:avLst>
@@ -7088,14 +6763,14 @@
       </p:sp>
       <p:sp>
         <p:nvSpPr>
-          <p:cNvPr id="88" name="Oval 87"/>
+          <p:cNvPr id="83" name="Oval 82"/>
           <p:cNvSpPr/>
           <p:nvPr/>
         </p:nvSpPr>
         <p:spPr>
           <a:xfrm>
-            <a:off x="4818888" y="3547872"/>
-            <a:ext cx="201168" cy="201168"/>
+            <a:off x="5001768" y="4480559"/>
+            <a:ext cx="237744" cy="237744"/>
           </a:xfrm>
           <a:prstGeom prst="ellipse">
             <a:avLst/>
@@ -7128,11 +6803,11 @@
           <a:p>
             <a:pPr algn="ctr"/>
             <a:r>
-              <a:rPr sz="750" b="1">
+              <a:rPr sz="900" b="1">
                 <a:solidFill>
                   <a:srgbClr val="FFFFFF"/>
                 </a:solidFill>
-                <a:latin typeface="Arial"/>
+                <a:latin typeface="Verdana"/>
               </a:rPr>
               <a:t>3</a:t>
             </a:r>
@@ -7141,14 +6816,14 @@
       </p:sp>
       <p:sp>
         <p:nvSpPr>
-          <p:cNvPr id="89" name="TextBox 88"/>
+          <p:cNvPr id="84" name="TextBox 83"/>
           <p:cNvSpPr txBox="1"/>
           <p:nvPr/>
         </p:nvSpPr>
         <p:spPr>
           <a:xfrm>
-            <a:off x="5047488" y="3520440"/>
-            <a:ext cx="731520" cy="256032"/>
+            <a:off x="5257800" y="4443983"/>
+            <a:ext cx="713232" cy="457200"/>
           </a:xfrm>
           <a:prstGeom prst="rect">
             <a:avLst/>
@@ -7163,15 +6838,15 @@
           <a:p>
             <a:pPr algn="l">
               <a:lnSpc>
-                <a:spcPct val="100000"/>
+                <a:spcPct val="90000"/>
               </a:lnSpc>
             </a:pPr>
             <a:r>
-              <a:rPr sz="700" b="1" i="0">
+              <a:rPr sz="1000" b="1" i="0">
                 <a:solidFill>
                   <a:srgbClr val="2B2B2B"/>
                 </a:solidFill>
-                <a:latin typeface="Arial"/>
+                <a:latin typeface="Verdana"/>
               </a:rPr>
               <a:t>Compose the plan</a:t>
             </a:r>
@@ -7180,7 +6855,7 @@
       </p:sp>
       <p:pic>
         <p:nvPicPr>
-          <p:cNvPr id="90" name="Picture 89" descr="sigma_4F6B75.png"/>
+          <p:cNvPr id="85" name="Picture 84" descr="sigma_4F6B75.png"/>
           <p:cNvPicPr>
             <a:picLocks noChangeAspect="1"/>
           </p:cNvPicPr>
@@ -7194,8 +6869,8 @@
         </p:blipFill>
         <p:spPr>
           <a:xfrm>
-            <a:off x="4828031" y="3794760"/>
-            <a:ext cx="237744" cy="237744"/>
+            <a:off x="5010912" y="4974336"/>
+            <a:ext cx="274320" cy="274320"/>
           </a:xfrm>
           <a:prstGeom prst="rect">
             <a:avLst/>
@@ -7204,14 +6879,14 @@
       </p:pic>
       <p:sp>
         <p:nvSpPr>
-          <p:cNvPr id="91" name="TextBox 90"/>
+          <p:cNvPr id="86" name="TextBox 85"/>
           <p:cNvSpPr txBox="1"/>
           <p:nvPr/>
         </p:nvSpPr>
         <p:spPr>
           <a:xfrm>
-            <a:off x="5084064" y="3776472"/>
-            <a:ext cx="694944" cy="603504"/>
+            <a:off x="5303520" y="4919472"/>
+            <a:ext cx="676656" cy="676656"/>
           </a:xfrm>
           <a:prstGeom prst="rect">
             <a:avLst/>
@@ -7226,54 +6901,38 @@
           <a:p>
             <a:pPr algn="l">
               <a:lnSpc>
-                <a:spcPct val="100000"/>
+                <a:spcPct val="95000"/>
               </a:lnSpc>
             </a:pPr>
             <a:r>
-              <a:rPr sz="620" b="0" i="0">
+              <a:rPr sz="850" b="0" i="0">
                 <a:solidFill>
                   <a:srgbClr val="2B2B2B"/>
                 </a:solidFill>
-                <a:latin typeface="Arial"/>
+                <a:latin typeface="Verdana"/>
               </a:rPr>
-              <a:t>• null kind, p0, tail</a:t>
-            </a:r>
-          </a:p>
-          <a:p>
-            <a:pPr algn="l">
-              <a:lnSpc>
-                <a:spcPct val="100000"/>
-              </a:lnSpc>
-            </a:pPr>
-            <a:r>
-              <a:rPr sz="620" b="0" i="0">
-                <a:solidFill>
-                  <a:srgbClr val="2B2B2B"/>
-                </a:solidFill>
-                <a:latin typeface="Arial"/>
-              </a:rPr>
-              <a:t>• test family, floor</a:t>
+              <a:t>null, p0, tail, test family, floor</a:t>
             </a:r>
           </a:p>
         </p:txBody>
       </p:sp>
       <p:cxnSp>
         <p:nvCxnSpPr>
-          <p:cNvPr id="92" name="Connector 91"/>
+          <p:cNvPr id="87" name="Connector 86"/>
           <p:cNvCxnSpPr/>
           <p:nvPr/>
         </p:nvCxnSpPr>
         <p:spPr>
           <a:xfrm>
-            <a:off x="5779008" y="3950208"/>
-            <a:ext cx="54864" cy="0"/>
+            <a:off x="5980176" y="5020056"/>
+            <a:ext cx="50292" cy="0"/>
           </a:xfrm>
           <a:prstGeom prst="line">
             <a:avLst/>
           </a:prstGeom>
-          <a:ln w="12700">
+          <a:ln w="15875">
             <a:solidFill>
-              <a:srgbClr val="6B6B6B"/>
+              <a:srgbClr val="5F5F5F"/>
             </a:solidFill>
             <a:tailEnd type="triangle" w="med" len="med"/>
           </a:ln>
@@ -7295,14 +6954,14 @@
       </p:cxnSp>
       <p:sp>
         <p:nvSpPr>
-          <p:cNvPr id="93" name="Rounded Rectangle 92"/>
+          <p:cNvPr id="88" name="Rounded Rectangle 87"/>
           <p:cNvSpPr/>
           <p:nvPr/>
         </p:nvSpPr>
         <p:spPr>
           <a:xfrm>
-            <a:off x="5833871" y="3502152"/>
-            <a:ext cx="1005840" cy="896112"/>
+            <a:off x="6030468" y="4425696"/>
+            <a:ext cx="1033271" cy="1188720"/>
           </a:xfrm>
           <a:prstGeom prst="roundRect">
             <a:avLst>
@@ -7339,14 +6998,14 @@
       </p:sp>
       <p:sp>
         <p:nvSpPr>
-          <p:cNvPr id="94" name="Oval 93"/>
+          <p:cNvPr id="89" name="Oval 88"/>
           <p:cNvSpPr/>
           <p:nvPr/>
         </p:nvSpPr>
         <p:spPr>
           <a:xfrm>
-            <a:off x="5879591" y="3547872"/>
-            <a:ext cx="201168" cy="201168"/>
+            <a:off x="6085332" y="4480559"/>
+            <a:ext cx="237744" cy="237744"/>
           </a:xfrm>
           <a:prstGeom prst="ellipse">
             <a:avLst/>
@@ -7379,11 +7038,11 @@
           <a:p>
             <a:pPr algn="ctr"/>
             <a:r>
-              <a:rPr sz="750" b="1">
+              <a:rPr sz="900" b="1">
                 <a:solidFill>
                   <a:srgbClr val="FFFFFF"/>
                 </a:solidFill>
-                <a:latin typeface="Arial"/>
+                <a:latin typeface="Verdana"/>
               </a:rPr>
               <a:t>4</a:t>
             </a:r>
@@ -7392,14 +7051,14 @@
       </p:sp>
       <p:sp>
         <p:nvSpPr>
-          <p:cNvPr id="95" name="TextBox 94"/>
+          <p:cNvPr id="90" name="TextBox 89"/>
           <p:cNvSpPr txBox="1"/>
           <p:nvPr/>
         </p:nvSpPr>
         <p:spPr>
           <a:xfrm>
-            <a:off x="6108191" y="3520440"/>
-            <a:ext cx="731520" cy="256032"/>
+            <a:off x="6341364" y="4443983"/>
+            <a:ext cx="713232" cy="457200"/>
           </a:xfrm>
           <a:prstGeom prst="rect">
             <a:avLst/>
@@ -7414,15 +7073,15 @@
           <a:p>
             <a:pPr algn="l">
               <a:lnSpc>
-                <a:spcPct val="100000"/>
+                <a:spcPct val="90000"/>
               </a:lnSpc>
             </a:pPr>
             <a:r>
-              <a:rPr sz="700" b="1" i="0">
+              <a:rPr sz="1000" b="1" i="0">
                 <a:solidFill>
                   <a:srgbClr val="2B2B2B"/>
                 </a:solidFill>
-                <a:latin typeface="Arial"/>
+                <a:latin typeface="Verdana"/>
               </a:rPr>
               <a:t>Verify, 1 round</a:t>
             </a:r>
@@ -7431,7 +7090,7 @@
       </p:sp>
       <p:pic>
         <p:nvPicPr>
-          <p:cNvPr id="96" name="Picture 95" descr="timer-reset_4F6B75.png"/>
+          <p:cNvPr id="91" name="Picture 90" descr="timer-reset_4F6B75.png"/>
           <p:cNvPicPr>
             <a:picLocks noChangeAspect="1"/>
           </p:cNvPicPr>
@@ -7445,8 +7104,8 @@
         </p:blipFill>
         <p:spPr>
           <a:xfrm>
-            <a:off x="5888735" y="3794760"/>
-            <a:ext cx="237744" cy="237744"/>
+            <a:off x="6094476" y="4974336"/>
+            <a:ext cx="274320" cy="274320"/>
           </a:xfrm>
           <a:prstGeom prst="rect">
             <a:avLst/>
@@ -7455,14 +7114,14 @@
       </p:pic>
       <p:sp>
         <p:nvSpPr>
-          <p:cNvPr id="97" name="TextBox 96"/>
+          <p:cNvPr id="92" name="TextBox 91"/>
           <p:cNvSpPr txBox="1"/>
           <p:nvPr/>
         </p:nvSpPr>
         <p:spPr>
           <a:xfrm>
-            <a:off x="6144767" y="3776472"/>
-            <a:ext cx="694944" cy="603504"/>
+            <a:off x="6387084" y="4919472"/>
+            <a:ext cx="676656" cy="676656"/>
           </a:xfrm>
           <a:prstGeom prst="rect">
             <a:avLst/>
@@ -7477,47 +7136,31 @@
           <a:p>
             <a:pPr algn="l">
               <a:lnSpc>
-                <a:spcPct val="100000"/>
+                <a:spcPct val="95000"/>
               </a:lnSpc>
             </a:pPr>
             <a:r>
-              <a:rPr sz="620" b="0" i="0">
+              <a:rPr sz="850" b="0" i="0">
                 <a:solidFill>
                   <a:srgbClr val="2B2B2B"/>
                 </a:solidFill>
-                <a:latin typeface="Arial"/>
+                <a:latin typeface="Verdana"/>
               </a:rPr>
-              <a:t>• plan vs the codebook</a:t>
-            </a:r>
-          </a:p>
-          <a:p>
-            <a:pPr algn="l">
-              <a:lnSpc>
-                <a:spcPct val="100000"/>
-              </a:lnSpc>
-            </a:pPr>
-            <a:r>
-              <a:rPr sz="620" b="0" i="0">
-                <a:solidFill>
-                  <a:srgbClr val="2B2B2B"/>
-                </a:solidFill>
-                <a:latin typeface="Arial"/>
-              </a:rPr>
-              <a:t>• re-ask once</a:t>
-            </a:r>
-          </a:p>
-        </p:txBody>
-      </p:sp>
-      <p:sp>
-        <p:nvSpPr>
-          <p:cNvPr id="98" name="Rounded Rectangle 97"/>
+              <a:t>plan vs the codebook; re-ask once</a:t>
+            </a:r>
+          </a:p>
+        </p:txBody>
+      </p:sp>
+      <p:sp>
+        <p:nvSpPr>
+          <p:cNvPr id="93" name="Rounded Rectangle 92"/>
           <p:cNvSpPr/>
           <p:nvPr/>
         </p:nvSpPr>
         <p:spPr>
           <a:xfrm>
-            <a:off x="2651760" y="4462272"/>
-            <a:ext cx="4242816" cy="365760"/>
+            <a:off x="2779776" y="5669279"/>
+            <a:ext cx="4297680" cy="384048"/>
           </a:xfrm>
           <a:prstGeom prst="roundRect">
             <a:avLst>
@@ -7556,14 +7199,14 @@
       </p:sp>
       <p:sp>
         <p:nvSpPr>
-          <p:cNvPr id="99" name="TextBox 98"/>
+          <p:cNvPr id="94" name="TextBox 93"/>
           <p:cNvSpPr txBox="1"/>
           <p:nvPr/>
         </p:nvSpPr>
         <p:spPr>
           <a:xfrm>
-            <a:off x="2706624" y="4471416"/>
-            <a:ext cx="4151376" cy="347472"/>
+            <a:off x="2834640" y="5678423"/>
+            <a:ext cx="4206240" cy="365760"/>
           </a:xfrm>
           <a:prstGeom prst="rect">
             <a:avLst/>
@@ -7578,45 +7221,45 @@
           <a:p>
             <a:pPr algn="l">
               <a:lnSpc>
-                <a:spcPct val="100000"/>
+                <a:spcPct val="95000"/>
               </a:lnSpc>
             </a:pPr>
             <a:r>
-              <a:rPr sz="700" b="1" i="0">
+              <a:rPr sz="900" b="1" i="0">
                 <a:solidFill>
                   <a:srgbClr val="A0522D"/>
                 </a:solidFill>
-                <a:latin typeface="Arial"/>
+                <a:latin typeface="Verdana"/>
               </a:rPr>
               <a:t>Contract: </a:t>
             </a:r>
             <a:r>
-              <a:rPr sz="700" b="0" i="0">
+              <a:rPr sz="900" b="0" i="0">
                 <a:solidFill>
                   <a:srgbClr val="2B2B2B"/>
                 </a:solidFill>
-                <a:latin typeface="Arial"/>
+                <a:latin typeface="Verdana"/>
               </a:rPr>
-              <a:t>the harness resolves the plan's primitive into its exact rule and states it to S2, so S2 implements a definition rather than interpreting advice</a:t>
+              <a:t>the harness resolves the plan's primitive into its exact rule and states it to S2</a:t>
             </a:r>
           </a:p>
         </p:txBody>
       </p:sp>
       <p:cxnSp>
         <p:nvCxnSpPr>
-          <p:cNvPr id="100" name="Connector 99"/>
+          <p:cNvPr id="95" name="Connector 94"/>
           <p:cNvCxnSpPr/>
           <p:nvPr/>
         </p:nvCxnSpPr>
         <p:spPr>
           <a:xfrm>
-            <a:off x="6986016" y="3931920"/>
-            <a:ext cx="201168" cy="0"/>
+            <a:off x="7168896" y="4974336"/>
+            <a:ext cx="219456" cy="0"/>
           </a:xfrm>
           <a:prstGeom prst="line">
             <a:avLst/>
           </a:prstGeom>
-          <a:ln w="25400">
+          <a:ln w="28575">
             <a:solidFill>
               <a:srgbClr val="A0522D"/>
             </a:solidFill>
@@ -7640,14 +7283,14 @@
       </p:cxnSp>
       <p:sp>
         <p:nvSpPr>
-          <p:cNvPr id="101" name="Rounded Rectangle 100"/>
+          <p:cNvPr id="96" name="Rounded Rectangle 95"/>
           <p:cNvSpPr/>
           <p:nvPr/>
         </p:nvSpPr>
         <p:spPr>
           <a:xfrm>
-            <a:off x="7223760" y="2971800"/>
-            <a:ext cx="2542032" cy="1920240"/>
+            <a:off x="7424927" y="3785615"/>
+            <a:ext cx="2523744" cy="2340864"/>
           </a:xfrm>
           <a:prstGeom prst="roundRect">
             <a:avLst>
@@ -7684,14 +7327,14 @@
       </p:sp>
       <p:sp>
         <p:nvSpPr>
-          <p:cNvPr id="102" name="Oval 101"/>
+          <p:cNvPr id="97" name="Oval 96"/>
           <p:cNvSpPr/>
           <p:nvPr/>
         </p:nvSpPr>
         <p:spPr>
           <a:xfrm>
-            <a:off x="7296912" y="3026664"/>
-            <a:ext cx="438912" cy="438912"/>
+            <a:off x="7498079" y="3849624"/>
+            <a:ext cx="493776" cy="493776"/>
           </a:xfrm>
           <a:prstGeom prst="ellipse">
             <a:avLst/>
@@ -7724,11 +7367,11 @@
           <a:p>
             <a:pPr algn="ctr"/>
             <a:r>
-              <a:rPr sz="1100" b="1">
+              <a:rPr sz="1300" b="1">
                 <a:solidFill>
                   <a:srgbClr val="FFFFFF"/>
                 </a:solidFill>
-                <a:latin typeface="Arial"/>
+                <a:latin typeface="Verdana"/>
               </a:rPr>
               <a:t>S2</a:t>
             </a:r>
@@ -7736,11 +7379,11 @@
           <a:p>
             <a:pPr algn="ctr"/>
             <a:r>
-              <a:rPr sz="550">
+              <a:rPr sz="650">
                 <a:solidFill>
                   <a:srgbClr val="FFFFFF"/>
                 </a:solidFill>
-                <a:latin typeface="Arial"/>
+                <a:latin typeface="Verdana"/>
               </a:rPr>
               <a:t>LLM</a:t>
             </a:r>
@@ -7749,14 +7392,14 @@
       </p:sp>
       <p:sp>
         <p:nvSpPr>
-          <p:cNvPr id="103" name="TextBox 102"/>
+          <p:cNvPr id="98" name="TextBox 97"/>
           <p:cNvSpPr txBox="1"/>
           <p:nvPr/>
         </p:nvSpPr>
         <p:spPr>
           <a:xfrm>
-            <a:off x="7772400" y="2999232"/>
-            <a:ext cx="1965960" cy="475488"/>
+            <a:off x="8046720" y="3822191"/>
+            <a:ext cx="1874519" cy="548640"/>
           </a:xfrm>
           <a:prstGeom prst="rect">
             <a:avLst/>
@@ -7775,11 +7418,11 @@
               </a:lnSpc>
             </a:pPr>
             <a:r>
-              <a:rPr sz="1100" b="1" i="0">
+              <a:rPr sz="1400" b="1" i="0">
                 <a:solidFill>
                   <a:srgbClr val="A0522D"/>
                 </a:solidFill>
-                <a:latin typeface="Arial"/>
+                <a:latin typeface="Verdana"/>
               </a:rPr>
               <a:t>Retrieve</a:t>
             </a:r>
@@ -7791,11 +7434,11 @@
               </a:lnSpc>
             </a:pPr>
             <a:r>
-              <a:rPr sz="750" b="0" i="0">
-                <a:solidFill>
-                  <a:srgbClr val="6B6B6B"/>
-                </a:solidFill>
-                <a:latin typeface="Arial"/>
+              <a:rPr sz="1050" b="0" i="0">
+                <a:solidFill>
+                  <a:srgbClr val="5F5F5F"/>
+                </a:solidFill>
+                <a:latin typeface="Verdana"/>
               </a:rPr>
               <a:t>plan to evidence sets</a:t>
             </a:r>
@@ -7804,7 +7447,7 @@
       </p:sp>
       <p:pic>
         <p:nvPicPr>
-          <p:cNvPr id="104" name="Picture 103" descr="code_A0522D.png"/>
+          <p:cNvPr id="99" name="Picture 98" descr="code_A0522D.png"/>
           <p:cNvPicPr>
             <a:picLocks noChangeAspect="1"/>
           </p:cNvPicPr>
@@ -7818,8 +7461,8 @@
         </p:blipFill>
         <p:spPr>
           <a:xfrm>
-            <a:off x="7296912" y="3538728"/>
-            <a:ext cx="274320" cy="274320"/>
+            <a:off x="7498079" y="4480559"/>
+            <a:ext cx="292608" cy="292608"/>
           </a:xfrm>
           <a:prstGeom prst="rect">
             <a:avLst/>
@@ -7828,14 +7471,14 @@
       </p:pic>
       <p:sp>
         <p:nvSpPr>
-          <p:cNvPr id="105" name="TextBox 104"/>
+          <p:cNvPr id="100" name="TextBox 99"/>
           <p:cNvSpPr txBox="1"/>
           <p:nvPr/>
         </p:nvSpPr>
         <p:spPr>
           <a:xfrm>
-            <a:off x="7626096" y="3520440"/>
-            <a:ext cx="2103120" cy="457200"/>
+            <a:off x="7845552" y="4443983"/>
+            <a:ext cx="2084831" cy="548640"/>
           </a:xfrm>
           <a:prstGeom prst="rect">
             <a:avLst/>
@@ -7850,24 +7493,24 @@
           <a:p>
             <a:pPr algn="l">
               <a:lnSpc>
-                <a:spcPct val="100000"/>
+                <a:spcPct val="95000"/>
               </a:lnSpc>
             </a:pPr>
             <a:r>
-              <a:rPr sz="700" b="0" i="0">
+              <a:rPr sz="900" b="0" i="0">
                 <a:solidFill>
                   <a:srgbClr val="2B2B2B"/>
                 </a:solidFill>
-                <a:latin typeface="Arial"/>
+                <a:latin typeface="Verdana"/>
               </a:rPr>
-              <a:t>told the schema (column listing) and the contract; writes one SQL per arm, one row per report: in_den, in_num, excl</a:t>
+              <a:t>told the schema and the contract; one SQL per arm, one row per report</a:t>
             </a:r>
           </a:p>
         </p:txBody>
       </p:sp>
       <p:pic>
         <p:nvPicPr>
-          <p:cNvPr id="106" name="Picture 105" descr="table-2_A0522D.png"/>
+          <p:cNvPr id="101" name="Picture 100" descr="table-2_A0522D.png"/>
           <p:cNvPicPr>
             <a:picLocks noChangeAspect="1"/>
           </p:cNvPicPr>
@@ -7881,8 +7524,8 @@
         </p:blipFill>
         <p:spPr>
           <a:xfrm>
-            <a:off x="7296912" y="3995927"/>
-            <a:ext cx="274320" cy="274320"/>
+            <a:off x="7498079" y="5047488"/>
+            <a:ext cx="292608" cy="292608"/>
           </a:xfrm>
           <a:prstGeom prst="rect">
             <a:avLst/>
@@ -7891,14 +7534,14 @@
       </p:pic>
       <p:sp>
         <p:nvSpPr>
-          <p:cNvPr id="107" name="TextBox 106"/>
+          <p:cNvPr id="102" name="TextBox 101"/>
           <p:cNvSpPr txBox="1"/>
           <p:nvPr/>
         </p:nvSpPr>
         <p:spPr>
           <a:xfrm>
-            <a:off x="7626096" y="3977639"/>
-            <a:ext cx="2103120" cy="457200"/>
+            <a:off x="7845552" y="5010912"/>
+            <a:ext cx="2084831" cy="548640"/>
           </a:xfrm>
           <a:prstGeom prst="rect">
             <a:avLst/>
@@ -7913,24 +7556,24 @@
           <a:p>
             <a:pPr algn="l">
               <a:lnSpc>
-                <a:spcPct val="100000"/>
+                <a:spcPct val="95000"/>
               </a:lnSpc>
             </a:pPr>
             <a:r>
-              <a:rPr sz="700" b="0" i="0">
+              <a:rPr sz="900" b="0" i="0">
                 <a:solidFill>
                   <a:srgbClr val="2B2B2B"/>
                 </a:solidFill>
-                <a:latin typeface="Arial"/>
+                <a:latin typeface="Verdana"/>
               </a:rPr>
-              <a:t>sandbox: read-only execution → n, k and report-id sets per arm</a:t>
+              <a:t>sandbox: read-only execution → n, k and report ids per arm</a:t>
             </a:r>
           </a:p>
         </p:txBody>
       </p:sp>
       <p:pic>
         <p:nvPicPr>
-          <p:cNvPr id="108" name="Picture 107" descr="timer-reset_A0522D.png"/>
+          <p:cNvPr id="103" name="Picture 102" descr="timer-reset_A0522D.png"/>
           <p:cNvPicPr>
             <a:picLocks noChangeAspect="1"/>
           </p:cNvPicPr>
@@ -7944,8 +7587,8 @@
         </p:blipFill>
         <p:spPr>
           <a:xfrm>
-            <a:off x="7296912" y="4407407"/>
-            <a:ext cx="274320" cy="274320"/>
+            <a:off x="7498079" y="5596128"/>
+            <a:ext cx="292608" cy="292608"/>
           </a:xfrm>
           <a:prstGeom prst="rect">
             <a:avLst/>
@@ -7954,14 +7597,14 @@
       </p:pic>
       <p:sp>
         <p:nvSpPr>
-          <p:cNvPr id="109" name="TextBox 108"/>
+          <p:cNvPr id="104" name="TextBox 103"/>
           <p:cNvSpPr txBox="1"/>
           <p:nvPr/>
         </p:nvSpPr>
         <p:spPr>
           <a:xfrm>
-            <a:off x="7626096" y="4389120"/>
-            <a:ext cx="2103120" cy="457200"/>
+            <a:off x="7845552" y="5559552"/>
+            <a:ext cx="2084831" cy="548640"/>
           </a:xfrm>
           <a:prstGeom prst="rect">
             <a:avLst/>
@@ -7976,38 +7619,38 @@
           <a:p>
             <a:pPr algn="l">
               <a:lnSpc>
-                <a:spcPct val="100000"/>
+                <a:spcPct val="95000"/>
               </a:lnSpc>
             </a:pPr>
             <a:r>
-              <a:rPr sz="700" b="0" i="0">
+              <a:rPr sz="900" b="0" i="0">
                 <a:solidFill>
                   <a:srgbClr val="2B2B2B"/>
                 </a:solidFill>
-                <a:latin typeface="Arial"/>
+                <a:latin typeface="Verdana"/>
               </a:rPr>
-              <a:t>verify, up to 2 rounds: rejected SQL, n = k, empty arm, co-exist / tie / adjacency leaks</a:t>
+              <a:t>verify, up to 2 rounds: rejected SQL, n = k, empty arm, rule leaks</a:t>
             </a:r>
           </a:p>
         </p:txBody>
       </p:sp>
       <p:cxnSp>
         <p:nvCxnSpPr>
-          <p:cNvPr id="110" name="Connector 109"/>
+          <p:cNvPr id="105" name="Connector 104"/>
           <p:cNvCxnSpPr/>
           <p:nvPr/>
         </p:nvCxnSpPr>
         <p:spPr>
           <a:xfrm>
-            <a:off x="9784080" y="3931920"/>
-            <a:ext cx="201168" cy="0"/>
+            <a:off x="9966960" y="4974336"/>
+            <a:ext cx="219456" cy="0"/>
           </a:xfrm>
           <a:prstGeom prst="line">
             <a:avLst/>
           </a:prstGeom>
-          <a:ln w="19050">
+          <a:ln w="22225">
             <a:solidFill>
-              <a:srgbClr val="6B6B6B"/>
+              <a:srgbClr val="5F5F5F"/>
             </a:solidFill>
             <a:tailEnd type="triangle" w="med" len="med"/>
           </a:ln>
@@ -8029,14 +7672,14 @@
       </p:cxnSp>
       <p:sp>
         <p:nvSpPr>
-          <p:cNvPr id="111" name="Rounded Rectangle 110"/>
+          <p:cNvPr id="106" name="Rounded Rectangle 105"/>
           <p:cNvSpPr/>
           <p:nvPr/>
         </p:nvSpPr>
         <p:spPr>
           <a:xfrm>
-            <a:off x="10021824" y="2971800"/>
-            <a:ext cx="2057400" cy="1920240"/>
+            <a:off x="10222992" y="3785615"/>
+            <a:ext cx="1856231" cy="2340864"/>
           </a:xfrm>
           <a:prstGeom prst="roundRect">
             <a:avLst>
@@ -8073,14 +7716,14 @@
       </p:sp>
       <p:sp>
         <p:nvSpPr>
-          <p:cNvPr id="112" name="Oval 111"/>
+          <p:cNvPr id="107" name="Oval 106"/>
           <p:cNvSpPr/>
           <p:nvPr/>
         </p:nvSpPr>
         <p:spPr>
           <a:xfrm>
-            <a:off x="10094976" y="3026664"/>
-            <a:ext cx="438912" cy="438912"/>
+            <a:off x="10296144" y="3849624"/>
+            <a:ext cx="493776" cy="493776"/>
           </a:xfrm>
           <a:prstGeom prst="ellipse">
             <a:avLst/>
@@ -8113,11 +7756,11 @@
           <a:p>
             <a:pPr algn="ctr"/>
             <a:r>
-              <a:rPr sz="1100" b="1">
+              <a:rPr sz="1300" b="1">
                 <a:solidFill>
                   <a:srgbClr val="FFFFFF"/>
                 </a:solidFill>
-                <a:latin typeface="Arial"/>
+                <a:latin typeface="Verdana"/>
               </a:rPr>
               <a:t>S3</a:t>
             </a:r>
@@ -8125,11 +7768,11 @@
           <a:p>
             <a:pPr algn="ctr"/>
             <a:r>
-              <a:rPr sz="550">
+              <a:rPr sz="650">
                 <a:solidFill>
                   <a:srgbClr val="FFFFFF"/>
                 </a:solidFill>
-                <a:latin typeface="Arial"/>
+                <a:latin typeface="Verdana"/>
               </a:rPr>
               <a:t>function</a:t>
             </a:r>
@@ -8138,14 +7781,14 @@
       </p:sp>
       <p:sp>
         <p:nvSpPr>
-          <p:cNvPr id="113" name="TextBox 112"/>
+          <p:cNvPr id="108" name="TextBox 107"/>
           <p:cNvSpPr txBox="1"/>
           <p:nvPr/>
         </p:nvSpPr>
         <p:spPr>
           <a:xfrm>
-            <a:off x="10570464" y="2999232"/>
-            <a:ext cx="1481328" cy="475488"/>
+            <a:off x="10844784" y="3822191"/>
+            <a:ext cx="1216152" cy="548640"/>
           </a:xfrm>
           <a:prstGeom prst="rect">
             <a:avLst/>
@@ -8160,15 +7803,15 @@
           <a:p>
             <a:pPr algn="l">
               <a:lnSpc>
-                <a:spcPct val="100000"/>
+                <a:spcPct val="95000"/>
               </a:lnSpc>
             </a:pPr>
             <a:r>
-              <a:rPr sz="1100" b="1" i="0">
+              <a:rPr sz="1400" b="1" i="0">
                 <a:solidFill>
                   <a:srgbClr val="A8812E"/>
                 </a:solidFill>
-                <a:latin typeface="Arial"/>
+                <a:latin typeface="Verdana"/>
               </a:rPr>
               <a:t>Test</a:t>
             </a:r>
@@ -8176,15 +7819,15 @@
           <a:p>
             <a:pPr algn="l">
               <a:lnSpc>
-                <a:spcPct val="100000"/>
+                <a:spcPct val="95000"/>
               </a:lnSpc>
             </a:pPr>
             <a:r>
-              <a:rPr sz="750" b="0" i="0">
-                <a:solidFill>
-                  <a:srgbClr val="6B6B6B"/>
-                </a:solidFill>
-                <a:latin typeface="Arial"/>
+              <a:rPr sz="1050" b="0" i="0">
+                <a:solidFill>
+                  <a:srgbClr val="5F5F5F"/>
+                </a:solidFill>
+                <a:latin typeface="Verdana"/>
               </a:rPr>
               <a:t>exact, deterministic</a:t>
             </a:r>
@@ -8193,7 +7836,7 @@
       </p:sp>
       <p:pic>
         <p:nvPicPr>
-          <p:cNvPr id="114" name="Picture 113" descr="settings_A8812E.png"/>
+          <p:cNvPr id="109" name="Picture 108" descr="settings_A8812E.png"/>
           <p:cNvPicPr>
             <a:picLocks noChangeAspect="1"/>
           </p:cNvPicPr>
@@ -8207,8 +7850,8 @@
         </p:blipFill>
         <p:spPr>
           <a:xfrm>
-            <a:off x="10094976" y="3538728"/>
-            <a:ext cx="274320" cy="274320"/>
+            <a:off x="10296144" y="4480559"/>
+            <a:ext cx="292608" cy="292608"/>
           </a:xfrm>
           <a:prstGeom prst="rect">
             <a:avLst/>
@@ -8217,14 +7860,14 @@
       </p:pic>
       <p:sp>
         <p:nvSpPr>
-          <p:cNvPr id="115" name="TextBox 114"/>
+          <p:cNvPr id="110" name="TextBox 109"/>
           <p:cNvSpPr txBox="1"/>
           <p:nvPr/>
         </p:nvSpPr>
         <p:spPr>
           <a:xfrm>
-            <a:off x="10424160" y="3502152"/>
-            <a:ext cx="1627632" cy="914400"/>
+            <a:off x="10625328" y="4425696"/>
+            <a:ext cx="1417320" cy="1005840"/>
           </a:xfrm>
           <a:prstGeom prst="rect">
             <a:avLst/>
@@ -8239,72 +7882,24 @@
           <a:p>
             <a:pPr algn="l">
               <a:lnSpc>
-                <a:spcPct val="100000"/>
+                <a:spcPct val="95000"/>
               </a:lnSpc>
             </a:pPr>
             <a:r>
-              <a:rPr sz="620" b="0" i="0">
+              <a:rPr sz="900" b="0" i="0">
                 <a:solidFill>
                   <a:srgbClr val="2B2B2B"/>
                 </a:solidFill>
-                <a:latin typeface="Arial"/>
+                <a:latin typeface="Verdana"/>
               </a:rPr>
-              <a:t>• exact binomial vs p0 (fixed, text-stated or data-derived)</a:t>
-            </a:r>
-          </a:p>
-          <a:p>
-            <a:pPr algn="l">
-              <a:lnSpc>
-                <a:spcPct val="100000"/>
-              </a:lnSpc>
-            </a:pPr>
-            <a:r>
-              <a:rPr sz="620" b="0" i="0">
-                <a:solidFill>
-                  <a:srgbClr val="2B2B2B"/>
-                </a:solidFill>
-                <a:latin typeface="Arial"/>
-              </a:rPr>
-              <a:t>• Fisher's exact test, two arms</a:t>
-            </a:r>
-          </a:p>
-          <a:p>
-            <a:pPr algn="l">
-              <a:lnSpc>
-                <a:spcPct val="100000"/>
-              </a:lnSpc>
-            </a:pPr>
-            <a:r>
-              <a:rPr sz="620" b="0" i="0">
-                <a:solidFill>
-                  <a:srgbClr val="2B2B2B"/>
-                </a:solidFill>
-                <a:latin typeface="Arial"/>
-              </a:rPr>
-              <a:t>• modal-vs-runner-up, argmax</a:t>
-            </a:r>
-          </a:p>
-          <a:p>
-            <a:pPr algn="l">
-              <a:lnSpc>
-                <a:spcPct val="100000"/>
-              </a:lnSpc>
-            </a:pPr>
-            <a:r>
-              <a:rPr sz="620" b="0" i="0">
-                <a:solidFill>
-                  <a:srgbClr val="2B2B2B"/>
-                </a:solidFill>
-                <a:latin typeface="Arial"/>
-              </a:rPr>
-              <a:t>• floor n ≥ 10; both tails</a:t>
+              <a:t>exact binomial vs p0; Fisher's exact test for two arms; modal-vs-runner-up for argmax; floor n ≥ 10</a:t>
             </a:r>
           </a:p>
         </p:txBody>
       </p:sp>
       <p:pic>
         <p:nvPicPr>
-          <p:cNvPr id="116" name="Picture 115" descr="circle-check_4F6B75.png"/>
+          <p:cNvPr id="111" name="Picture 110" descr="circle-check_4F6B75.png"/>
           <p:cNvPicPr>
             <a:picLocks noChangeAspect="1"/>
           </p:cNvPicPr>
@@ -8318,8 +7913,8 @@
         </p:blipFill>
         <p:spPr>
           <a:xfrm>
-            <a:off x="10076688" y="4471416"/>
-            <a:ext cx="219456" cy="219456"/>
+            <a:off x="10296144" y="5413248"/>
+            <a:ext cx="201168" cy="201168"/>
           </a:xfrm>
           <a:prstGeom prst="rect">
             <a:avLst/>
@@ -8328,14 +7923,14 @@
       </p:pic>
       <p:sp>
         <p:nvSpPr>
-          <p:cNvPr id="117" name="TextBox 116"/>
+          <p:cNvPr id="112" name="TextBox 111"/>
           <p:cNvSpPr txBox="1"/>
           <p:nvPr/>
         </p:nvSpPr>
         <p:spPr>
           <a:xfrm>
-            <a:off x="10296144" y="4462272"/>
-            <a:ext cx="603504" cy="237744"/>
+            <a:off x="10533888" y="5385816"/>
+            <a:ext cx="1463040" cy="256032"/>
           </a:xfrm>
           <a:prstGeom prst="rect">
             <a:avLst/>
@@ -8354,11 +7949,11 @@
               </a:lnSpc>
             </a:pPr>
             <a:r>
-              <a:rPr sz="620" b="1" i="0">
+              <a:rPr sz="900" b="1" i="0">
                 <a:solidFill>
                   <a:srgbClr val="2B2B2B"/>
                 </a:solidFill>
-                <a:latin typeface="Arial"/>
+                <a:latin typeface="Verdana"/>
               </a:rPr>
               <a:t>Supported</a:t>
             </a:r>
@@ -8367,7 +7962,7 @@
       </p:sp>
       <p:pic>
         <p:nvPicPr>
-          <p:cNvPr id="118" name="Picture 117" descr="circle-x_A0522D.png"/>
+          <p:cNvPr id="113" name="Picture 112" descr="circle-x_A0522D.png"/>
           <p:cNvPicPr>
             <a:picLocks noChangeAspect="1"/>
           </p:cNvPicPr>
@@ -8381,8 +7976,8 @@
         </p:blipFill>
         <p:spPr>
           <a:xfrm>
-            <a:off x="10735056" y="4471416"/>
-            <a:ext cx="219456" cy="219456"/>
+            <a:off x="10296144" y="5650992"/>
+            <a:ext cx="201168" cy="201168"/>
           </a:xfrm>
           <a:prstGeom prst="rect">
             <a:avLst/>
@@ -8391,14 +7986,14 @@
       </p:pic>
       <p:sp>
         <p:nvSpPr>
-          <p:cNvPr id="119" name="TextBox 118"/>
+          <p:cNvPr id="114" name="TextBox 113"/>
           <p:cNvSpPr txBox="1"/>
           <p:nvPr/>
         </p:nvSpPr>
         <p:spPr>
           <a:xfrm>
-            <a:off x="10954512" y="4462272"/>
-            <a:ext cx="512064" cy="237744"/>
+            <a:off x="10533888" y="5623559"/>
+            <a:ext cx="1463040" cy="256032"/>
           </a:xfrm>
           <a:prstGeom prst="rect">
             <a:avLst/>
@@ -8417,11 +8012,11 @@
               </a:lnSpc>
             </a:pPr>
             <a:r>
-              <a:rPr sz="620" b="1" i="0">
+              <a:rPr sz="900" b="1" i="0">
                 <a:solidFill>
                   <a:srgbClr val="2B2B2B"/>
                 </a:solidFill>
-                <a:latin typeface="Arial"/>
+                <a:latin typeface="Verdana"/>
               </a:rPr>
               <a:t>Refuted</a:t>
             </a:r>
@@ -8430,7 +8025,7 @@
       </p:sp>
       <p:pic>
         <p:nvPicPr>
-          <p:cNvPr id="120" name="Picture 119" descr="circle-help_A8812E.png"/>
+          <p:cNvPr id="115" name="Picture 114" descr="circle-help_A8812E.png"/>
           <p:cNvPicPr>
             <a:picLocks noChangeAspect="1"/>
           </p:cNvPicPr>
@@ -8444,8 +8039,8 @@
         </p:blipFill>
         <p:spPr>
           <a:xfrm>
-            <a:off x="11301984" y="4471416"/>
-            <a:ext cx="219456" cy="219456"/>
+            <a:off x="10296144" y="5888736"/>
+            <a:ext cx="201168" cy="201168"/>
           </a:xfrm>
           <a:prstGeom prst="rect">
             <a:avLst/>
@@ -8454,14 +8049,14 @@
       </p:pic>
       <p:sp>
         <p:nvSpPr>
-          <p:cNvPr id="121" name="TextBox 120"/>
+          <p:cNvPr id="116" name="TextBox 115"/>
           <p:cNvSpPr txBox="1"/>
           <p:nvPr/>
         </p:nvSpPr>
         <p:spPr>
           <a:xfrm>
-            <a:off x="11521440" y="4462272"/>
-            <a:ext cx="731520" cy="237744"/>
+            <a:off x="10533888" y="5861303"/>
+            <a:ext cx="1463040" cy="256032"/>
           </a:xfrm>
           <a:prstGeom prst="rect">
             <a:avLst/>
@@ -8480,11 +8075,11 @@
               </a:lnSpc>
             </a:pPr>
             <a:r>
-              <a:rPr sz="620" b="1" i="0">
+              <a:rPr sz="900" b="1" i="0">
                 <a:solidFill>
                   <a:srgbClr val="2B2B2B"/>
                 </a:solidFill>
-                <a:latin typeface="Arial"/>
+                <a:latin typeface="Verdana"/>
               </a:rPr>
               <a:t>Insufficient</a:t>
             </a:r>
@@ -8493,53 +8088,14 @@
       </p:sp>
       <p:sp>
         <p:nvSpPr>
-          <p:cNvPr id="122" name="TextBox 121"/>
-          <p:cNvSpPr txBox="1"/>
-          <p:nvPr/>
-        </p:nvSpPr>
-        <p:spPr>
-          <a:xfrm>
-            <a:off x="10076688" y="4690872"/>
-            <a:ext cx="1965960" cy="182880"/>
-          </a:xfrm>
-          <a:prstGeom prst="rect">
-            <a:avLst/>
-          </a:prstGeom>
-          <a:noFill/>
-        </p:spPr>
-        <p:txBody>
-          <a:bodyPr wrap="square" lIns="27432" rIns="27432" tIns="9144" bIns="9144" anchor="t">
-            <a:spAutoFit/>
-          </a:bodyPr>
-          <a:lstStyle/>
-          <a:p>
-            <a:pPr algn="l">
-              <a:lnSpc>
-                <a:spcPct val="100000"/>
-              </a:lnSpc>
-            </a:pPr>
-            <a:r>
-              <a:rPr sz="560" b="0" i="0">
-                <a:solidFill>
-                  <a:srgbClr val="6B6B6B"/>
-                </a:solidFill>
-                <a:latin typeface="Arial"/>
-              </a:rPr>
-              <a:t>insufficient: not-locatable / sparse / underpowered</a:t>
-            </a:r>
-          </a:p>
-        </p:txBody>
-      </p:sp>
-      <p:sp>
-        <p:nvSpPr>
-          <p:cNvPr id="123" name="Rounded Rectangle 122"/>
+          <p:cNvPr id="117" name="Rounded Rectangle 116"/>
           <p:cNvSpPr/>
           <p:nvPr/>
         </p:nvSpPr>
         <p:spPr>
           <a:xfrm>
-            <a:off x="109728" y="5047488"/>
-            <a:ext cx="11969496" cy="1115568"/>
+            <a:off x="109728" y="6309360"/>
+            <a:ext cx="11972239" cy="1051560"/>
           </a:xfrm>
           <a:prstGeom prst="roundRect">
             <a:avLst>
@@ -8576,14 +8132,14 @@
       </p:sp>
       <p:sp>
         <p:nvSpPr>
-          <p:cNvPr id="124" name="Oval 123"/>
+          <p:cNvPr id="118" name="Oval 117"/>
           <p:cNvSpPr/>
           <p:nvPr/>
         </p:nvSpPr>
         <p:spPr>
           <a:xfrm>
-            <a:off x="219456" y="5285232"/>
-            <a:ext cx="365760" cy="365760"/>
+            <a:off x="237744" y="6601968"/>
+            <a:ext cx="420624" cy="420624"/>
           </a:xfrm>
           <a:prstGeom prst="ellipse">
             <a:avLst/>
@@ -8616,11 +8172,11 @@
           <a:p>
             <a:pPr algn="ctr"/>
             <a:r>
-              <a:rPr sz="1300" b="1">
+              <a:rPr sz="1500" b="1">
                 <a:solidFill>
                   <a:srgbClr val="FFFFFF"/>
                 </a:solidFill>
-                <a:latin typeface="Arial"/>
+                <a:latin typeface="Verdana"/>
               </a:rPr>
               <a:t>3</a:t>
             </a:r>
@@ -8629,14 +8185,14 @@
       </p:sp>
       <p:sp>
         <p:nvSpPr>
-          <p:cNvPr id="125" name="TextBox 124"/>
+          <p:cNvPr id="119" name="TextBox 118"/>
           <p:cNvSpPr txBox="1"/>
           <p:nvPr/>
         </p:nvSpPr>
         <p:spPr>
           <a:xfrm>
-            <a:off x="640080" y="5230368"/>
-            <a:ext cx="2286000" cy="457200"/>
+            <a:off x="731520" y="6473952"/>
+            <a:ext cx="3108960" cy="457200"/>
           </a:xfrm>
           <a:prstGeom prst="rect">
             <a:avLst/>
@@ -8655,11 +8211,11 @@
               </a:lnSpc>
             </a:pPr>
             <a:r>
-              <a:rPr sz="1500" b="1" i="0">
+              <a:rPr sz="1800" b="1" i="0">
                 <a:solidFill>
                   <a:srgbClr val="4F6B75"/>
                 </a:solidFill>
-                <a:latin typeface="Arial"/>
+                <a:latin typeface="Verdana"/>
               </a:rPr>
               <a:t>Stage-level Evaluation</a:t>
             </a:r>
@@ -8668,14 +8224,14 @@
       </p:sp>
       <p:sp>
         <p:nvSpPr>
-          <p:cNvPr id="126" name="TextBox 125"/>
+          <p:cNvPr id="120" name="TextBox 119"/>
           <p:cNvSpPr txBox="1"/>
           <p:nvPr/>
         </p:nvSpPr>
         <p:spPr>
           <a:xfrm>
-            <a:off x="640080" y="5650992"/>
-            <a:ext cx="2286000" cy="411480"/>
+            <a:off x="749808" y="6912864"/>
+            <a:ext cx="3108960" cy="320040"/>
           </a:xfrm>
           <a:prstGeom prst="rect">
             <a:avLst/>
@@ -8694,27 +8250,27 @@
               </a:lnSpc>
             </a:pPr>
             <a:r>
-              <a:rPr sz="700" b="0" i="0">
-                <a:solidFill>
-                  <a:srgbClr val="6B6B6B"/>
-                </a:solidFill>
-                <a:latin typeface="Arial"/>
+              <a:rPr sz="900" b="0" i="0">
+                <a:solidFill>
+                  <a:srgbClr val="5F5F5F"/>
+                </a:solidFill>
+                <a:latin typeface="Verdana"/>
               </a:rPr>
-              <a:t>any stage can be set to gold to isolate the others</a:t>
-            </a:r>
-          </a:p>
-        </p:txBody>
-      </p:sp>
-      <p:sp>
-        <p:nvSpPr>
-          <p:cNvPr id="127" name="Rounded Rectangle 126"/>
+              <a:t>any stage can be set to gold</a:t>
+            </a:r>
+          </a:p>
+        </p:txBody>
+      </p:sp>
+      <p:sp>
+        <p:nvSpPr>
+          <p:cNvPr id="121" name="Rounded Rectangle 120"/>
           <p:cNvSpPr/>
           <p:nvPr/>
         </p:nvSpPr>
         <p:spPr>
           <a:xfrm>
-            <a:off x="3017520" y="5138928"/>
-            <a:ext cx="2944368" cy="932688"/>
+            <a:off x="3657600" y="6400800"/>
+            <a:ext cx="2724912" cy="868680"/>
           </a:xfrm>
           <a:prstGeom prst="roundRect">
             <a:avLst>
@@ -8753,7 +8309,7 @@
       </p:sp>
       <p:pic>
         <p:nvPicPr>
-          <p:cNvPr id="128" name="Picture 127" descr="file-check_4F6B75.png"/>
+          <p:cNvPr id="122" name="Picture 121" descr="file-check_4F6B75.png"/>
           <p:cNvPicPr>
             <a:picLocks noChangeAspect="1"/>
           </p:cNvPicPr>
@@ -8767,8 +8323,8 @@
         </p:blipFill>
         <p:spPr>
           <a:xfrm>
-            <a:off x="3108960" y="5394960"/>
-            <a:ext cx="402336" cy="402336"/>
+            <a:off x="3749039" y="6620256"/>
+            <a:ext cx="420624" cy="420624"/>
           </a:xfrm>
           <a:prstGeom prst="rect">
             <a:avLst/>
@@ -8777,14 +8333,14 @@
       </p:pic>
       <p:sp>
         <p:nvSpPr>
-          <p:cNvPr id="129" name="TextBox 128"/>
+          <p:cNvPr id="123" name="TextBox 122"/>
           <p:cNvSpPr txBox="1"/>
           <p:nvPr/>
         </p:nvSpPr>
         <p:spPr>
           <a:xfrm>
-            <a:off x="3584448" y="5175504"/>
-            <a:ext cx="2331720" cy="877824"/>
+            <a:off x="4261104" y="6437376"/>
+            <a:ext cx="2103120" cy="804672"/>
           </a:xfrm>
           <a:prstGeom prst="rect">
             <a:avLst/>
@@ -8799,15 +8355,15 @@
           <a:p>
             <a:pPr algn="l">
               <a:lnSpc>
-                <a:spcPct val="105000"/>
+                <a:spcPct val="95000"/>
               </a:lnSpc>
             </a:pPr>
             <a:r>
-              <a:rPr sz="900" b="1" i="0">
+              <a:rPr sz="1200" b="1" i="0">
                 <a:solidFill>
                   <a:srgbClr val="4F6B75"/>
                 </a:solidFill>
-                <a:latin typeface="Arial"/>
+                <a:latin typeface="Verdana"/>
               </a:rPr>
               <a:t>Plan correctness</a:t>
             </a:r>
@@ -8815,31 +8371,15 @@
           <a:p>
             <a:pPr algn="l">
               <a:lnSpc>
-                <a:spcPct val="105000"/>
+                <a:spcPct val="95000"/>
               </a:lnSpc>
             </a:pPr>
             <a:r>
-              <a:rPr sz="700" b="0" i="0">
-                <a:solidFill>
-                  <a:srgbClr val="2B2B2B"/>
-                </a:solidFill>
-                <a:latin typeface="Arial"/>
-              </a:rPr>
-              <a:t>the plan against the gold plan</a:t>
-            </a:r>
-          </a:p>
-          <a:p>
-            <a:pPr algn="l">
-              <a:lnSpc>
-                <a:spcPct val="105000"/>
-              </a:lnSpc>
-            </a:pPr>
-            <a:r>
-              <a:rPr sz="620" b="0" i="0">
-                <a:solidFill>
-                  <a:srgbClr val="6B6B6B"/>
-                </a:solidFill>
-                <a:latin typeface="Arial"/>
+              <a:rPr sz="900" b="0" i="0">
+                <a:solidFill>
+                  <a:srgbClr val="5F5F5F"/>
+                </a:solidFill>
+                <a:latin typeface="Verdana"/>
               </a:rPr>
               <a:t>plan EM, claim-type EM</a:t>
             </a:r>
@@ -8848,14 +8388,14 @@
       </p:sp>
       <p:sp>
         <p:nvSpPr>
-          <p:cNvPr id="130" name="Rounded Rectangle 129"/>
+          <p:cNvPr id="124" name="Rounded Rectangle 123"/>
           <p:cNvSpPr/>
           <p:nvPr/>
         </p:nvSpPr>
         <p:spPr>
           <a:xfrm>
-            <a:off x="6053327" y="5138928"/>
-            <a:ext cx="2944368" cy="932688"/>
+            <a:off x="6473952" y="6400800"/>
+            <a:ext cx="2724912" cy="868680"/>
           </a:xfrm>
           <a:prstGeom prst="roundRect">
             <a:avLst>
@@ -8894,7 +8434,7 @@
       </p:sp>
       <p:pic>
         <p:nvPicPr>
-          <p:cNvPr id="131" name="Picture 130" descr="database_A0522D.png"/>
+          <p:cNvPr id="125" name="Picture 124" descr="database_A0522D.png"/>
           <p:cNvPicPr>
             <a:picLocks noChangeAspect="1"/>
           </p:cNvPicPr>
@@ -8908,8 +8448,8 @@
         </p:blipFill>
         <p:spPr>
           <a:xfrm>
-            <a:off x="6144767" y="5394960"/>
-            <a:ext cx="402336" cy="402336"/>
+            <a:off x="6565392" y="6620256"/>
+            <a:ext cx="420624" cy="420624"/>
           </a:xfrm>
           <a:prstGeom prst="rect">
             <a:avLst/>
@@ -8918,14 +8458,14 @@
       </p:pic>
       <p:sp>
         <p:nvSpPr>
-          <p:cNvPr id="132" name="TextBox 131"/>
+          <p:cNvPr id="126" name="TextBox 125"/>
           <p:cNvSpPr txBox="1"/>
           <p:nvPr/>
         </p:nvSpPr>
         <p:spPr>
           <a:xfrm>
-            <a:off x="6620255" y="5175504"/>
-            <a:ext cx="2331720" cy="877824"/>
+            <a:off x="7077456" y="6437376"/>
+            <a:ext cx="2103120" cy="804672"/>
           </a:xfrm>
           <a:prstGeom prst="rect">
             <a:avLst/>
@@ -8940,15 +8480,15 @@
           <a:p>
             <a:pPr algn="l">
               <a:lnSpc>
-                <a:spcPct val="105000"/>
+                <a:spcPct val="95000"/>
               </a:lnSpc>
             </a:pPr>
             <a:r>
-              <a:rPr sz="900" b="1" i="0">
+              <a:rPr sz="1200" b="1" i="0">
                 <a:solidFill>
                   <a:srgbClr val="A0522D"/>
                 </a:solidFill>
-                <a:latin typeface="Arial"/>
+                <a:latin typeface="Verdana"/>
               </a:rPr>
               <a:t>Evidence correctness</a:t>
             </a:r>
@@ -8956,47 +8496,31 @@
           <a:p>
             <a:pPr algn="l">
               <a:lnSpc>
-                <a:spcPct val="105000"/>
+                <a:spcPct val="95000"/>
               </a:lnSpc>
             </a:pPr>
             <a:r>
-              <a:rPr sz="700" b="0" i="0">
-                <a:solidFill>
-                  <a:srgbClr val="2B2B2B"/>
-                </a:solidFill>
-                <a:latin typeface="Arial"/>
+              <a:rPr sz="900" b="0" i="0">
+                <a:solidFill>
+                  <a:srgbClr val="5F5F5F"/>
+                </a:solidFill>
+                <a:latin typeface="Verdana"/>
               </a:rPr>
-              <a:t>the retrieved report sets against the gold sets</a:t>
-            </a:r>
-          </a:p>
-          <a:p>
-            <a:pPr algn="l">
-              <a:lnSpc>
-                <a:spcPct val="105000"/>
-              </a:lnSpc>
-            </a:pPr>
-            <a:r>
-              <a:rPr sz="620" b="0" i="0">
-                <a:solidFill>
-                  <a:srgbClr val="6B6B6B"/>
-                </a:solidFill>
-                <a:latin typeface="Arial"/>
-              </a:rPr>
-              <a:t>evidence F1, co-exist / tie leak, faithfulness P(evidence exact | verdict right)</a:t>
-            </a:r>
-          </a:p>
-        </p:txBody>
-      </p:sp>
-      <p:sp>
-        <p:nvSpPr>
-          <p:cNvPr id="133" name="Rounded Rectangle 132"/>
+              <a:t>evidence F1, co-exist / tie leak, faithfulness</a:t>
+            </a:r>
+          </a:p>
+        </p:txBody>
+      </p:sp>
+      <p:sp>
+        <p:nvSpPr>
+          <p:cNvPr id="127" name="Rounded Rectangle 126"/>
           <p:cNvSpPr/>
           <p:nvPr/>
         </p:nvSpPr>
         <p:spPr>
           <a:xfrm>
-            <a:off x="9089136" y="5138928"/>
-            <a:ext cx="2944368" cy="932688"/>
+            <a:off x="9290304" y="6400800"/>
+            <a:ext cx="2724912" cy="868680"/>
           </a:xfrm>
           <a:prstGeom prst="roundRect">
             <a:avLst>
@@ -9035,7 +8559,7 @@
       </p:sp>
       <p:pic>
         <p:nvPicPr>
-          <p:cNvPr id="134" name="Picture 133" descr="scale_A8812E.png"/>
+          <p:cNvPr id="128" name="Picture 127" descr="scale_A8812E.png"/>
           <p:cNvPicPr>
             <a:picLocks noChangeAspect="1"/>
           </p:cNvPicPr>
@@ -9049,8 +8573,8 @@
         </p:blipFill>
         <p:spPr>
           <a:xfrm>
-            <a:off x="9180576" y="5394960"/>
-            <a:ext cx="402336" cy="402336"/>
+            <a:off x="9381744" y="6620256"/>
+            <a:ext cx="420624" cy="420624"/>
           </a:xfrm>
           <a:prstGeom prst="rect">
             <a:avLst/>
@@ -9059,14 +8583,14 @@
       </p:pic>
       <p:sp>
         <p:nvSpPr>
-          <p:cNvPr id="135" name="TextBox 134"/>
+          <p:cNvPr id="129" name="TextBox 128"/>
           <p:cNvSpPr txBox="1"/>
           <p:nvPr/>
         </p:nvSpPr>
         <p:spPr>
           <a:xfrm>
-            <a:off x="9656063" y="5175504"/>
-            <a:ext cx="2331720" cy="877824"/>
+            <a:off x="9893808" y="6437376"/>
+            <a:ext cx="2103120" cy="804672"/>
           </a:xfrm>
           <a:prstGeom prst="rect">
             <a:avLst/>
@@ -9081,15 +8605,15 @@
           <a:p>
             <a:pPr algn="l">
               <a:lnSpc>
-                <a:spcPct val="105000"/>
+                <a:spcPct val="95000"/>
               </a:lnSpc>
             </a:pPr>
             <a:r>
-              <a:rPr sz="900" b="1" i="0">
+              <a:rPr sz="1200" b="1" i="0">
                 <a:solidFill>
                   <a:srgbClr val="A8812E"/>
                 </a:solidFill>
-                <a:latin typeface="Arial"/>
+                <a:latin typeface="Verdana"/>
               </a:rPr>
               <a:t>Verdict and abstention</a:t>
             </a:r>
@@ -9097,33 +8621,17 @@
           <a:p>
             <a:pPr algn="l">
               <a:lnSpc>
-                <a:spcPct val="105000"/>
+                <a:spcPct val="95000"/>
               </a:lnSpc>
             </a:pPr>
             <a:r>
-              <a:rPr sz="700" b="0" i="0">
-                <a:solidFill>
-                  <a:srgbClr val="2B2B2B"/>
-                </a:solidFill>
-                <a:latin typeface="Arial"/>
+              <a:rPr sz="900" b="0" i="0">
+                <a:solidFill>
+                  <a:srgbClr val="5F5F5F"/>
+                </a:solidFill>
+                <a:latin typeface="Verdana"/>
               </a:rPr>
-              <a:t>the test and verdict against the gold</a:t>
-            </a:r>
-          </a:p>
-          <a:p>
-            <a:pPr algn="l">
-              <a:lnSpc>
-                <a:spcPct val="105000"/>
-              </a:lnSpc>
-            </a:pPr>
-            <a:r>
-              <a:rPr sz="620" b="0" i="0">
-                <a:solidFill>
-                  <a:srgbClr val="6B6B6B"/>
-                </a:solidFill>
-                <a:latin typeface="Arial"/>
-              </a:rPr>
-              <a:t>accuracy, macro P/R/F1, p-agreement, overclaim, underclaim, sub-type accuracy</a:t>
+              <a:t>accuracy, macro P/R/F1, overclaim, underclaim</a:t>
             </a:r>
           </a:p>
         </p:txBody>

</xml_diff>

<commit_message>
Framework slide: band titles 16 pt, connector shadows off, panels inset symmetrically inside the band shading
Co-Authored-By: Claude Fable 5.1 <noreply@anthropic.com>
</commit_message>
<xml_diff>
--- a/docs/draft/Figures/STRATA_framework_editable.pptx
+++ b/docs/draft/Figures/STRATA_framework_editable.pptx
@@ -3096,8 +3096,8 @@
         </p:nvSpPr>
         <p:spPr>
           <a:xfrm>
-            <a:off x="109728" y="91440"/>
-            <a:ext cx="11972239" cy="3017520"/>
+            <a:off x="91440" y="91440"/>
+            <a:ext cx="12008815" cy="3017520"/>
           </a:xfrm>
           <a:prstGeom prst="roundRect">
             <a:avLst>
@@ -3213,7 +3213,7 @@
               </a:lnSpc>
             </a:pPr>
             <a:r>
-              <a:rPr sz="1800" b="1" i="0">
+              <a:rPr sz="1600" b="1" i="0">
                 <a:solidFill>
                   <a:srgbClr val="A0522D"/>
                 </a:solidFill>
@@ -3578,6 +3578,7 @@
               <a:srgbClr val="4F6B75"/>
             </a:solidFill>
           </a:ln>
+          <a:effectLst/>
         </p:spPr>
         <p:style>
           <a:lnRef idx="2">
@@ -3586,7 +3587,7 @@
           <a:fillRef idx="0">
             <a:schemeClr val="accent1"/>
           </a:fillRef>
-          <a:effectRef idx="1">
+          <a:effectRef idx="0">
             <a:schemeClr val="accent1"/>
           </a:effectRef>
           <a:fontRef idx="minor">
@@ -3929,6 +3930,7 @@
             </a:solidFill>
             <a:tailEnd type="triangle" w="med" len="med"/>
           </a:ln>
+          <a:effectLst/>
         </p:spPr>
         <p:style>
           <a:lnRef idx="2">
@@ -3937,7 +3939,7 @@
           <a:fillRef idx="0">
             <a:schemeClr val="accent1"/>
           </a:fillRef>
-          <a:effectRef idx="1">
+          <a:effectRef idx="0">
             <a:schemeClr val="accent1"/>
           </a:effectRef>
           <a:fontRef idx="minor">
@@ -4453,6 +4455,7 @@
             </a:solidFill>
             <a:tailEnd type="triangle" w="med" len="med"/>
           </a:ln>
+          <a:effectLst/>
         </p:spPr>
         <p:style>
           <a:lnRef idx="2">
@@ -4461,7 +4464,7 @@
           <a:fillRef idx="0">
             <a:schemeClr val="accent1"/>
           </a:fillRef>
-          <a:effectRef idx="1">
+          <a:effectRef idx="0">
             <a:schemeClr val="accent1"/>
           </a:effectRef>
           <a:fontRef idx="minor">
@@ -4998,6 +5001,7 @@
             </a:solidFill>
             <a:tailEnd type="triangle" w="med" len="med"/>
           </a:ln>
+          <a:effectLst/>
         </p:spPr>
         <p:style>
           <a:lnRef idx="2">
@@ -5006,7 +5010,7 @@
           <a:fillRef idx="0">
             <a:schemeClr val="accent1"/>
           </a:fillRef>
-          <a:effectRef idx="1">
+          <a:effectRef idx="0">
             <a:schemeClr val="accent1"/>
           </a:effectRef>
           <a:fontRef idx="minor">
@@ -5023,7 +5027,7 @@
         <p:spPr>
           <a:xfrm>
             <a:off x="9509760" y="676656"/>
-            <a:ext cx="2569464" cy="2340864"/>
+            <a:ext cx="2459736" cy="2340864"/>
           </a:xfrm>
           <a:prstGeom prst="roundRect">
             <a:avLst>
@@ -5124,7 +5128,7 @@
         <p:spPr>
           <a:xfrm>
             <a:off x="10076688" y="713232"/>
-            <a:ext cx="1947672" cy="310896"/>
+            <a:ext cx="1837943" cy="310896"/>
           </a:xfrm>
           <a:prstGeom prst="rect">
             <a:avLst/>
@@ -5163,7 +5167,7 @@
         <p:spPr>
           <a:xfrm>
             <a:off x="9582912" y="1078992"/>
-            <a:ext cx="2423160" cy="548640"/>
+            <a:ext cx="2313432" cy="548640"/>
           </a:xfrm>
           <a:prstGeom prst="roundRect">
             <a:avLst>
@@ -5231,7 +5235,7 @@
         <p:spPr>
           <a:xfrm>
             <a:off x="9985248" y="1097280"/>
-            <a:ext cx="2011680" cy="512063"/>
+            <a:ext cx="1901952" cy="512063"/>
           </a:xfrm>
           <a:prstGeom prst="rect">
             <a:avLst/>
@@ -5286,7 +5290,7 @@
         <p:spPr>
           <a:xfrm>
             <a:off x="9582912" y="1682496"/>
-            <a:ext cx="2423160" cy="475488"/>
+            <a:ext cx="2313432" cy="475488"/>
           </a:xfrm>
           <a:prstGeom prst="roundRect">
             <a:avLst>
@@ -5354,7 +5358,7 @@
         <p:spPr>
           <a:xfrm>
             <a:off x="9985248" y="1700784"/>
-            <a:ext cx="2011680" cy="438912"/>
+            <a:ext cx="1901952" cy="438912"/>
           </a:xfrm>
           <a:prstGeom prst="rect">
             <a:avLst/>
@@ -5409,7 +5413,7 @@
         <p:spPr>
           <a:xfrm>
             <a:off x="9582912" y="2212848"/>
-            <a:ext cx="2423160" cy="548640"/>
+            <a:ext cx="2313432" cy="548640"/>
           </a:xfrm>
           <a:prstGeom prst="roundRect">
             <a:avLst>
@@ -5477,7 +5481,7 @@
         <p:spPr>
           <a:xfrm>
             <a:off x="9985248" y="2231136"/>
-            <a:ext cx="2011680" cy="512063"/>
+            <a:ext cx="1901952" cy="512063"/>
           </a:xfrm>
           <a:prstGeom prst="rect">
             <a:avLst/>
@@ -5532,7 +5536,7 @@
         <p:spPr>
           <a:xfrm>
             <a:off x="9582912" y="2779776"/>
-            <a:ext cx="2423160" cy="219456"/>
+            <a:ext cx="2313432" cy="219456"/>
           </a:xfrm>
           <a:prstGeom prst="rect">
             <a:avLst/>
@@ -5570,8 +5574,8 @@
         </p:nvSpPr>
         <p:spPr>
           <a:xfrm>
-            <a:off x="109728" y="3200400"/>
-            <a:ext cx="11972239" cy="3017520"/>
+            <a:off x="91440" y="3200400"/>
+            <a:ext cx="12008815" cy="3017520"/>
           </a:xfrm>
           <a:prstGeom prst="roundRect">
             <a:avLst>
@@ -5687,7 +5691,7 @@
               </a:lnSpc>
             </a:pPr>
             <a:r>
-              <a:rPr sz="1800" b="1" i="0">
+              <a:rPr sz="1600" b="1" i="0">
                 <a:solidFill>
                   <a:srgbClr val="A0522D"/>
                 </a:solidFill>
@@ -6031,6 +6035,7 @@
             </a:solidFill>
             <a:tailEnd type="triangle" w="med" len="med"/>
           </a:ln>
+          <a:effectLst/>
         </p:spPr>
         <p:style>
           <a:lnRef idx="2">
@@ -6039,7 +6044,7 @@
           <a:fillRef idx="0">
             <a:schemeClr val="accent1"/>
           </a:fillRef>
-          <a:effectRef idx="1">
+          <a:effectRef idx="0">
             <a:schemeClr val="accent1"/>
           </a:effectRef>
           <a:fontRef idx="minor">
@@ -6067,6 +6072,7 @@
             </a:solidFill>
             <a:tailEnd type="triangle" w="med" len="med"/>
           </a:ln>
+          <a:effectLst/>
         </p:spPr>
         <p:style>
           <a:lnRef idx="2">
@@ -6075,7 +6081,7 @@
           <a:fillRef idx="0">
             <a:schemeClr val="accent1"/>
           </a:fillRef>
-          <a:effectRef idx="1">
+          <a:effectRef idx="0">
             <a:schemeClr val="accent1"/>
           </a:effectRef>
           <a:fontRef idx="minor">
@@ -6466,6 +6472,7 @@
             </a:solidFill>
             <a:tailEnd type="triangle" w="med" len="med"/>
           </a:ln>
+          <a:effectLst/>
         </p:spPr>
         <p:style>
           <a:lnRef idx="2">
@@ -6474,7 +6481,7 @@
           <a:fillRef idx="0">
             <a:schemeClr val="accent1"/>
           </a:fillRef>
-          <a:effectRef idx="1">
+          <a:effectRef idx="0">
             <a:schemeClr val="accent1"/>
           </a:effectRef>
           <a:fontRef idx="minor">
@@ -6701,6 +6708,7 @@
             </a:solidFill>
             <a:tailEnd type="triangle" w="med" len="med"/>
           </a:ln>
+          <a:effectLst/>
         </p:spPr>
         <p:style>
           <a:lnRef idx="2">
@@ -6709,7 +6717,7 @@
           <a:fillRef idx="0">
             <a:schemeClr val="accent1"/>
           </a:fillRef>
-          <a:effectRef idx="1">
+          <a:effectRef idx="0">
             <a:schemeClr val="accent1"/>
           </a:effectRef>
           <a:fontRef idx="minor">
@@ -6936,6 +6944,7 @@
             </a:solidFill>
             <a:tailEnd type="triangle" w="med" len="med"/>
           </a:ln>
+          <a:effectLst/>
         </p:spPr>
         <p:style>
           <a:lnRef idx="2">
@@ -6944,7 +6953,7 @@
           <a:fillRef idx="0">
             <a:schemeClr val="accent1"/>
           </a:fillRef>
-          <a:effectRef idx="1">
+          <a:effectRef idx="0">
             <a:schemeClr val="accent1"/>
           </a:effectRef>
           <a:fontRef idx="minor">
@@ -7265,6 +7274,7 @@
             </a:solidFill>
             <a:tailEnd type="triangle" w="med" len="med"/>
           </a:ln>
+          <a:effectLst/>
         </p:spPr>
         <p:style>
           <a:lnRef idx="2">
@@ -7273,7 +7283,7 @@
           <a:fillRef idx="0">
             <a:schemeClr val="accent1"/>
           </a:fillRef>
-          <a:effectRef idx="1">
+          <a:effectRef idx="0">
             <a:schemeClr val="accent1"/>
           </a:effectRef>
           <a:fontRef idx="minor">
@@ -7654,6 +7664,7 @@
             </a:solidFill>
             <a:tailEnd type="triangle" w="med" len="med"/>
           </a:ln>
+          <a:effectLst/>
         </p:spPr>
         <p:style>
           <a:lnRef idx="2">
@@ -7662,7 +7673,7 @@
           <a:fillRef idx="0">
             <a:schemeClr val="accent1"/>
           </a:fillRef>
-          <a:effectRef idx="1">
+          <a:effectRef idx="0">
             <a:schemeClr val="accent1"/>
           </a:effectRef>
           <a:fontRef idx="minor">
@@ -7679,7 +7690,7 @@
         <p:spPr>
           <a:xfrm>
             <a:off x="10222992" y="3785615"/>
-            <a:ext cx="1856231" cy="2340864"/>
+            <a:ext cx="1746504" cy="2340864"/>
           </a:xfrm>
           <a:prstGeom prst="roundRect">
             <a:avLst>
@@ -7788,7 +7799,7 @@
         <p:spPr>
           <a:xfrm>
             <a:off x="10844784" y="3822191"/>
-            <a:ext cx="1216152" cy="548640"/>
+            <a:ext cx="1106424" cy="548640"/>
           </a:xfrm>
           <a:prstGeom prst="rect">
             <a:avLst/>
@@ -7867,7 +7878,7 @@
         <p:spPr>
           <a:xfrm>
             <a:off x="10625328" y="4425696"/>
-            <a:ext cx="1417320" cy="1005840"/>
+            <a:ext cx="1325880" cy="1005840"/>
           </a:xfrm>
           <a:prstGeom prst="rect">
             <a:avLst/>
@@ -7892,7 +7903,7 @@
                 </a:solidFill>
                 <a:latin typeface="Verdana"/>
               </a:rPr>
-              <a:t>exact binomial vs p0; Fisher's exact test for two arms; modal-vs-runner-up for argmax; floor n ≥ 10</a:t>
+              <a:t>exact binomial vs p0; Fisher's test, two arms; modal-vs-runner-up, argmax; floor n ≥ 10</a:t>
             </a:r>
           </a:p>
         </p:txBody>
@@ -7930,7 +7941,7 @@
         <p:spPr>
           <a:xfrm>
             <a:off x="10533888" y="5385816"/>
-            <a:ext cx="1463040" cy="256032"/>
+            <a:ext cx="1371600" cy="256032"/>
           </a:xfrm>
           <a:prstGeom prst="rect">
             <a:avLst/>
@@ -7993,7 +8004,7 @@
         <p:spPr>
           <a:xfrm>
             <a:off x="10533888" y="5623559"/>
-            <a:ext cx="1463040" cy="256032"/>
+            <a:ext cx="1371600" cy="256032"/>
           </a:xfrm>
           <a:prstGeom prst="rect">
             <a:avLst/>
@@ -8056,7 +8067,7 @@
         <p:spPr>
           <a:xfrm>
             <a:off x="10533888" y="5861303"/>
-            <a:ext cx="1463040" cy="256032"/>
+            <a:ext cx="1371600" cy="256032"/>
           </a:xfrm>
           <a:prstGeom prst="rect">
             <a:avLst/>
@@ -8094,8 +8105,8 @@
         </p:nvSpPr>
         <p:spPr>
           <a:xfrm>
-            <a:off x="109728" y="6309360"/>
-            <a:ext cx="11972239" cy="1051560"/>
+            <a:off x="91440" y="6309360"/>
+            <a:ext cx="12008815" cy="1051560"/>
           </a:xfrm>
           <a:prstGeom prst="roundRect">
             <a:avLst>
@@ -8211,7 +8222,7 @@
               </a:lnSpc>
             </a:pPr>
             <a:r>
-              <a:rPr sz="1800" b="1" i="0">
+              <a:rPr sz="1600" b="1" i="0">
                 <a:solidFill>
                   <a:srgbClr val="4F6B75"/>
                 </a:solidFill>
@@ -8270,7 +8281,7 @@
         <p:spPr>
           <a:xfrm>
             <a:off x="3657600" y="6400800"/>
-            <a:ext cx="2724912" cy="868680"/>
+            <a:ext cx="2706624" cy="868680"/>
           </a:xfrm>
           <a:prstGeom prst="roundRect">
             <a:avLst>
@@ -8394,8 +8405,8 @@
         </p:nvSpPr>
         <p:spPr>
           <a:xfrm>
-            <a:off x="6473952" y="6400800"/>
-            <a:ext cx="2724912" cy="868680"/>
+            <a:off x="6460236" y="6400800"/>
+            <a:ext cx="2706624" cy="868680"/>
           </a:xfrm>
           <a:prstGeom prst="roundRect">
             <a:avLst>
@@ -8448,7 +8459,7 @@
         </p:blipFill>
         <p:spPr>
           <a:xfrm>
-            <a:off x="6565392" y="6620256"/>
+            <a:off x="6551675" y="6620256"/>
             <a:ext cx="420624" cy="420624"/>
           </a:xfrm>
           <a:prstGeom prst="rect">
@@ -8464,7 +8475,7 @@
         </p:nvSpPr>
         <p:spPr>
           <a:xfrm>
-            <a:off x="7077456" y="6437376"/>
+            <a:off x="7063740" y="6437376"/>
             <a:ext cx="2103120" cy="804672"/>
           </a:xfrm>
           <a:prstGeom prst="rect">
@@ -8519,8 +8530,8 @@
         </p:nvSpPr>
         <p:spPr>
           <a:xfrm>
-            <a:off x="9290304" y="6400800"/>
-            <a:ext cx="2724912" cy="868680"/>
+            <a:off x="9262872" y="6400800"/>
+            <a:ext cx="2706624" cy="868680"/>
           </a:xfrm>
           <a:prstGeom prst="roundRect">
             <a:avLst>
@@ -8573,7 +8584,7 @@
         </p:blipFill>
         <p:spPr>
           <a:xfrm>
-            <a:off x="9381744" y="6620256"/>
+            <a:off x="9354311" y="6620256"/>
             <a:ext cx="420624" cy="420624"/>
           </a:xfrm>
           <a:prstGeom prst="rect">
@@ -8589,7 +8600,7 @@
         </p:nvSpPr>
         <p:spPr>
           <a:xfrm>
-            <a:off x="9893808" y="6437376"/>
+            <a:off x="9866376" y="6437376"/>
             <a:ext cx="2103120" cy="804672"/>
           </a:xfrm>
           <a:prstGeom prst="rect">

</xml_diff>

<commit_message>
Double-blind wording: clinical timelines (cited) instead of annotated data; positioning table split into benchmarks and systems; new title from Overleaf
Abstract, introduction, related work, task, corpus, method and the Figure 1
slide no longer describe the data as annotated or expert-annotated; MedTempo
is cited (CRAFT) and described as clinical timelines. EHRSQL (benchmark) and
EHRAgent (system) get separate rows in the positioning table, which is grouped
into benchmarks and systems.

Co-Authored-By: Claude Opus 5.5 <noreply@anthropic.com>
</commit_message>
<xml_diff>
--- a/docs/draft/Figures/STRATA_framework_editable.pptx
+++ b/docs/draft/Figures/STRATA_framework_editable.pptx
@@ -3359,7 +3359,7 @@
                 </a:solidFill>
                 <a:latin typeface="Verdana"/>
               </a:rPr>
-              <a:t>Annotated timelines</a:t>
+              <a:t>Clinical timelines</a:t>
             </a:r>
             <a:r>
               <a:rPr sz="900" b="0" i="0">
@@ -3455,7 +3455,7 @@
                 </a:solidFill>
                 <a:latin typeface="Verdana"/>
               </a:rPr>
-              <a:t>3,166 VAERS reports, three vaccines, expert-annotated as a leveled order of events</a:t>
+              <a:t>3,166 VAERS reports, three vaccines, each a leveled order of events</a:t>
             </a:r>
           </a:p>
         </p:txBody>
@@ -5153,7 +5153,7 @@
                 </a:solidFill>
                 <a:latin typeface="Verdana"/>
               </a:rPr>
-              <a:t>Gold annotations</a:t>
+              <a:t>Gold at every stage</a:t>
             </a:r>
           </a:p>
         </p:txBody>
@@ -6010,7 +6010,7 @@
                 </a:solidFill>
                 <a:latin typeface="Verdana"/>
               </a:rPr>
-              <a:t>annotation DB: report, vaccine, term, first-mention stage</a:t>
+              <a:t>timeline DB: report, vaccine, term, first-mention stage</a:t>
             </a:r>
           </a:p>
         </p:txBody>

</xml_diff>

<commit_message>
VERITAS removed from the results and discussion (kept in related work and the positioning table; results in ~/veritas_baseline); main table one font size larger; Figure 1 flatter (evaluation row folded under the pipeline stages)
Co-Authored-By: Claude Opus 5.5 <noreply@anthropic.com>
</commit_message>
<xml_diff>
--- a/docs/draft/Figures/STRATA_framework_editable.pptx
+++ b/docs/draft/Figures/STRATA_framework_editable.pptx
@@ -7,7 +7,7 @@
   <p:sldIdLst>
     <p:sldId id="256" r:id="rId7"/>
   </p:sldIdLst>
-  <p:sldSz cx="12191695" cy="7452360" type="screen4x3"/>
+  <p:sldSz cx="12191695" cy="6364224" type="screen4x3"/>
   <p:notesSz cx="6858000" cy="9144000"/>
   <p:defaultTextStyle>
     <a:defPPr>
@@ -3097,7 +3097,7 @@
         <p:spPr>
           <a:xfrm>
             <a:off x="91440" y="91440"/>
-            <a:ext cx="12008815" cy="3017520"/>
+            <a:ext cx="12008815" cy="2743200"/>
           </a:xfrm>
           <a:prstGeom prst="roundRect">
             <a:avLst>
@@ -3232,8 +3232,8 @@
         </p:nvSpPr>
         <p:spPr>
           <a:xfrm>
-            <a:off x="219456" y="676656"/>
-            <a:ext cx="2834640" cy="2340864"/>
+            <a:off x="219456" y="621792"/>
+            <a:ext cx="2834640" cy="2103120"/>
           </a:xfrm>
           <a:prstGeom prst="roundRect">
             <a:avLst>
@@ -3278,7 +3278,7 @@
         </p:nvSpPr>
         <p:spPr>
           <a:xfrm>
-            <a:off x="292608" y="749808"/>
+            <a:off x="292608" y="694944"/>
             <a:ext cx="457200" cy="237744"/>
           </a:xfrm>
           <a:prstGeom prst="roundRect">
@@ -3333,7 +3333,7 @@
         </p:nvSpPr>
         <p:spPr>
           <a:xfrm>
-            <a:off x="786384" y="713232"/>
+            <a:off x="786384" y="658368"/>
             <a:ext cx="2212848" cy="310896"/>
           </a:xfrm>
           <a:prstGeom prst="rect">
@@ -3389,7 +3389,7 @@
         </p:blipFill>
         <p:spPr>
           <a:xfrm>
-            <a:off x="310896" y="1115568"/>
+            <a:off x="310896" y="1042416"/>
             <a:ext cx="420624" cy="420624"/>
           </a:xfrm>
           <a:prstGeom prst="rect">
@@ -3413,7 +3413,7 @@
         </p:blipFill>
         <p:spPr>
           <a:xfrm>
-            <a:off x="804672" y="1115568"/>
+            <a:off x="804672" y="1042416"/>
             <a:ext cx="420624" cy="420624"/>
           </a:xfrm>
           <a:prstGeom prst="rect">
@@ -3429,8 +3429,8 @@
         </p:nvSpPr>
         <p:spPr>
           <a:xfrm>
-            <a:off x="274320" y="1609344"/>
-            <a:ext cx="1280160" cy="1371600"/>
+            <a:off x="274320" y="1517904"/>
+            <a:ext cx="1280160" cy="1097280"/>
           </a:xfrm>
           <a:prstGeom prst="rect">
             <a:avLst/>
@@ -3468,8 +3468,8 @@
         </p:nvSpPr>
         <p:spPr>
           <a:xfrm>
-            <a:off x="1572768" y="1078992"/>
-            <a:ext cx="1408176" cy="1847088"/>
+            <a:off x="1572768" y="1005840"/>
+            <a:ext cx="1408176" cy="1645920"/>
           </a:xfrm>
           <a:prstGeom prst="roundRect">
             <a:avLst>
@@ -3512,7 +3512,7 @@
         </p:nvSpPr>
         <p:spPr>
           <a:xfrm>
-            <a:off x="1609344" y="1106424"/>
+            <a:off x="1609344" y="1033272"/>
             <a:ext cx="1353312" cy="457200"/>
           </a:xfrm>
           <a:prstGeom prst="rect">
@@ -3567,7 +3567,7 @@
         </p:nvCxnSpPr>
         <p:spPr>
           <a:xfrm>
-            <a:off x="1700784" y="1728216"/>
+            <a:off x="1700784" y="1609344"/>
             <a:ext cx="1152144" cy="0"/>
           </a:xfrm>
           <a:prstGeom prst="line">
@@ -3603,7 +3603,7 @@
         </p:nvSpPr>
         <p:spPr>
           <a:xfrm>
-            <a:off x="1709928" y="1664207"/>
+            <a:off x="1709928" y="1545336"/>
             <a:ext cx="128016" cy="128016"/>
           </a:xfrm>
           <a:prstGeom prst="ellipse">
@@ -3656,7 +3656,7 @@
         </p:nvSpPr>
         <p:spPr>
           <a:xfrm>
-            <a:off x="1408176" y="1801368"/>
+            <a:off x="1408176" y="1682496"/>
             <a:ext cx="731520" cy="201168"/>
           </a:xfrm>
           <a:prstGeom prst="rect">
@@ -3695,7 +3695,7 @@
         </p:nvSpPr>
         <p:spPr>
           <a:xfrm>
-            <a:off x="2212848" y="1664207"/>
+            <a:off x="2212848" y="1545336"/>
             <a:ext cx="128016" cy="128016"/>
           </a:xfrm>
           <a:prstGeom prst="ellipse">
@@ -3748,7 +3748,7 @@
         </p:nvSpPr>
         <p:spPr>
           <a:xfrm>
-            <a:off x="1911096" y="1801368"/>
+            <a:off x="1911096" y="1682496"/>
             <a:ext cx="731520" cy="201168"/>
           </a:xfrm>
           <a:prstGeom prst="rect">
@@ -3787,7 +3787,7 @@
         </p:nvSpPr>
         <p:spPr>
           <a:xfrm>
-            <a:off x="2715768" y="1664207"/>
+            <a:off x="2715768" y="1545336"/>
             <a:ext cx="128016" cy="128016"/>
           </a:xfrm>
           <a:prstGeom prst="ellipse">
@@ -3840,7 +3840,7 @@
         </p:nvSpPr>
         <p:spPr>
           <a:xfrm>
-            <a:off x="2414016" y="1801368"/>
+            <a:off x="2414016" y="1682496"/>
             <a:ext cx="731520" cy="201168"/>
           </a:xfrm>
           <a:prstGeom prst="rect">
@@ -3879,8 +3879,8 @@
         </p:nvSpPr>
         <p:spPr>
           <a:xfrm>
-            <a:off x="1609344" y="2048256"/>
-            <a:ext cx="1353312" cy="868680"/>
+            <a:off x="1609344" y="1901952"/>
+            <a:ext cx="1353312" cy="731520"/>
           </a:xfrm>
           <a:prstGeom prst="rect">
             <a:avLst/>
@@ -3918,7 +3918,7 @@
         </p:nvCxnSpPr>
         <p:spPr>
           <a:xfrm>
-            <a:off x="3090672" y="1773936"/>
+            <a:off x="3090672" y="1627632"/>
             <a:ext cx="219456" cy="0"/>
           </a:xfrm>
           <a:prstGeom prst="line">
@@ -3955,8 +3955,8 @@
         </p:nvSpPr>
         <p:spPr>
           <a:xfrm>
-            <a:off x="3346704" y="676656"/>
-            <a:ext cx="2834640" cy="2340864"/>
+            <a:off x="3346704" y="621792"/>
+            <a:ext cx="2834640" cy="2103120"/>
           </a:xfrm>
           <a:prstGeom prst="roundRect">
             <a:avLst>
@@ -4001,7 +4001,7 @@
         </p:nvSpPr>
         <p:spPr>
           <a:xfrm>
-            <a:off x="3419856" y="749808"/>
+            <a:off x="3419856" y="694944"/>
             <a:ext cx="457200" cy="237744"/>
           </a:xfrm>
           <a:prstGeom prst="roundRect">
@@ -4056,7 +4056,7 @@
         </p:nvSpPr>
         <p:spPr>
           <a:xfrm>
-            <a:off x="3913632" y="713232"/>
+            <a:off x="3913632" y="658368"/>
             <a:ext cx="2212848" cy="310896"/>
           </a:xfrm>
           <a:prstGeom prst="rect">
@@ -4096,8 +4096,8 @@
           <p:nvPr/>
         </p:nvGraphicFramePr>
         <p:xfrm>
-          <a:off x="3419856" y="1078992"/>
-          <a:ext cx="2688336" cy="1828799"/>
+          <a:off x="3419856" y="1005840"/>
+          <a:ext cx="2688336" cy="1627626"/>
         </p:xfrm>
         <a:graphic>
           <a:graphicData uri="http://schemas.openxmlformats.org/drawingml/2006/table">
@@ -4109,7 +4109,7 @@
                 <a:gridCol w="896112"/>
                 <a:gridCol w="1792224"/>
               </a:tblGrid>
-              <a:tr h="261257">
+              <a:tr h="232518">
                 <a:tc>
                   <a:txBody>
                     <a:bodyPr/>
@@ -4155,7 +4155,7 @@
                   </a:tcPr>
                 </a:tc>
               </a:tr>
-              <a:tr h="261257">
+              <a:tr h="232518">
                 <a:tc>
                   <a:txBody>
                     <a:bodyPr/>
@@ -4201,7 +4201,7 @@
                   </a:tcPr>
                 </a:tc>
               </a:tr>
-              <a:tr h="261257">
+              <a:tr h="232518">
                 <a:tc>
                   <a:txBody>
                     <a:bodyPr/>
@@ -4247,7 +4247,7 @@
                   </a:tcPr>
                 </a:tc>
               </a:tr>
-              <a:tr h="261257">
+              <a:tr h="232518">
                 <a:tc>
                   <a:txBody>
                     <a:bodyPr/>
@@ -4293,7 +4293,7 @@
                   </a:tcPr>
                 </a:tc>
               </a:tr>
-              <a:tr h="261257">
+              <a:tr h="232518">
                 <a:tc>
                   <a:txBody>
                     <a:bodyPr/>
@@ -4339,7 +4339,7 @@
                   </a:tcPr>
                 </a:tc>
               </a:tr>
-              <a:tr h="261257">
+              <a:tr h="232518">
                 <a:tc>
                   <a:txBody>
                     <a:bodyPr/>
@@ -4385,7 +4385,7 @@
                   </a:tcPr>
                 </a:tc>
               </a:tr>
-              <a:tr h="261257">
+              <a:tr h="232518">
                 <a:tc>
                   <a:txBody>
                     <a:bodyPr/>
@@ -4443,7 +4443,7 @@
         </p:nvCxnSpPr>
         <p:spPr>
           <a:xfrm>
-            <a:off x="6217920" y="1773936"/>
+            <a:off x="6217920" y="1627632"/>
             <a:ext cx="219456" cy="0"/>
           </a:xfrm>
           <a:prstGeom prst="line">
@@ -4480,8 +4480,8 @@
         </p:nvSpPr>
         <p:spPr>
           <a:xfrm>
-            <a:off x="6473952" y="676656"/>
-            <a:ext cx="2743200" cy="2340864"/>
+            <a:off x="6473952" y="621792"/>
+            <a:ext cx="2743200" cy="2103120"/>
           </a:xfrm>
           <a:prstGeom prst="roundRect">
             <a:avLst>
@@ -4526,7 +4526,7 @@
         </p:nvSpPr>
         <p:spPr>
           <a:xfrm>
-            <a:off x="6547104" y="749808"/>
+            <a:off x="6547104" y="694944"/>
             <a:ext cx="457200" cy="237744"/>
           </a:xfrm>
           <a:prstGeom prst="roundRect">
@@ -4581,7 +4581,7 @@
         </p:nvSpPr>
         <p:spPr>
           <a:xfrm>
-            <a:off x="7040880" y="713232"/>
+            <a:off x="7040880" y="658368"/>
             <a:ext cx="2121408" cy="310896"/>
           </a:xfrm>
           <a:prstGeom prst="rect">
@@ -4620,8 +4620,8 @@
         </p:nvSpPr>
         <p:spPr>
           <a:xfrm>
-            <a:off x="6547104" y="1078992"/>
-            <a:ext cx="2596896" cy="548640"/>
+            <a:off x="6547104" y="1005840"/>
+            <a:ext cx="2596896" cy="493776"/>
           </a:xfrm>
           <a:prstGeom prst="roundRect">
             <a:avLst>
@@ -4672,7 +4672,7 @@
         </p:blipFill>
         <p:spPr>
           <a:xfrm>
-            <a:off x="6601968" y="1188719"/>
+            <a:off x="6601968" y="1088136"/>
             <a:ext cx="329184" cy="329184"/>
           </a:xfrm>
           <a:prstGeom prst="rect">
@@ -4688,8 +4688,8 @@
         </p:nvSpPr>
         <p:spPr>
           <a:xfrm>
-            <a:off x="6967728" y="1097280"/>
-            <a:ext cx="2157984" cy="512063"/>
+            <a:off x="6967728" y="1024128"/>
+            <a:ext cx="2157984" cy="457200"/>
           </a:xfrm>
           <a:prstGeom prst="rect">
             <a:avLst/>
@@ -4743,8 +4743,8 @@
         </p:nvSpPr>
         <p:spPr>
           <a:xfrm>
-            <a:off x="6547104" y="1682496"/>
-            <a:ext cx="2596896" cy="621792"/>
+            <a:off x="6547104" y="1554480"/>
+            <a:ext cx="2596896" cy="603504"/>
           </a:xfrm>
           <a:prstGeom prst="roundRect">
             <a:avLst>
@@ -4795,7 +4795,7 @@
         </p:blipFill>
         <p:spPr>
           <a:xfrm>
-            <a:off x="6601968" y="1828800"/>
+            <a:off x="6601968" y="1691640"/>
             <a:ext cx="329184" cy="329184"/>
           </a:xfrm>
           <a:prstGeom prst="rect">
@@ -4811,8 +4811,8 @@
         </p:nvSpPr>
         <p:spPr>
           <a:xfrm>
-            <a:off x="6967728" y="1700784"/>
-            <a:ext cx="2157984" cy="585216"/>
+            <a:off x="6967728" y="1572768"/>
+            <a:ext cx="2157984" cy="566928"/>
           </a:xfrm>
           <a:prstGeom prst="rect">
             <a:avLst/>
@@ -4866,8 +4866,8 @@
         </p:nvSpPr>
         <p:spPr>
           <a:xfrm>
-            <a:off x="6547104" y="2359152"/>
-            <a:ext cx="2596896" cy="566928"/>
+            <a:off x="6547104" y="2212848"/>
+            <a:ext cx="2596896" cy="457200"/>
           </a:xfrm>
           <a:prstGeom prst="roundRect">
             <a:avLst>
@@ -4918,7 +4918,7 @@
         </p:blipFill>
         <p:spPr>
           <a:xfrm>
-            <a:off x="6601968" y="2478024"/>
+            <a:off x="6601968" y="2276856"/>
             <a:ext cx="329184" cy="329184"/>
           </a:xfrm>
           <a:prstGeom prst="rect">
@@ -4934,8 +4934,8 @@
         </p:nvSpPr>
         <p:spPr>
           <a:xfrm>
-            <a:off x="6967728" y="2377440"/>
-            <a:ext cx="2157984" cy="530352"/>
+            <a:off x="6967728" y="2231136"/>
+            <a:ext cx="2157984" cy="420624"/>
           </a:xfrm>
           <a:prstGeom prst="rect">
             <a:avLst/>
@@ -4989,7 +4989,7 @@
         </p:nvCxnSpPr>
         <p:spPr>
           <a:xfrm>
-            <a:off x="9253728" y="1773936"/>
+            <a:off x="9253728" y="1627632"/>
             <a:ext cx="219456" cy="0"/>
           </a:xfrm>
           <a:prstGeom prst="line">
@@ -5026,8 +5026,8 @@
         </p:nvSpPr>
         <p:spPr>
           <a:xfrm>
-            <a:off x="9509760" y="676656"/>
-            <a:ext cx="2459736" cy="2340864"/>
+            <a:off x="9509760" y="621792"/>
+            <a:ext cx="2459736" cy="2103120"/>
           </a:xfrm>
           <a:prstGeom prst="roundRect">
             <a:avLst>
@@ -5072,7 +5072,7 @@
         </p:nvSpPr>
         <p:spPr>
           <a:xfrm>
-            <a:off x="9582912" y="749808"/>
+            <a:off x="9582912" y="694944"/>
             <a:ext cx="457200" cy="237744"/>
           </a:xfrm>
           <a:prstGeom prst="roundRect">
@@ -5127,7 +5127,7 @@
         </p:nvSpPr>
         <p:spPr>
           <a:xfrm>
-            <a:off x="10076688" y="713232"/>
+            <a:off x="10076688" y="658368"/>
             <a:ext cx="1837943" cy="310896"/>
           </a:xfrm>
           <a:prstGeom prst="rect">
@@ -5166,8 +5166,8 @@
         </p:nvSpPr>
         <p:spPr>
           <a:xfrm>
-            <a:off x="9582912" y="1078992"/>
-            <a:ext cx="2313432" cy="548640"/>
+            <a:off x="9582912" y="1005840"/>
+            <a:ext cx="2313432" cy="566928"/>
           </a:xfrm>
           <a:prstGeom prst="roundRect">
             <a:avLst>
@@ -5218,7 +5218,7 @@
         </p:blipFill>
         <p:spPr>
           <a:xfrm>
-            <a:off x="9637776" y="1197863"/>
+            <a:off x="9637776" y="1133856"/>
             <a:ext cx="310896" cy="310896"/>
           </a:xfrm>
           <a:prstGeom prst="rect">
@@ -5234,8 +5234,8 @@
         </p:nvSpPr>
         <p:spPr>
           <a:xfrm>
-            <a:off x="9985248" y="1097280"/>
-            <a:ext cx="1901952" cy="512063"/>
+            <a:off x="9985248" y="1024128"/>
+            <a:ext cx="1901952" cy="530352"/>
           </a:xfrm>
           <a:prstGeom prst="rect">
             <a:avLst/>
@@ -5289,7 +5289,7 @@
         </p:nvSpPr>
         <p:spPr>
           <a:xfrm>
-            <a:off x="9582912" y="1682496"/>
+            <a:off x="9582912" y="1627632"/>
             <a:ext cx="2313432" cy="475488"/>
           </a:xfrm>
           <a:prstGeom prst="roundRect">
@@ -5341,7 +5341,7 @@
         </p:blipFill>
         <p:spPr>
           <a:xfrm>
-            <a:off x="9637776" y="1764792"/>
+            <a:off x="9637776" y="1709928"/>
             <a:ext cx="310896" cy="310896"/>
           </a:xfrm>
           <a:prstGeom prst="rect">
@@ -5357,7 +5357,7 @@
         </p:nvSpPr>
         <p:spPr>
           <a:xfrm>
-            <a:off x="9985248" y="1700784"/>
+            <a:off x="9985248" y="1645920"/>
             <a:ext cx="1901952" cy="438912"/>
           </a:xfrm>
           <a:prstGeom prst="rect">
@@ -5412,8 +5412,8 @@
         </p:nvSpPr>
         <p:spPr>
           <a:xfrm>
-            <a:off x="9582912" y="2212848"/>
-            <a:ext cx="2313432" cy="548640"/>
+            <a:off x="9582912" y="2157984"/>
+            <a:ext cx="2313432" cy="512064"/>
           </a:xfrm>
           <a:prstGeom prst="roundRect">
             <a:avLst>
@@ -5464,7 +5464,7 @@
         </p:blipFill>
         <p:spPr>
           <a:xfrm>
-            <a:off x="9637776" y="2331720"/>
+            <a:off x="9637776" y="2258568"/>
             <a:ext cx="310896" cy="310896"/>
           </a:xfrm>
           <a:prstGeom prst="rect">
@@ -5480,8 +5480,8 @@
         </p:nvSpPr>
         <p:spPr>
           <a:xfrm>
-            <a:off x="9985248" y="2231136"/>
-            <a:ext cx="1901952" cy="512063"/>
+            <a:off x="9985248" y="2176272"/>
+            <a:ext cx="1901952" cy="475488"/>
           </a:xfrm>
           <a:prstGeom prst="rect">
             <a:avLst/>
@@ -5522,60 +5522,21 @@
                 </a:solidFill>
                 <a:latin typeface="Verdana"/>
               </a:rPr>
-              <a:t>p on both tails, Wilson CI, Cohen's h; supported / refuted / insufficient</a:t>
-            </a:r>
-          </a:p>
-        </p:txBody>
-      </p:sp>
-      <p:sp>
-        <p:nvSpPr>
-          <p:cNvPr id="52" name="TextBox 51"/>
-          <p:cNvSpPr txBox="1"/>
-          <p:nvPr/>
-        </p:nvSpPr>
-        <p:spPr>
-          <a:xfrm>
-            <a:off x="9582912" y="2779776"/>
-            <a:ext cx="2313432" cy="219456"/>
-          </a:xfrm>
-          <a:prstGeom prst="rect">
-            <a:avLst/>
-          </a:prstGeom>
-          <a:noFill/>
-        </p:spPr>
-        <p:txBody>
-          <a:bodyPr wrap="square" lIns="27432" rIns="27432" tIns="9144" bIns="9144" anchor="t">
-            <a:spAutoFit/>
-          </a:bodyPr>
-          <a:lstStyle/>
-          <a:p>
-            <a:pPr algn="l">
-              <a:lnSpc>
-                <a:spcPct val="100000"/>
-              </a:lnSpc>
-            </a:pPr>
-            <a:r>
-              <a:rPr sz="750" b="0" i="1">
-                <a:solidFill>
-                  <a:srgbClr val="5F5F5F"/>
-                </a:solidFill>
-                <a:latin typeface="Verdana"/>
-              </a:rPr>
-              <a:t>validated by invariants and an oracle; permutation-screened</a:t>
-            </a:r>
-          </a:p>
-        </p:txBody>
-      </p:sp>
-      <p:sp>
-        <p:nvSpPr>
-          <p:cNvPr id="53" name="Rounded Rectangle 52"/>
+              <a:t>p on both tails, Wilson CI, Cohen's h; three-way verdict</a:t>
+            </a:r>
+          </a:p>
+        </p:txBody>
+      </p:sp>
+      <p:sp>
+        <p:nvSpPr>
+          <p:cNvPr id="52" name="Rounded Rectangle 51"/>
           <p:cNvSpPr/>
           <p:nvPr/>
         </p:nvSpPr>
         <p:spPr>
           <a:xfrm>
-            <a:off x="91440" y="3200400"/>
-            <a:ext cx="12008815" cy="3017520"/>
+            <a:off x="91440" y="2907792"/>
+            <a:ext cx="12008815" cy="3438143"/>
           </a:xfrm>
           <a:prstGeom prst="roundRect">
             <a:avLst>
@@ -5612,13 +5573,13 @@
       </p:sp>
       <p:sp>
         <p:nvSpPr>
-          <p:cNvPr id="54" name="Oval 53"/>
+          <p:cNvPr id="53" name="Oval 52"/>
           <p:cNvSpPr/>
           <p:nvPr/>
         </p:nvSpPr>
         <p:spPr>
           <a:xfrm>
-            <a:off x="237744" y="3264408"/>
+            <a:off x="237744" y="2971800"/>
             <a:ext cx="420624" cy="420624"/>
           </a:xfrm>
           <a:prstGeom prst="ellipse">
@@ -5665,13 +5626,13 @@
       </p:sp>
       <p:sp>
         <p:nvSpPr>
-          <p:cNvPr id="55" name="TextBox 54"/>
+          <p:cNvPr id="54" name="TextBox 53"/>
           <p:cNvSpPr txBox="1"/>
           <p:nvPr/>
         </p:nvSpPr>
         <p:spPr>
           <a:xfrm>
-            <a:off x="731520" y="3236976"/>
+            <a:off x="731520" y="2944368"/>
             <a:ext cx="6400800" cy="475488"/>
           </a:xfrm>
           <a:prstGeom prst="rect">
@@ -5704,14 +5665,14 @@
       </p:sp>
       <p:sp>
         <p:nvSpPr>
-          <p:cNvPr id="56" name="Rounded Rectangle 55"/>
+          <p:cNvPr id="55" name="Rounded Rectangle 54"/>
           <p:cNvSpPr/>
           <p:nvPr/>
         </p:nvSpPr>
         <p:spPr>
           <a:xfrm>
-            <a:off x="219456" y="3785615"/>
-            <a:ext cx="2212848" cy="2340864"/>
+            <a:off x="219456" y="3438144"/>
+            <a:ext cx="2212848" cy="2103120"/>
           </a:xfrm>
           <a:prstGeom prst="roundRect">
             <a:avLst>
@@ -5750,13 +5711,13 @@
       </p:sp>
       <p:sp>
         <p:nvSpPr>
-          <p:cNvPr id="57" name="TextBox 56"/>
+          <p:cNvPr id="56" name="TextBox 55"/>
           <p:cNvSpPr txBox="1"/>
           <p:nvPr/>
         </p:nvSpPr>
         <p:spPr>
           <a:xfrm>
-            <a:off x="274320" y="3831335"/>
+            <a:off x="274320" y="3483864"/>
             <a:ext cx="2103120" cy="274320"/>
           </a:xfrm>
           <a:prstGeom prst="rect">
@@ -5789,7 +5750,7 @@
       </p:sp>
       <p:pic>
         <p:nvPicPr>
-          <p:cNvPr id="58" name="Picture 57" descr="file-text_4F6B75.png"/>
+          <p:cNvPr id="57" name="Picture 56" descr="file-text_4F6B75.png"/>
           <p:cNvPicPr>
             <a:picLocks noChangeAspect="1"/>
           </p:cNvPicPr>
@@ -5803,7 +5764,7 @@
         </p:blipFill>
         <p:spPr>
           <a:xfrm>
-            <a:off x="292608" y="4169663"/>
+            <a:off x="292608" y="3803904"/>
             <a:ext cx="329184" cy="329184"/>
           </a:xfrm>
           <a:prstGeom prst="rect">
@@ -5813,13 +5774,13 @@
       </p:pic>
       <p:sp>
         <p:nvSpPr>
-          <p:cNvPr id="59" name="TextBox 58"/>
+          <p:cNvPr id="58" name="TextBox 57"/>
           <p:cNvSpPr txBox="1"/>
           <p:nvPr/>
         </p:nvSpPr>
         <p:spPr>
           <a:xfrm>
-            <a:off x="676656" y="4133087"/>
+            <a:off x="676656" y="3767328"/>
             <a:ext cx="1737360" cy="457200"/>
           </a:xfrm>
           <a:prstGeom prst="rect">
@@ -5852,13 +5813,13 @@
       </p:sp>
       <p:sp>
         <p:nvSpPr>
-          <p:cNvPr id="60" name="TextBox 59"/>
+          <p:cNvPr id="59" name="TextBox 58"/>
           <p:cNvSpPr txBox="1"/>
           <p:nvPr/>
         </p:nvSpPr>
         <p:spPr>
           <a:xfrm>
-            <a:off x="274320" y="4700016"/>
+            <a:off x="274320" y="4261104"/>
             <a:ext cx="2103120" cy="274320"/>
           </a:xfrm>
           <a:prstGeom prst="rect">
@@ -5891,7 +5852,7 @@
       </p:sp>
       <p:pic>
         <p:nvPicPr>
-          <p:cNvPr id="61" name="Picture 60" descr="list-checks_4F6B75.png"/>
+          <p:cNvPr id="60" name="Picture 59" descr="list-checks_4F6B75.png"/>
           <p:cNvPicPr>
             <a:picLocks noChangeAspect="1"/>
           </p:cNvPicPr>
@@ -5905,7 +5866,7 @@
         </p:blipFill>
         <p:spPr>
           <a:xfrm>
-            <a:off x="292608" y="5065775"/>
+            <a:off x="292608" y="4590288"/>
             <a:ext cx="329184" cy="329184"/>
           </a:xfrm>
           <a:prstGeom prst="rect">
@@ -5915,13 +5876,13 @@
       </p:pic>
       <p:sp>
         <p:nvSpPr>
-          <p:cNvPr id="62" name="TextBox 61"/>
+          <p:cNvPr id="61" name="TextBox 60"/>
           <p:cNvSpPr txBox="1"/>
           <p:nvPr/>
         </p:nvSpPr>
         <p:spPr>
           <a:xfrm>
-            <a:off x="676656" y="5010912"/>
+            <a:off x="676656" y="4535424"/>
             <a:ext cx="1737360" cy="548640"/>
           </a:xfrm>
           <a:prstGeom prst="rect">
@@ -5954,7 +5915,7 @@
       </p:sp>
       <p:pic>
         <p:nvPicPr>
-          <p:cNvPr id="63" name="Picture 62" descr="database_4F6B75.png"/>
+          <p:cNvPr id="62" name="Picture 61" descr="database_4F6B75.png"/>
           <p:cNvPicPr>
             <a:picLocks noChangeAspect="1"/>
           </p:cNvPicPr>
@@ -5968,7 +5929,7 @@
         </p:blipFill>
         <p:spPr>
           <a:xfrm>
-            <a:off x="292608" y="5632704"/>
+            <a:off x="292608" y="5102352"/>
             <a:ext cx="329184" cy="329184"/>
           </a:xfrm>
           <a:prstGeom prst="rect">
@@ -5978,14 +5939,14 @@
       </p:pic>
       <p:sp>
         <p:nvSpPr>
-          <p:cNvPr id="64" name="TextBox 63"/>
+          <p:cNvPr id="63" name="TextBox 62"/>
           <p:cNvSpPr txBox="1"/>
           <p:nvPr/>
         </p:nvSpPr>
         <p:spPr>
           <a:xfrm>
-            <a:off x="676656" y="5596127"/>
-            <a:ext cx="1737360" cy="512064"/>
+            <a:off x="676656" y="5047488"/>
+            <a:ext cx="1737360" cy="475488"/>
           </a:xfrm>
           <a:prstGeom prst="rect">
             <a:avLst/>
@@ -6017,13 +5978,13 @@
       </p:sp>
       <p:cxnSp>
         <p:nvCxnSpPr>
-          <p:cNvPr id="65" name="Connector 64"/>
+          <p:cNvPr id="64" name="Connector 63"/>
           <p:cNvCxnSpPr/>
           <p:nvPr/>
         </p:nvCxnSpPr>
         <p:spPr>
           <a:xfrm>
-            <a:off x="2450592" y="4334255"/>
+            <a:off x="2450592" y="3941064"/>
             <a:ext cx="219456" cy="0"/>
           </a:xfrm>
           <a:prstGeom prst="line">
@@ -6054,13 +6015,13 @@
       </p:cxnSp>
       <p:cxnSp>
         <p:nvCxnSpPr>
-          <p:cNvPr id="66" name="Connector 65"/>
+          <p:cNvPr id="65" name="Connector 64"/>
           <p:cNvCxnSpPr/>
           <p:nvPr/>
         </p:nvCxnSpPr>
         <p:spPr>
           <a:xfrm>
-            <a:off x="2450592" y="5248656"/>
+            <a:off x="2450592" y="4764024"/>
             <a:ext cx="219456" cy="0"/>
           </a:xfrm>
           <a:prstGeom prst="line">
@@ -6091,14 +6052,14 @@
       </p:cxnSp>
       <p:sp>
         <p:nvSpPr>
-          <p:cNvPr id="67" name="Rounded Rectangle 66"/>
+          <p:cNvPr id="66" name="Rounded Rectangle 65"/>
           <p:cNvSpPr/>
           <p:nvPr/>
         </p:nvSpPr>
         <p:spPr>
           <a:xfrm>
-            <a:off x="2706624" y="3785615"/>
-            <a:ext cx="4443984" cy="2340864"/>
+            <a:off x="2706624" y="3438144"/>
+            <a:ext cx="4443984" cy="2103120"/>
           </a:xfrm>
           <a:prstGeom prst="roundRect">
             <a:avLst>
@@ -6135,13 +6096,13 @@
       </p:sp>
       <p:sp>
         <p:nvSpPr>
-          <p:cNvPr id="68" name="Oval 67"/>
+          <p:cNvPr id="67" name="Oval 66"/>
           <p:cNvSpPr/>
           <p:nvPr/>
         </p:nvSpPr>
         <p:spPr>
           <a:xfrm>
-            <a:off x="2779776" y="3849624"/>
+            <a:off x="2779776" y="3502152"/>
             <a:ext cx="493776" cy="493776"/>
           </a:xfrm>
           <a:prstGeom prst="ellipse">
@@ -6200,13 +6161,13 @@
       </p:sp>
       <p:sp>
         <p:nvSpPr>
-          <p:cNvPr id="69" name="TextBox 68"/>
+          <p:cNvPr id="68" name="TextBox 67"/>
           <p:cNvSpPr txBox="1"/>
           <p:nvPr/>
         </p:nvSpPr>
         <p:spPr>
           <a:xfrm>
-            <a:off x="3328416" y="3822191"/>
+            <a:off x="3328416" y="3474720"/>
             <a:ext cx="3794760" cy="548640"/>
           </a:xfrm>
           <a:prstGeom prst="rect">
@@ -6255,14 +6216,14 @@
       </p:sp>
       <p:sp>
         <p:nvSpPr>
-          <p:cNvPr id="70" name="Rounded Rectangle 69"/>
+          <p:cNvPr id="69" name="Rounded Rectangle 68"/>
           <p:cNvSpPr/>
           <p:nvPr/>
         </p:nvSpPr>
         <p:spPr>
           <a:xfrm>
-            <a:off x="2779776" y="4425696"/>
-            <a:ext cx="1033271" cy="1188720"/>
+            <a:off x="2779776" y="4059936"/>
+            <a:ext cx="1033271" cy="1005840"/>
           </a:xfrm>
           <a:prstGeom prst="roundRect">
             <a:avLst>
@@ -6299,13 +6260,13 @@
       </p:sp>
       <p:sp>
         <p:nvSpPr>
-          <p:cNvPr id="71" name="Oval 70"/>
+          <p:cNvPr id="70" name="Oval 69"/>
           <p:cNvSpPr/>
           <p:nvPr/>
         </p:nvSpPr>
         <p:spPr>
           <a:xfrm>
-            <a:off x="2834640" y="4480559"/>
+            <a:off x="2834640" y="4114800"/>
             <a:ext cx="237744" cy="237744"/>
           </a:xfrm>
           <a:prstGeom prst="ellipse">
@@ -6352,13 +6313,13 @@
       </p:sp>
       <p:sp>
         <p:nvSpPr>
-          <p:cNvPr id="72" name="TextBox 71"/>
+          <p:cNvPr id="71" name="TextBox 70"/>
           <p:cNvSpPr txBox="1"/>
           <p:nvPr/>
         </p:nvSpPr>
         <p:spPr>
           <a:xfrm>
-            <a:off x="3090672" y="4443983"/>
+            <a:off x="3090672" y="4078224"/>
             <a:ext cx="713232" cy="457200"/>
           </a:xfrm>
           <a:prstGeom prst="rect">
@@ -6391,7 +6352,7 @@
       </p:sp>
       <p:pic>
         <p:nvPicPr>
-          <p:cNvPr id="73" name="Picture 72" descr="file-search_4F6B75.png"/>
+          <p:cNvPr id="72" name="Picture 71" descr="file-search_4F6B75.png"/>
           <p:cNvPicPr>
             <a:picLocks noChangeAspect="1"/>
           </p:cNvPicPr>
@@ -6405,7 +6366,7 @@
         </p:blipFill>
         <p:spPr>
           <a:xfrm>
-            <a:off x="2843784" y="4974336"/>
+            <a:off x="2843784" y="4572000"/>
             <a:ext cx="274320" cy="274320"/>
           </a:xfrm>
           <a:prstGeom prst="rect">
@@ -6415,14 +6376,14 @@
       </p:pic>
       <p:sp>
         <p:nvSpPr>
-          <p:cNvPr id="74" name="TextBox 73"/>
+          <p:cNvPr id="73" name="TextBox 72"/>
           <p:cNvSpPr txBox="1"/>
           <p:nvPr/>
         </p:nvSpPr>
         <p:spPr>
           <a:xfrm>
-            <a:off x="3136392" y="4919472"/>
-            <a:ext cx="676656" cy="676656"/>
+            <a:off x="3136392" y="4517136"/>
+            <a:ext cx="676656" cy="548640"/>
           </a:xfrm>
           <a:prstGeom prst="rect">
             <a:avLst/>
@@ -6454,13 +6415,13 @@
       </p:sp>
       <p:cxnSp>
         <p:nvCxnSpPr>
-          <p:cNvPr id="75" name="Connector 74"/>
+          <p:cNvPr id="74" name="Connector 73"/>
           <p:cNvCxnSpPr/>
           <p:nvPr/>
         </p:nvCxnSpPr>
         <p:spPr>
           <a:xfrm>
-            <a:off x="3813048" y="5020056"/>
+            <a:off x="3813048" y="4562856"/>
             <a:ext cx="50291" cy="0"/>
           </a:xfrm>
           <a:prstGeom prst="line">
@@ -6491,14 +6452,14 @@
       </p:cxnSp>
       <p:sp>
         <p:nvSpPr>
-          <p:cNvPr id="76" name="Rounded Rectangle 75"/>
+          <p:cNvPr id="75" name="Rounded Rectangle 74"/>
           <p:cNvSpPr/>
           <p:nvPr/>
         </p:nvSpPr>
         <p:spPr>
           <a:xfrm>
-            <a:off x="3863339" y="4425696"/>
-            <a:ext cx="1033271" cy="1188720"/>
+            <a:off x="3863339" y="4059936"/>
+            <a:ext cx="1033271" cy="1005840"/>
           </a:xfrm>
           <a:prstGeom prst="roundRect">
             <a:avLst>
@@ -6535,13 +6496,13 @@
       </p:sp>
       <p:sp>
         <p:nvSpPr>
-          <p:cNvPr id="77" name="Oval 76"/>
+          <p:cNvPr id="76" name="Oval 75"/>
           <p:cNvSpPr/>
           <p:nvPr/>
         </p:nvSpPr>
         <p:spPr>
           <a:xfrm>
-            <a:off x="3918203" y="4480559"/>
+            <a:off x="3918203" y="4114800"/>
             <a:ext cx="237744" cy="237744"/>
           </a:xfrm>
           <a:prstGeom prst="ellipse">
@@ -6588,13 +6549,13 @@
       </p:sp>
       <p:sp>
         <p:nvSpPr>
-          <p:cNvPr id="78" name="TextBox 77"/>
+          <p:cNvPr id="77" name="TextBox 76"/>
           <p:cNvSpPr txBox="1"/>
           <p:nvPr/>
         </p:nvSpPr>
         <p:spPr>
           <a:xfrm>
-            <a:off x="4174235" y="4443983"/>
+            <a:off x="4174235" y="4078224"/>
             <a:ext cx="713232" cy="457200"/>
           </a:xfrm>
           <a:prstGeom prst="rect">
@@ -6627,7 +6588,7 @@
       </p:sp>
       <p:pic>
         <p:nvPicPr>
-          <p:cNvPr id="79" name="Picture 78" descr="git-branch_4F6B75.png"/>
+          <p:cNvPr id="78" name="Picture 77" descr="git-branch_4F6B75.png"/>
           <p:cNvPicPr>
             <a:picLocks noChangeAspect="1"/>
           </p:cNvPicPr>
@@ -6641,7 +6602,7 @@
         </p:blipFill>
         <p:spPr>
           <a:xfrm>
-            <a:off x="3927348" y="4974336"/>
+            <a:off x="3927348" y="4572000"/>
             <a:ext cx="274320" cy="274320"/>
           </a:xfrm>
           <a:prstGeom prst="rect">
@@ -6651,14 +6612,14 @@
       </p:pic>
       <p:sp>
         <p:nvSpPr>
-          <p:cNvPr id="80" name="TextBox 79"/>
+          <p:cNvPr id="79" name="TextBox 78"/>
           <p:cNvSpPr txBox="1"/>
           <p:nvPr/>
         </p:nvSpPr>
         <p:spPr>
           <a:xfrm>
-            <a:off x="4219955" y="4919472"/>
-            <a:ext cx="676656" cy="676656"/>
+            <a:off x="4219955" y="4517136"/>
+            <a:ext cx="676656" cy="548640"/>
           </a:xfrm>
           <a:prstGeom prst="rect">
             <a:avLst/>
@@ -6690,13 +6651,13 @@
       </p:sp>
       <p:cxnSp>
         <p:nvCxnSpPr>
-          <p:cNvPr id="81" name="Connector 80"/>
+          <p:cNvPr id="80" name="Connector 79"/>
           <p:cNvCxnSpPr/>
           <p:nvPr/>
         </p:nvCxnSpPr>
         <p:spPr>
           <a:xfrm>
-            <a:off x="4896612" y="5020056"/>
+            <a:off x="4896612" y="4562856"/>
             <a:ext cx="50292" cy="0"/>
           </a:xfrm>
           <a:prstGeom prst="line">
@@ -6727,14 +6688,14 @@
       </p:cxnSp>
       <p:sp>
         <p:nvSpPr>
-          <p:cNvPr id="82" name="Rounded Rectangle 81"/>
+          <p:cNvPr id="81" name="Rounded Rectangle 80"/>
           <p:cNvSpPr/>
           <p:nvPr/>
         </p:nvSpPr>
         <p:spPr>
           <a:xfrm>
-            <a:off x="4946904" y="4425696"/>
-            <a:ext cx="1033271" cy="1188720"/>
+            <a:off x="4946904" y="4059936"/>
+            <a:ext cx="1033271" cy="1005840"/>
           </a:xfrm>
           <a:prstGeom prst="roundRect">
             <a:avLst>
@@ -6771,13 +6732,13 @@
       </p:sp>
       <p:sp>
         <p:nvSpPr>
-          <p:cNvPr id="83" name="Oval 82"/>
+          <p:cNvPr id="82" name="Oval 81"/>
           <p:cNvSpPr/>
           <p:nvPr/>
         </p:nvSpPr>
         <p:spPr>
           <a:xfrm>
-            <a:off x="5001768" y="4480559"/>
+            <a:off x="5001768" y="4114800"/>
             <a:ext cx="237744" cy="237744"/>
           </a:xfrm>
           <a:prstGeom prst="ellipse">
@@ -6824,13 +6785,13 @@
       </p:sp>
       <p:sp>
         <p:nvSpPr>
-          <p:cNvPr id="84" name="TextBox 83"/>
+          <p:cNvPr id="83" name="TextBox 82"/>
           <p:cNvSpPr txBox="1"/>
           <p:nvPr/>
         </p:nvSpPr>
         <p:spPr>
           <a:xfrm>
-            <a:off x="5257800" y="4443983"/>
+            <a:off x="5257800" y="4078224"/>
             <a:ext cx="713232" cy="457200"/>
           </a:xfrm>
           <a:prstGeom prst="rect">
@@ -6863,7 +6824,7 @@
       </p:sp>
       <p:pic>
         <p:nvPicPr>
-          <p:cNvPr id="85" name="Picture 84" descr="sigma_4F6B75.png"/>
+          <p:cNvPr id="84" name="Picture 83" descr="sigma_4F6B75.png"/>
           <p:cNvPicPr>
             <a:picLocks noChangeAspect="1"/>
           </p:cNvPicPr>
@@ -6877,7 +6838,7 @@
         </p:blipFill>
         <p:spPr>
           <a:xfrm>
-            <a:off x="5010912" y="4974336"/>
+            <a:off x="5010912" y="4572000"/>
             <a:ext cx="274320" cy="274320"/>
           </a:xfrm>
           <a:prstGeom prst="rect">
@@ -6887,14 +6848,14 @@
       </p:pic>
       <p:sp>
         <p:nvSpPr>
-          <p:cNvPr id="86" name="TextBox 85"/>
+          <p:cNvPr id="85" name="TextBox 84"/>
           <p:cNvSpPr txBox="1"/>
           <p:nvPr/>
         </p:nvSpPr>
         <p:spPr>
           <a:xfrm>
-            <a:off x="5303520" y="4919472"/>
-            <a:ext cx="676656" cy="676656"/>
+            <a:off x="5303520" y="4517136"/>
+            <a:ext cx="676656" cy="548640"/>
           </a:xfrm>
           <a:prstGeom prst="rect">
             <a:avLst/>
@@ -6926,13 +6887,13 @@
       </p:sp>
       <p:cxnSp>
         <p:nvCxnSpPr>
-          <p:cNvPr id="87" name="Connector 86"/>
+          <p:cNvPr id="86" name="Connector 85"/>
           <p:cNvCxnSpPr/>
           <p:nvPr/>
         </p:nvCxnSpPr>
         <p:spPr>
           <a:xfrm>
-            <a:off x="5980176" y="5020056"/>
+            <a:off x="5980176" y="4562856"/>
             <a:ext cx="50292" cy="0"/>
           </a:xfrm>
           <a:prstGeom prst="line">
@@ -6963,14 +6924,14 @@
       </p:cxnSp>
       <p:sp>
         <p:nvSpPr>
-          <p:cNvPr id="88" name="Rounded Rectangle 87"/>
+          <p:cNvPr id="87" name="Rounded Rectangle 86"/>
           <p:cNvSpPr/>
           <p:nvPr/>
         </p:nvSpPr>
         <p:spPr>
           <a:xfrm>
-            <a:off x="6030468" y="4425696"/>
-            <a:ext cx="1033271" cy="1188720"/>
+            <a:off x="6030468" y="4059936"/>
+            <a:ext cx="1033271" cy="1005840"/>
           </a:xfrm>
           <a:prstGeom prst="roundRect">
             <a:avLst>
@@ -7007,13 +6968,13 @@
       </p:sp>
       <p:sp>
         <p:nvSpPr>
-          <p:cNvPr id="89" name="Oval 88"/>
+          <p:cNvPr id="88" name="Oval 87"/>
           <p:cNvSpPr/>
           <p:nvPr/>
         </p:nvSpPr>
         <p:spPr>
           <a:xfrm>
-            <a:off x="6085332" y="4480559"/>
+            <a:off x="6085332" y="4114800"/>
             <a:ext cx="237744" cy="237744"/>
           </a:xfrm>
           <a:prstGeom prst="ellipse">
@@ -7060,13 +7021,13 @@
       </p:sp>
       <p:sp>
         <p:nvSpPr>
-          <p:cNvPr id="90" name="TextBox 89"/>
+          <p:cNvPr id="89" name="TextBox 88"/>
           <p:cNvSpPr txBox="1"/>
           <p:nvPr/>
         </p:nvSpPr>
         <p:spPr>
           <a:xfrm>
-            <a:off x="6341364" y="4443983"/>
+            <a:off x="6341364" y="4078224"/>
             <a:ext cx="713232" cy="457200"/>
           </a:xfrm>
           <a:prstGeom prst="rect">
@@ -7099,7 +7060,7 @@
       </p:sp>
       <p:pic>
         <p:nvPicPr>
-          <p:cNvPr id="91" name="Picture 90" descr="timer-reset_4F6B75.png"/>
+          <p:cNvPr id="90" name="Picture 89" descr="timer-reset_4F6B75.png"/>
           <p:cNvPicPr>
             <a:picLocks noChangeAspect="1"/>
           </p:cNvPicPr>
@@ -7113,7 +7074,7 @@
         </p:blipFill>
         <p:spPr>
           <a:xfrm>
-            <a:off x="6094476" y="4974336"/>
+            <a:off x="6094476" y="4572000"/>
             <a:ext cx="274320" cy="274320"/>
           </a:xfrm>
           <a:prstGeom prst="rect">
@@ -7123,14 +7084,14 @@
       </p:pic>
       <p:sp>
         <p:nvSpPr>
-          <p:cNvPr id="92" name="TextBox 91"/>
+          <p:cNvPr id="91" name="TextBox 90"/>
           <p:cNvSpPr txBox="1"/>
           <p:nvPr/>
         </p:nvSpPr>
         <p:spPr>
           <a:xfrm>
-            <a:off x="6387084" y="4919472"/>
-            <a:ext cx="676656" cy="676656"/>
+            <a:off x="6387084" y="4517136"/>
+            <a:ext cx="676656" cy="548640"/>
           </a:xfrm>
           <a:prstGeom prst="rect">
             <a:avLst/>
@@ -7162,14 +7123,14 @@
       </p:sp>
       <p:sp>
         <p:nvSpPr>
-          <p:cNvPr id="93" name="Rounded Rectangle 92"/>
+          <p:cNvPr id="92" name="Rounded Rectangle 91"/>
           <p:cNvSpPr/>
           <p:nvPr/>
         </p:nvSpPr>
         <p:spPr>
           <a:xfrm>
-            <a:off x="2779776" y="5669279"/>
-            <a:ext cx="4297680" cy="384048"/>
+            <a:off x="2779776" y="5120640"/>
+            <a:ext cx="4297680" cy="365760"/>
           </a:xfrm>
           <a:prstGeom prst="roundRect">
             <a:avLst>
@@ -7208,13 +7169,13 @@
       </p:sp>
       <p:sp>
         <p:nvSpPr>
-          <p:cNvPr id="94" name="TextBox 93"/>
+          <p:cNvPr id="93" name="TextBox 92"/>
           <p:cNvSpPr txBox="1"/>
           <p:nvPr/>
         </p:nvSpPr>
         <p:spPr>
           <a:xfrm>
-            <a:off x="2834640" y="5678423"/>
+            <a:off x="2834640" y="5120640"/>
             <a:ext cx="4206240" cy="365760"/>
           </a:xfrm>
           <a:prstGeom prst="rect">
@@ -7256,13 +7217,13 @@
       </p:sp>
       <p:cxnSp>
         <p:nvCxnSpPr>
-          <p:cNvPr id="95" name="Connector 94"/>
+          <p:cNvPr id="94" name="Connector 93"/>
           <p:cNvCxnSpPr/>
           <p:nvPr/>
         </p:nvCxnSpPr>
         <p:spPr>
           <a:xfrm>
-            <a:off x="7168896" y="4974336"/>
+            <a:off x="7168896" y="4489704"/>
             <a:ext cx="219456" cy="0"/>
           </a:xfrm>
           <a:prstGeom prst="line">
@@ -7293,14 +7254,14 @@
       </p:cxnSp>
       <p:sp>
         <p:nvSpPr>
-          <p:cNvPr id="96" name="Rounded Rectangle 95"/>
+          <p:cNvPr id="95" name="Rounded Rectangle 94"/>
           <p:cNvSpPr/>
           <p:nvPr/>
         </p:nvSpPr>
         <p:spPr>
           <a:xfrm>
-            <a:off x="7424927" y="3785615"/>
-            <a:ext cx="2523744" cy="2340864"/>
+            <a:off x="7424927" y="3438144"/>
+            <a:ext cx="2523744" cy="2103120"/>
           </a:xfrm>
           <a:prstGeom prst="roundRect">
             <a:avLst>
@@ -7337,13 +7298,13 @@
       </p:sp>
       <p:sp>
         <p:nvSpPr>
-          <p:cNvPr id="97" name="Oval 96"/>
+          <p:cNvPr id="96" name="Oval 95"/>
           <p:cNvSpPr/>
           <p:nvPr/>
         </p:nvSpPr>
         <p:spPr>
           <a:xfrm>
-            <a:off x="7498079" y="3849624"/>
+            <a:off x="7498079" y="3502152"/>
             <a:ext cx="493776" cy="493776"/>
           </a:xfrm>
           <a:prstGeom prst="ellipse">
@@ -7402,13 +7363,13 @@
       </p:sp>
       <p:sp>
         <p:nvSpPr>
-          <p:cNvPr id="98" name="TextBox 97"/>
+          <p:cNvPr id="97" name="TextBox 96"/>
           <p:cNvSpPr txBox="1"/>
           <p:nvPr/>
         </p:nvSpPr>
         <p:spPr>
           <a:xfrm>
-            <a:off x="8046720" y="3822191"/>
+            <a:off x="8046720" y="3474720"/>
             <a:ext cx="1874519" cy="548640"/>
           </a:xfrm>
           <a:prstGeom prst="rect">
@@ -7457,7 +7418,7 @@
       </p:sp>
       <p:pic>
         <p:nvPicPr>
-          <p:cNvPr id="99" name="Picture 98" descr="code_A0522D.png"/>
+          <p:cNvPr id="98" name="Picture 97" descr="code_A0522D.png"/>
           <p:cNvPicPr>
             <a:picLocks noChangeAspect="1"/>
           </p:cNvPicPr>
@@ -7471,7 +7432,7 @@
         </p:blipFill>
         <p:spPr>
           <a:xfrm>
-            <a:off x="7498079" y="4480559"/>
+            <a:off x="7498079" y="4096512"/>
             <a:ext cx="292608" cy="292608"/>
           </a:xfrm>
           <a:prstGeom prst="rect">
@@ -7481,14 +7442,14 @@
       </p:pic>
       <p:sp>
         <p:nvSpPr>
-          <p:cNvPr id="100" name="TextBox 99"/>
+          <p:cNvPr id="99" name="TextBox 98"/>
           <p:cNvSpPr txBox="1"/>
           <p:nvPr/>
         </p:nvSpPr>
         <p:spPr>
           <a:xfrm>
-            <a:off x="7845552" y="4443983"/>
-            <a:ext cx="2084831" cy="548640"/>
+            <a:off x="7845552" y="4059936"/>
+            <a:ext cx="2084831" cy="512064"/>
           </a:xfrm>
           <a:prstGeom prst="rect">
             <a:avLst/>
@@ -7520,7 +7481,7 @@
       </p:sp>
       <p:pic>
         <p:nvPicPr>
-          <p:cNvPr id="101" name="Picture 100" descr="table-2_A0522D.png"/>
+          <p:cNvPr id="100" name="Picture 99" descr="table-2_A0522D.png"/>
           <p:cNvPicPr>
             <a:picLocks noChangeAspect="1"/>
           </p:cNvPicPr>
@@ -7534,7 +7495,7 @@
         </p:blipFill>
         <p:spPr>
           <a:xfrm>
-            <a:off x="7498079" y="5047488"/>
+            <a:off x="7498079" y="4590288"/>
             <a:ext cx="292608" cy="292608"/>
           </a:xfrm>
           <a:prstGeom prst="rect">
@@ -7544,14 +7505,14 @@
       </p:pic>
       <p:sp>
         <p:nvSpPr>
-          <p:cNvPr id="102" name="TextBox 101"/>
+          <p:cNvPr id="101" name="TextBox 100"/>
           <p:cNvSpPr txBox="1"/>
           <p:nvPr/>
         </p:nvSpPr>
         <p:spPr>
           <a:xfrm>
-            <a:off x="7845552" y="5010912"/>
-            <a:ext cx="2084831" cy="548640"/>
+            <a:off x="7845552" y="4553712"/>
+            <a:ext cx="2084831" cy="512064"/>
           </a:xfrm>
           <a:prstGeom prst="rect">
             <a:avLst/>
@@ -7583,7 +7544,7 @@
       </p:sp>
       <p:pic>
         <p:nvPicPr>
-          <p:cNvPr id="103" name="Picture 102" descr="timer-reset_A0522D.png"/>
+          <p:cNvPr id="102" name="Picture 101" descr="timer-reset_A0522D.png"/>
           <p:cNvPicPr>
             <a:picLocks noChangeAspect="1"/>
           </p:cNvPicPr>
@@ -7597,7 +7558,7 @@
         </p:blipFill>
         <p:spPr>
           <a:xfrm>
-            <a:off x="7498079" y="5596128"/>
+            <a:off x="7498079" y="5065776"/>
             <a:ext cx="292608" cy="292608"/>
           </a:xfrm>
           <a:prstGeom prst="rect">
@@ -7607,14 +7568,14 @@
       </p:pic>
       <p:sp>
         <p:nvSpPr>
-          <p:cNvPr id="104" name="TextBox 103"/>
+          <p:cNvPr id="103" name="TextBox 102"/>
           <p:cNvSpPr txBox="1"/>
           <p:nvPr/>
         </p:nvSpPr>
         <p:spPr>
           <a:xfrm>
-            <a:off x="7845552" y="5559552"/>
-            <a:ext cx="2084831" cy="548640"/>
+            <a:off x="7845552" y="5029200"/>
+            <a:ext cx="2084831" cy="512064"/>
           </a:xfrm>
           <a:prstGeom prst="rect">
             <a:avLst/>
@@ -7646,13 +7607,13 @@
       </p:sp>
       <p:cxnSp>
         <p:nvCxnSpPr>
-          <p:cNvPr id="105" name="Connector 104"/>
+          <p:cNvPr id="104" name="Connector 103"/>
           <p:cNvCxnSpPr/>
           <p:nvPr/>
         </p:nvCxnSpPr>
         <p:spPr>
           <a:xfrm>
-            <a:off x="9966960" y="4974336"/>
+            <a:off x="9966960" y="4489704"/>
             <a:ext cx="219456" cy="0"/>
           </a:xfrm>
           <a:prstGeom prst="line">
@@ -7683,14 +7644,14 @@
       </p:cxnSp>
       <p:sp>
         <p:nvSpPr>
-          <p:cNvPr id="106" name="Rounded Rectangle 105"/>
+          <p:cNvPr id="105" name="Rounded Rectangle 104"/>
           <p:cNvSpPr/>
           <p:nvPr/>
         </p:nvSpPr>
         <p:spPr>
           <a:xfrm>
-            <a:off x="10222992" y="3785615"/>
-            <a:ext cx="1746504" cy="2340864"/>
+            <a:off x="10222992" y="3438144"/>
+            <a:ext cx="1746504" cy="2103120"/>
           </a:xfrm>
           <a:prstGeom prst="roundRect">
             <a:avLst>
@@ -7727,13 +7688,13 @@
       </p:sp>
       <p:sp>
         <p:nvSpPr>
-          <p:cNvPr id="107" name="Oval 106"/>
+          <p:cNvPr id="106" name="Oval 105"/>
           <p:cNvSpPr/>
           <p:nvPr/>
         </p:nvSpPr>
         <p:spPr>
           <a:xfrm>
-            <a:off x="10296144" y="3849624"/>
+            <a:off x="10296144" y="3502152"/>
             <a:ext cx="493776" cy="493776"/>
           </a:xfrm>
           <a:prstGeom prst="ellipse">
@@ -7792,13 +7753,13 @@
       </p:sp>
       <p:sp>
         <p:nvSpPr>
-          <p:cNvPr id="108" name="TextBox 107"/>
+          <p:cNvPr id="107" name="TextBox 106"/>
           <p:cNvSpPr txBox="1"/>
           <p:nvPr/>
         </p:nvSpPr>
         <p:spPr>
           <a:xfrm>
-            <a:off x="10844784" y="3822191"/>
+            <a:off x="10844784" y="3474720"/>
             <a:ext cx="1106424" cy="548640"/>
           </a:xfrm>
           <a:prstGeom prst="rect">
@@ -7847,7 +7808,7 @@
       </p:sp>
       <p:pic>
         <p:nvPicPr>
-          <p:cNvPr id="109" name="Picture 108" descr="settings_A8812E.png"/>
+          <p:cNvPr id="108" name="Picture 107" descr="settings_A8812E.png"/>
           <p:cNvPicPr>
             <a:picLocks noChangeAspect="1"/>
           </p:cNvPicPr>
@@ -7861,7 +7822,7 @@
         </p:blipFill>
         <p:spPr>
           <a:xfrm>
-            <a:off x="10296144" y="4480559"/>
+            <a:off x="10296144" y="4096512"/>
             <a:ext cx="292608" cy="292608"/>
           </a:xfrm>
           <a:prstGeom prst="rect">
@@ -7871,14 +7832,14 @@
       </p:pic>
       <p:sp>
         <p:nvSpPr>
-          <p:cNvPr id="110" name="TextBox 109"/>
+          <p:cNvPr id="109" name="TextBox 108"/>
           <p:cNvSpPr txBox="1"/>
           <p:nvPr/>
         </p:nvSpPr>
         <p:spPr>
           <a:xfrm>
-            <a:off x="10625328" y="4425696"/>
-            <a:ext cx="1325880" cy="1005840"/>
+            <a:off x="10625328" y="4041648"/>
+            <a:ext cx="1325880" cy="822960"/>
           </a:xfrm>
           <a:prstGeom prst="rect">
             <a:avLst/>
@@ -7910,7 +7871,7 @@
       </p:sp>
       <p:pic>
         <p:nvPicPr>
-          <p:cNvPr id="111" name="Picture 110" descr="circle-check_4F6B75.png"/>
+          <p:cNvPr id="110" name="Picture 109" descr="circle-check_4F6B75.png"/>
           <p:cNvPicPr>
             <a:picLocks noChangeAspect="1"/>
           </p:cNvPicPr>
@@ -7924,7 +7885,7 @@
         </p:blipFill>
         <p:spPr>
           <a:xfrm>
-            <a:off x="10296144" y="5413248"/>
+            <a:off x="10296144" y="4864608"/>
             <a:ext cx="201168" cy="201168"/>
           </a:xfrm>
           <a:prstGeom prst="rect">
@@ -7934,13 +7895,13 @@
       </p:pic>
       <p:sp>
         <p:nvSpPr>
-          <p:cNvPr id="112" name="TextBox 111"/>
+          <p:cNvPr id="111" name="TextBox 110"/>
           <p:cNvSpPr txBox="1"/>
           <p:nvPr/>
         </p:nvSpPr>
         <p:spPr>
           <a:xfrm>
-            <a:off x="10533888" y="5385816"/>
+            <a:off x="10533888" y="4837176"/>
             <a:ext cx="1371600" cy="256032"/>
           </a:xfrm>
           <a:prstGeom prst="rect">
@@ -7973,7 +7934,7 @@
       </p:sp>
       <p:pic>
         <p:nvPicPr>
-          <p:cNvPr id="113" name="Picture 112" descr="circle-x_A0522D.png"/>
+          <p:cNvPr id="112" name="Picture 111" descr="circle-x_A0522D.png"/>
           <p:cNvPicPr>
             <a:picLocks noChangeAspect="1"/>
           </p:cNvPicPr>
@@ -7987,7 +7948,7 @@
         </p:blipFill>
         <p:spPr>
           <a:xfrm>
-            <a:off x="10296144" y="5650992"/>
+            <a:off x="10296144" y="5084064"/>
             <a:ext cx="201168" cy="201168"/>
           </a:xfrm>
           <a:prstGeom prst="rect">
@@ -7997,13 +7958,13 @@
       </p:pic>
       <p:sp>
         <p:nvSpPr>
-          <p:cNvPr id="114" name="TextBox 113"/>
+          <p:cNvPr id="113" name="TextBox 112"/>
           <p:cNvSpPr txBox="1"/>
           <p:nvPr/>
         </p:nvSpPr>
         <p:spPr>
           <a:xfrm>
-            <a:off x="10533888" y="5623559"/>
+            <a:off x="10533888" y="5056632"/>
             <a:ext cx="1371600" cy="256032"/>
           </a:xfrm>
           <a:prstGeom prst="rect">
@@ -8036,7 +7997,7 @@
       </p:sp>
       <p:pic>
         <p:nvPicPr>
-          <p:cNvPr id="115" name="Picture 114" descr="circle-help_A8812E.png"/>
+          <p:cNvPr id="114" name="Picture 113" descr="circle-help_A8812E.png"/>
           <p:cNvPicPr>
             <a:picLocks noChangeAspect="1"/>
           </p:cNvPicPr>
@@ -8050,7 +8011,7 @@
         </p:blipFill>
         <p:spPr>
           <a:xfrm>
-            <a:off x="10296144" y="5888736"/>
+            <a:off x="10296144" y="5303520"/>
             <a:ext cx="201168" cy="201168"/>
           </a:xfrm>
           <a:prstGeom prst="rect">
@@ -8060,13 +8021,13 @@
       </p:pic>
       <p:sp>
         <p:nvSpPr>
-          <p:cNvPr id="116" name="TextBox 115"/>
+          <p:cNvPr id="115" name="TextBox 114"/>
           <p:cNvSpPr txBox="1"/>
           <p:nvPr/>
         </p:nvSpPr>
         <p:spPr>
           <a:xfrm>
-            <a:off x="10533888" y="5861303"/>
+            <a:off x="10533888" y="5276088"/>
             <a:ext cx="1371600" cy="256032"/>
           </a:xfrm>
           <a:prstGeom prst="rect">
@@ -8099,57 +8060,13 @@
       </p:sp>
       <p:sp>
         <p:nvSpPr>
-          <p:cNvPr id="117" name="Rounded Rectangle 116"/>
+          <p:cNvPr id="116" name="Oval 115"/>
           <p:cNvSpPr/>
           <p:nvPr/>
         </p:nvSpPr>
         <p:spPr>
           <a:xfrm>
-            <a:off x="91440" y="6309360"/>
-            <a:ext cx="12008815" cy="1051560"/>
-          </a:xfrm>
-          <a:prstGeom prst="roundRect">
-            <a:avLst>
-              <a:gd name="adj" fmla="val 3000"/>
-            </a:avLst>
-          </a:prstGeom>
-          <a:solidFill>
-            <a:srgbClr val="ECEAE7"/>
-          </a:solidFill>
-          <a:ln>
-            <a:noFill/>
-          </a:ln>
-          <a:effectLst/>
-        </p:spPr>
-        <p:style>
-          <a:lnRef idx="1">
-            <a:schemeClr val="accent1"/>
-          </a:lnRef>
-          <a:fillRef idx="3">
-            <a:schemeClr val="accent1"/>
-          </a:fillRef>
-          <a:effectRef idx="0">
-            <a:schemeClr val="accent1"/>
-          </a:effectRef>
-          <a:fontRef idx="minor">
-            <a:schemeClr val="lt1"/>
-          </a:fontRef>
-        </p:style>
-        <p:txBody>
-          <a:bodyPr rtlCol="0" anchor="ctr"/>
-          <a:lstStyle/>
-          <a:p/>
-        </p:txBody>
-      </p:sp>
-      <p:sp>
-        <p:nvSpPr>
-          <p:cNvPr id="118" name="Oval 117"/>
-          <p:cNvSpPr/>
-          <p:nvPr/>
-        </p:nvSpPr>
-        <p:spPr>
-          <a:xfrm>
-            <a:off x="237744" y="6601968"/>
+            <a:off x="237744" y="5705856"/>
             <a:ext cx="420624" cy="420624"/>
           </a:xfrm>
           <a:prstGeom prst="ellipse">
@@ -8196,14 +8113,14 @@
       </p:sp>
       <p:sp>
         <p:nvSpPr>
-          <p:cNvPr id="119" name="TextBox 118"/>
+          <p:cNvPr id="117" name="TextBox 116"/>
           <p:cNvSpPr txBox="1"/>
           <p:nvPr/>
         </p:nvSpPr>
         <p:spPr>
           <a:xfrm>
-            <a:off x="731520" y="6473952"/>
-            <a:ext cx="3108960" cy="457200"/>
+            <a:off x="731520" y="5650992"/>
+            <a:ext cx="1737360" cy="292608"/>
           </a:xfrm>
           <a:prstGeom prst="rect">
             <a:avLst/>
@@ -8222,27 +8139,27 @@
               </a:lnSpc>
             </a:pPr>
             <a:r>
-              <a:rPr sz="1600" b="1" i="0">
+              <a:rPr sz="1200" b="1" i="0">
                 <a:solidFill>
                   <a:srgbClr val="4F6B75"/>
                 </a:solidFill>
                 <a:latin typeface="Verdana"/>
               </a:rPr>
-              <a:t>Stage-level Evaluation</a:t>
-            </a:r>
-          </a:p>
-        </p:txBody>
-      </p:sp>
-      <p:sp>
-        <p:nvSpPr>
-          <p:cNvPr id="120" name="TextBox 119"/>
+              <a:t>Evaluation</a:t>
+            </a:r>
+          </a:p>
+        </p:txBody>
+      </p:sp>
+      <p:sp>
+        <p:nvSpPr>
+          <p:cNvPr id="118" name="TextBox 117"/>
           <p:cNvSpPr txBox="1"/>
           <p:nvPr/>
         </p:nvSpPr>
         <p:spPr>
           <a:xfrm>
-            <a:off x="749808" y="6912864"/>
-            <a:ext cx="3108960" cy="320040"/>
+            <a:off x="731520" y="5907024"/>
+            <a:ext cx="1700784" cy="365760"/>
           </a:xfrm>
           <a:prstGeom prst="rect">
             <a:avLst/>
@@ -8257,7 +8174,7 @@
           <a:p>
             <a:pPr algn="l">
               <a:lnSpc>
-                <a:spcPct val="100000"/>
+                <a:spcPct val="92000"/>
               </a:lnSpc>
             </a:pPr>
             <a:r>
@@ -8267,21 +8184,21 @@
                 </a:solidFill>
                 <a:latin typeface="Verdana"/>
               </a:rPr>
-              <a:t>any stage can be set to gold</a:t>
-            </a:r>
-          </a:p>
-        </p:txBody>
-      </p:sp>
-      <p:sp>
-        <p:nvSpPr>
-          <p:cNvPr id="121" name="Rounded Rectangle 120"/>
+              <a:t>per stage; any stage can be set to gold</a:t>
+            </a:r>
+          </a:p>
+        </p:txBody>
+      </p:sp>
+      <p:sp>
+        <p:nvSpPr>
+          <p:cNvPr id="119" name="Rounded Rectangle 118"/>
           <p:cNvSpPr/>
           <p:nvPr/>
         </p:nvSpPr>
         <p:spPr>
           <a:xfrm>
-            <a:off x="3657600" y="6400800"/>
-            <a:ext cx="2706624" cy="868680"/>
+            <a:off x="2706624" y="5632704"/>
+            <a:ext cx="4443984" cy="621792"/>
           </a:xfrm>
           <a:prstGeom prst="roundRect">
             <a:avLst>
@@ -8320,7 +8237,7 @@
       </p:sp>
       <p:pic>
         <p:nvPicPr>
-          <p:cNvPr id="122" name="Picture 121" descr="file-check_4F6B75.png"/>
+          <p:cNvPr id="120" name="Picture 119" descr="file-check_4F6B75.png"/>
           <p:cNvPicPr>
             <a:picLocks noChangeAspect="1"/>
           </p:cNvPicPr>
@@ -8334,8 +8251,8 @@
         </p:blipFill>
         <p:spPr>
           <a:xfrm>
-            <a:off x="3749039" y="6620256"/>
-            <a:ext cx="420624" cy="420624"/>
+            <a:off x="2779776" y="5779008"/>
+            <a:ext cx="329184" cy="329184"/>
           </a:xfrm>
           <a:prstGeom prst="rect">
             <a:avLst/>
@@ -8344,14 +8261,14 @@
       </p:pic>
       <p:sp>
         <p:nvSpPr>
-          <p:cNvPr id="123" name="TextBox 122"/>
+          <p:cNvPr id="121" name="TextBox 120"/>
           <p:cNvSpPr txBox="1"/>
           <p:nvPr/>
         </p:nvSpPr>
         <p:spPr>
           <a:xfrm>
-            <a:off x="4261104" y="6437376"/>
-            <a:ext cx="2103120" cy="804672"/>
+            <a:off x="3163824" y="5641848"/>
+            <a:ext cx="3950208" cy="603504"/>
           </a:xfrm>
           <a:prstGeom prst="rect">
             <a:avLst/>
@@ -8366,11 +8283,11 @@
           <a:p>
             <a:pPr algn="l">
               <a:lnSpc>
-                <a:spcPct val="95000"/>
+                <a:spcPct val="92000"/>
               </a:lnSpc>
             </a:pPr>
             <a:r>
-              <a:rPr sz="1200" b="1" i="0">
+              <a:rPr sz="1100" b="1" i="0">
                 <a:solidFill>
                   <a:srgbClr val="4F6B75"/>
                 </a:solidFill>
@@ -8382,7 +8299,7 @@
           <a:p>
             <a:pPr algn="l">
               <a:lnSpc>
-                <a:spcPct val="95000"/>
+                <a:spcPct val="92000"/>
               </a:lnSpc>
             </a:pPr>
             <a:r>
@@ -8399,14 +8316,14 @@
       </p:sp>
       <p:sp>
         <p:nvSpPr>
-          <p:cNvPr id="124" name="Rounded Rectangle 123"/>
+          <p:cNvPr id="122" name="Rounded Rectangle 121"/>
           <p:cNvSpPr/>
           <p:nvPr/>
         </p:nvSpPr>
         <p:spPr>
           <a:xfrm>
-            <a:off x="6460236" y="6400800"/>
-            <a:ext cx="2706624" cy="868680"/>
+            <a:off x="7424927" y="5632704"/>
+            <a:ext cx="2523744" cy="621792"/>
           </a:xfrm>
           <a:prstGeom prst="roundRect">
             <a:avLst>
@@ -8445,7 +8362,7 @@
       </p:sp>
       <p:pic>
         <p:nvPicPr>
-          <p:cNvPr id="125" name="Picture 124" descr="database_A0522D.png"/>
+          <p:cNvPr id="123" name="Picture 122" descr="database_A0522D.png"/>
           <p:cNvPicPr>
             <a:picLocks noChangeAspect="1"/>
           </p:cNvPicPr>
@@ -8459,8 +8376,8 @@
         </p:blipFill>
         <p:spPr>
           <a:xfrm>
-            <a:off x="6551675" y="6620256"/>
-            <a:ext cx="420624" cy="420624"/>
+            <a:off x="7498079" y="5779008"/>
+            <a:ext cx="329184" cy="329184"/>
           </a:xfrm>
           <a:prstGeom prst="rect">
             <a:avLst/>
@@ -8469,14 +8386,14 @@
       </p:pic>
       <p:sp>
         <p:nvSpPr>
-          <p:cNvPr id="126" name="TextBox 125"/>
+          <p:cNvPr id="124" name="TextBox 123"/>
           <p:cNvSpPr txBox="1"/>
           <p:nvPr/>
         </p:nvSpPr>
         <p:spPr>
           <a:xfrm>
-            <a:off x="7063740" y="6437376"/>
-            <a:ext cx="2103120" cy="804672"/>
+            <a:off x="7882127" y="5641848"/>
+            <a:ext cx="2029967" cy="603504"/>
           </a:xfrm>
           <a:prstGeom prst="rect">
             <a:avLst/>
@@ -8491,11 +8408,11 @@
           <a:p>
             <a:pPr algn="l">
               <a:lnSpc>
-                <a:spcPct val="95000"/>
+                <a:spcPct val="92000"/>
               </a:lnSpc>
             </a:pPr>
             <a:r>
-              <a:rPr sz="1200" b="1" i="0">
+              <a:rPr sz="1100" b="1" i="0">
                 <a:solidFill>
                   <a:srgbClr val="A0522D"/>
                 </a:solidFill>
@@ -8507,7 +8424,7 @@
           <a:p>
             <a:pPr algn="l">
               <a:lnSpc>
-                <a:spcPct val="95000"/>
+                <a:spcPct val="92000"/>
               </a:lnSpc>
             </a:pPr>
             <a:r>
@@ -8524,14 +8441,14 @@
       </p:sp>
       <p:sp>
         <p:nvSpPr>
-          <p:cNvPr id="127" name="Rounded Rectangle 126"/>
+          <p:cNvPr id="125" name="Rounded Rectangle 124"/>
           <p:cNvSpPr/>
           <p:nvPr/>
         </p:nvSpPr>
         <p:spPr>
           <a:xfrm>
-            <a:off x="9262872" y="6400800"/>
-            <a:ext cx="2706624" cy="868680"/>
+            <a:off x="10222992" y="5632704"/>
+            <a:ext cx="1746504" cy="621792"/>
           </a:xfrm>
           <a:prstGeom prst="roundRect">
             <a:avLst>
@@ -8570,7 +8487,7 @@
       </p:sp>
       <p:pic>
         <p:nvPicPr>
-          <p:cNvPr id="128" name="Picture 127" descr="scale_A8812E.png"/>
+          <p:cNvPr id="126" name="Picture 125" descr="scale_A8812E.png"/>
           <p:cNvPicPr>
             <a:picLocks noChangeAspect="1"/>
           </p:cNvPicPr>
@@ -8584,8 +8501,8 @@
         </p:blipFill>
         <p:spPr>
           <a:xfrm>
-            <a:off x="9354311" y="6620256"/>
-            <a:ext cx="420624" cy="420624"/>
+            <a:off x="10296144" y="5779008"/>
+            <a:ext cx="329184" cy="329184"/>
           </a:xfrm>
           <a:prstGeom prst="rect">
             <a:avLst/>
@@ -8594,14 +8511,14 @@
       </p:pic>
       <p:sp>
         <p:nvSpPr>
-          <p:cNvPr id="129" name="TextBox 128"/>
+          <p:cNvPr id="127" name="TextBox 126"/>
           <p:cNvSpPr txBox="1"/>
           <p:nvPr/>
         </p:nvSpPr>
         <p:spPr>
           <a:xfrm>
-            <a:off x="9866376" y="6437376"/>
-            <a:ext cx="2103120" cy="804672"/>
+            <a:off x="10680192" y="5641848"/>
+            <a:ext cx="1252728" cy="603504"/>
           </a:xfrm>
           <a:prstGeom prst="rect">
             <a:avLst/>
@@ -8616,23 +8533,23 @@
           <a:p>
             <a:pPr algn="l">
               <a:lnSpc>
-                <a:spcPct val="95000"/>
+                <a:spcPct val="92000"/>
               </a:lnSpc>
             </a:pPr>
             <a:r>
-              <a:rPr sz="1200" b="1" i="0">
+              <a:rPr sz="1100" b="1" i="0">
                 <a:solidFill>
                   <a:srgbClr val="A8812E"/>
                 </a:solidFill>
                 <a:latin typeface="Verdana"/>
               </a:rPr>
-              <a:t>Verdict and abstention</a:t>
+              <a:t>Verdict</a:t>
             </a:r>
           </a:p>
           <a:p>
             <a:pPr algn="l">
               <a:lnSpc>
-                <a:spcPct val="95000"/>
+                <a:spcPct val="92000"/>
               </a:lnSpc>
             </a:pPr>
             <a:r>
@@ -8642,7 +8559,7 @@
                 </a:solidFill>
                 <a:latin typeface="Verdana"/>
               </a:rPr>
-              <a:t>accuracy, macro P/R/F1, overclaim, underclaim</a:t>
+              <a:t>accuracy, P/R/F1, over- and underclaim</a:t>
             </a:r>
           </a:p>
         </p:txBody>

</xml_diff>

<commit_message>
Figure 1 in the hand-drawn style: Comic Sans MS body, Times New Roman titles (now the default build; Verdana kept as a candidate)
Co-Authored-By: Claude Opus 5.5 <noreply@anthropic.com>
</commit_message>
<xml_diff>
--- a/docs/draft/Figures/STRATA_framework_editable.pptx
+++ b/docs/draft/Figures/STRATA_framework_editable.pptx
@@ -3178,7 +3178,7 @@
                 <a:solidFill>
                   <a:srgbClr val="FFFFFF"/>
                 </a:solidFill>
-                <a:latin typeface="Verdana"/>
+                <a:latin typeface="Comic Sans MS"/>
               </a:rPr>
               <a:t>1</a:t>
             </a:r>
@@ -3217,7 +3217,7 @@
                 <a:solidFill>
                   <a:srgbClr val="A0522D"/>
                 </a:solidFill>
-                <a:latin typeface="Verdana"/>
+                <a:latin typeface="Times New Roman"/>
               </a:rPr>
               <a:t>STRATA Benchmark Construction</a:t>
             </a:r>
@@ -3318,7 +3318,7 @@
                 <a:solidFill>
                   <a:srgbClr val="FFFFFF"/>
                 </a:solidFill>
-                <a:latin typeface="Verdana"/>
+                <a:latin typeface="Comic Sans MS"/>
               </a:rPr>
               <a:t>1.1</a:t>
             </a:r>
@@ -3357,7 +3357,7 @@
                 <a:solidFill>
                   <a:srgbClr val="2B2B2B"/>
                 </a:solidFill>
-                <a:latin typeface="Verdana"/>
+                <a:latin typeface="Times New Roman"/>
               </a:rPr>
               <a:t>Clinical timelines</a:t>
             </a:r>
@@ -3366,7 +3366,7 @@
                 <a:solidFill>
                   <a:srgbClr val="5F5F5F"/>
                 </a:solidFill>
-                <a:latin typeface="Verdana"/>
+                <a:latin typeface="Comic Sans MS"/>
               </a:rPr>
               <a:t> (MedTempo)</a:t>
             </a:r>
@@ -3453,7 +3453,7 @@
                 <a:solidFill>
                   <a:srgbClr val="2B2B2B"/>
                 </a:solidFill>
-                <a:latin typeface="Verdana"/>
+                <a:latin typeface="Comic Sans MS"/>
               </a:rPr>
               <a:t>3,166 VAERS reports, three vaccines, each a leveled order of events</a:t>
             </a:r>
@@ -3536,7 +3536,7 @@
                 <a:solidFill>
                   <a:srgbClr val="2B2B2B"/>
                 </a:solidFill>
-                <a:latin typeface="Verdana"/>
+                <a:latin typeface="Comic Sans MS"/>
               </a:rPr>
               <a:t>Example timeline</a:t>
             </a:r>
@@ -3552,7 +3552,7 @@
                 <a:solidFill>
                   <a:srgbClr val="5F5F5F"/>
                 </a:solidFill>
-                <a:latin typeface="Verdana"/>
+                <a:latin typeface="Comic Sans MS"/>
               </a:rPr>
               <a:t>report MT-0482913</a:t>
             </a:r>
@@ -3641,7 +3641,7 @@
                 <a:solidFill>
                   <a:srgbClr val="FFFFFF"/>
                 </a:solidFill>
-                <a:latin typeface="Verdana"/>
+                <a:latin typeface="Comic Sans MS"/>
               </a:rPr>
               <a:t/>
             </a:r>
@@ -3680,7 +3680,7 @@
                 <a:solidFill>
                   <a:srgbClr val="4F6B75"/>
                 </a:solidFill>
-                <a:latin typeface="Verdana"/>
+                <a:latin typeface="Comic Sans MS"/>
               </a:rPr>
               <a:t>Fever</a:t>
             </a:r>
@@ -3733,7 +3733,7 @@
                 <a:solidFill>
                   <a:srgbClr val="FFFFFF"/>
                 </a:solidFill>
-                <a:latin typeface="Verdana"/>
+                <a:latin typeface="Comic Sans MS"/>
               </a:rPr>
               <a:t/>
             </a:r>
@@ -3772,7 +3772,7 @@
                 <a:solidFill>
                   <a:srgbClr val="A0522D"/>
                 </a:solidFill>
-                <a:latin typeface="Verdana"/>
+                <a:latin typeface="Comic Sans MS"/>
               </a:rPr>
               <a:t>Headache</a:t>
             </a:r>
@@ -3825,7 +3825,7 @@
                 <a:solidFill>
                   <a:srgbClr val="FFFFFF"/>
                 </a:solidFill>
-                <a:latin typeface="Verdana"/>
+                <a:latin typeface="Comic Sans MS"/>
               </a:rPr>
               <a:t/>
             </a:r>
@@ -3864,7 +3864,7 @@
                 <a:solidFill>
                   <a:srgbClr val="A8812E"/>
                 </a:solidFill>
-                <a:latin typeface="Verdana"/>
+                <a:latin typeface="Comic Sans MS"/>
               </a:rPr>
               <a:t>Fatigue</a:t>
             </a:r>
@@ -3903,7 +3903,7 @@
                 <a:solidFill>
                   <a:srgbClr val="5F5F5F"/>
                 </a:solidFill>
-                <a:latin typeface="Verdana"/>
+                <a:latin typeface="Comic Sans MS"/>
               </a:rPr>
               <a:t>stage → events; the first mention fixes the stage; events at one stage co-exist</a:t>
             </a:r>
@@ -4041,7 +4041,7 @@
                 <a:solidFill>
                   <a:srgbClr val="FFFFFF"/>
                 </a:solidFill>
-                <a:latin typeface="Verdana"/>
+                <a:latin typeface="Comic Sans MS"/>
               </a:rPr>
               <a:t>1.2</a:t>
             </a:r>
@@ -4080,7 +4080,7 @@
                 <a:solidFill>
                   <a:srgbClr val="2B2B2B"/>
                 </a:solidFill>
-                <a:latin typeface="Verdana"/>
+                <a:latin typeface="Times New Roman"/>
               </a:rPr>
               <a:t>Hypothesis templates</a:t>
             </a:r>
@@ -4120,7 +4120,7 @@
                           <a:solidFill>
                             <a:srgbClr val="2B2B2B"/>
                           </a:solidFill>
-                          <a:latin typeface="Verdana"/>
+                          <a:latin typeface="Comic Sans MS"/>
                         </a:rPr>
                         <a:t>Precedes</a:t>
                       </a:r>
@@ -4142,7 +4142,7 @@
                           <a:solidFill>
                             <a:srgbClr val="2B2B2B"/>
                           </a:solidFill>
-                          <a:latin typeface="Verdana"/>
+                          <a:latin typeface="Comic Sans MS"/>
                         </a:rPr>
                         <a:t>A tends to precede B</a:t>
                       </a:r>
@@ -4166,7 +4166,7 @@
                           <a:solidFill>
                             <a:srgbClr val="2B2B2B"/>
                           </a:solidFill>
-                          <a:latin typeface="Verdana"/>
+                          <a:latin typeface="Comic Sans MS"/>
                         </a:rPr>
                         <a:t>Co-occurs</a:t>
                       </a:r>
@@ -4188,7 +4188,7 @@
                           <a:solidFill>
                             <a:srgbClr val="2B2B2B"/>
                           </a:solidFill>
-                          <a:latin typeface="Verdana"/>
+                          <a:latin typeface="Comic Sans MS"/>
                         </a:rPr>
                         <a:t>A and B tend to co-occur</a:t>
                       </a:r>
@@ -4212,7 +4212,7 @@
                           <a:solidFill>
                             <a:srgbClr val="2B2B2B"/>
                           </a:solidFill>
-                          <a:latin typeface="Verdana"/>
+                          <a:latin typeface="Comic Sans MS"/>
                         </a:rPr>
                         <a:t>Sequence</a:t>
                       </a:r>
@@ -4234,7 +4234,7 @@
                           <a:solidFill>
                             <a:srgbClr val="2B2B2B"/>
                           </a:solidFill>
-                          <a:latin typeface="Verdana"/>
+                          <a:latin typeface="Comic Sans MS"/>
                         </a:rPr>
                         <a:t>A, then B, then C</a:t>
                       </a:r>
@@ -4258,7 +4258,7 @@
                           <a:solidFill>
                             <a:srgbClr val="2B2B2B"/>
                           </a:solidFill>
-                          <a:latin typeface="Verdana"/>
+                          <a:latin typeface="Comic Sans MS"/>
                         </a:rPr>
                         <a:t>First / Last</a:t>
                       </a:r>
@@ -4280,7 +4280,7 @@
                           <a:solidFill>
                             <a:srgbClr val="2B2B2B"/>
                           </a:solidFill>
-                          <a:latin typeface="Verdana"/>
+                          <a:latin typeface="Comic Sans MS"/>
                         </a:rPr>
                         <a:t>A is most often first (last)</a:t>
                       </a:r>
@@ -4304,7 +4304,7 @@
                           <a:solidFill>
                             <a:srgbClr val="2B2B2B"/>
                           </a:solidFill>
-                          <a:latin typeface="Verdana"/>
+                          <a:latin typeface="Comic Sans MS"/>
                         </a:rPr>
                         <a:t>Position</a:t>
                       </a:r>
@@ -4326,7 +4326,7 @@
                           <a:solidFill>
                             <a:srgbClr val="2B2B2B"/>
                           </a:solidFill>
-                          <a:latin typeface="Verdana"/>
+                          <a:latin typeface="Comic Sans MS"/>
                         </a:rPr>
                         <a:t>A falls in the earlier half</a:t>
                       </a:r>
@@ -4350,7 +4350,7 @@
                           <a:solidFill>
                             <a:srgbClr val="2B2B2B"/>
                           </a:solidFill>
-                          <a:latin typeface="Verdana"/>
+                          <a:latin typeface="Comic Sans MS"/>
                         </a:rPr>
                         <a:t>Proximity</a:t>
                       </a:r>
@@ -4372,7 +4372,7 @@
                           <a:solidFill>
                             <a:srgbClr val="2B2B2B"/>
                           </a:solidFill>
-                          <a:latin typeface="Verdana"/>
+                          <a:latin typeface="Comic Sans MS"/>
                         </a:rPr>
                         <a:t>A occurs right before B</a:t>
                       </a:r>
@@ -4396,7 +4396,7 @@
                           <a:solidFill>
                             <a:srgbClr val="2B2B2B"/>
                           </a:solidFill>
-                          <a:latin typeface="Verdana"/>
+                          <a:latin typeface="Comic Sans MS"/>
                         </a:rPr>
                         <a:t>Threshold</a:t>
                       </a:r>
@@ -4418,7 +4418,7 @@
                           <a:solidFill>
                             <a:srgbClr val="2B2B2B"/>
                           </a:solidFill>
-                          <a:latin typeface="Verdana"/>
+                          <a:latin typeface="Comic Sans MS"/>
                         </a:rPr>
                         <a:t>A precedes B in ≥ 2/3</a:t>
                       </a:r>
@@ -4566,7 +4566,7 @@
                 <a:solidFill>
                   <a:srgbClr val="FFFFFF"/>
                 </a:solidFill>
-                <a:latin typeface="Verdana"/>
+                <a:latin typeface="Comic Sans MS"/>
               </a:rPr>
               <a:t>1.3</a:t>
             </a:r>
@@ -4605,7 +4605,7 @@
                 <a:solidFill>
                   <a:srgbClr val="2B2B2B"/>
                 </a:solidFill>
-                <a:latin typeface="Verdana"/>
+                <a:latin typeface="Times New Roman"/>
               </a:rPr>
               <a:t>Groups, families, levels</a:t>
             </a:r>
@@ -4712,7 +4712,7 @@
                 <a:solidFill>
                   <a:srgbClr val="2B2B2B"/>
                 </a:solidFill>
-                <a:latin typeface="Verdana"/>
+                <a:latin typeface="Comic Sans MS"/>
               </a:rPr>
               <a:t>26 groups</a:t>
             </a:r>
@@ -4728,7 +4728,7 @@
                 <a:solidFill>
                   <a:srgbClr val="5F5F5F"/>
                 </a:solidFill>
-                <a:latin typeface="Verdana"/>
+                <a:latin typeface="Comic Sans MS"/>
               </a:rPr>
               <a:t>9 report, 16 cohort, 1 two-cohort</a:t>
             </a:r>
@@ -4835,7 +4835,7 @@
                 <a:solidFill>
                   <a:srgbClr val="2B2B2B"/>
                 </a:solidFill>
-                <a:latin typeface="Verdana"/>
+                <a:latin typeface="Comic Sans MS"/>
               </a:rPr>
               <a:t>7 claim families</a:t>
             </a:r>
@@ -4851,7 +4851,7 @@
                 <a:solidFill>
                   <a:srgbClr val="5F5F5F"/>
                 </a:solidFill>
-                <a:latin typeface="Verdana"/>
+                <a:latin typeface="Comic Sans MS"/>
               </a:rPr>
               <a:t>precedes, co-occurs, sequence, first/last, position, proximity, threshold</a:t>
             </a:r>
@@ -4958,7 +4958,7 @@
                 <a:solidFill>
                   <a:srgbClr val="2B2B2B"/>
                 </a:solidFill>
-                <a:latin typeface="Verdana"/>
+                <a:latin typeface="Comic Sans MS"/>
               </a:rPr>
               <a:t>3 difficulty levels</a:t>
             </a:r>
@@ -4974,7 +4974,7 @@
                 <a:solidFill>
                   <a:srgbClr val="5F5F5F"/>
                 </a:solidFill>
-                <a:latin typeface="Verdana"/>
+                <a:latin typeface="Comic Sans MS"/>
               </a:rPr>
               <a:t>Easy one report; Medium one cohort; Hard two cohorts</a:t>
             </a:r>
@@ -5112,7 +5112,7 @@
                 <a:solidFill>
                   <a:srgbClr val="FFFFFF"/>
                 </a:solidFill>
-                <a:latin typeface="Verdana"/>
+                <a:latin typeface="Comic Sans MS"/>
               </a:rPr>
               <a:t>1.4</a:t>
             </a:r>
@@ -5151,7 +5151,7 @@
                 <a:solidFill>
                   <a:srgbClr val="2B2B2B"/>
                 </a:solidFill>
-                <a:latin typeface="Verdana"/>
+                <a:latin typeface="Times New Roman"/>
               </a:rPr>
               <a:t>Gold at every stage</a:t>
             </a:r>
@@ -5258,7 +5258,7 @@
                 <a:solidFill>
                   <a:srgbClr val="2B2B2B"/>
                 </a:solidFill>
-                <a:latin typeface="Verdana"/>
+                <a:latin typeface="Comic Sans MS"/>
               </a:rPr>
               <a:t>Plan</a:t>
             </a:r>
@@ -5274,7 +5274,7 @@
                 <a:solidFill>
                   <a:srgbClr val="5F5F5F"/>
                 </a:solidFill>
-                <a:latin typeface="Verdana"/>
+                <a:latin typeface="Comic Sans MS"/>
               </a:rPr>
               <a:t>events, quantity, denominator primitive, arms, null, p0, tail, test, floor</a:t>
             </a:r>
@@ -5381,7 +5381,7 @@
                 <a:solidFill>
                   <a:srgbClr val="2B2B2B"/>
                 </a:solidFill>
-                <a:latin typeface="Verdana"/>
+                <a:latin typeface="Comic Sans MS"/>
               </a:rPr>
               <a:t>Evidence sets</a:t>
             </a:r>
@@ -5397,7 +5397,7 @@
                 <a:solidFill>
                   <a:srgbClr val="5F5F5F"/>
                 </a:solidFill>
-                <a:latin typeface="Verdana"/>
+                <a:latin typeface="Comic Sans MS"/>
               </a:rPr>
               <a:t>denominator, numerator and excluded ids; n, k per arm</a:t>
             </a:r>
@@ -5504,7 +5504,7 @@
                 <a:solidFill>
                   <a:srgbClr val="2B2B2B"/>
                 </a:solidFill>
-                <a:latin typeface="Verdana"/>
+                <a:latin typeface="Comic Sans MS"/>
               </a:rPr>
               <a:t>Statistics, verdict</a:t>
             </a:r>
@@ -5520,7 +5520,7 @@
                 <a:solidFill>
                   <a:srgbClr val="5F5F5F"/>
                 </a:solidFill>
-                <a:latin typeface="Verdana"/>
+                <a:latin typeface="Comic Sans MS"/>
               </a:rPr>
               <a:t>p on both tails, Wilson CI, Cohen's h; three-way verdict</a:t>
             </a:r>
@@ -5617,7 +5617,7 @@
                 <a:solidFill>
                   <a:srgbClr val="FFFFFF"/>
                 </a:solidFill>
-                <a:latin typeface="Verdana"/>
+                <a:latin typeface="Comic Sans MS"/>
               </a:rPr>
               <a:t>2</a:t>
             </a:r>
@@ -5656,7 +5656,7 @@
                 <a:solidFill>
                   <a:srgbClr val="A0522D"/>
                 </a:solidFill>
-                <a:latin typeface="Verdana"/>
+                <a:latin typeface="Times New Roman"/>
               </a:rPr>
               <a:t>ART Verification Pipeline</a:t>
             </a:r>
@@ -5741,7 +5741,7 @@
                 <a:solidFill>
                   <a:srgbClr val="2B2B2B"/>
                 </a:solidFill>
-                <a:latin typeface="Verdana"/>
+                <a:latin typeface="Times New Roman"/>
               </a:rPr>
               <a:t>Inputs</a:t>
             </a:r>
@@ -5804,7 +5804,7 @@
                 <a:solidFill>
                   <a:srgbClr val="2B2B2B"/>
                 </a:solidFill>
-                <a:latin typeface="Verdana"/>
+                <a:latin typeface="Comic Sans MS"/>
               </a:rPr>
               <a:t>a claim in natural language, with its cohort and level</a:t>
             </a:r>
@@ -5843,7 +5843,7 @@
                 <a:solidFill>
                   <a:srgbClr val="2B2B2B"/>
                 </a:solidFill>
-                <a:latin typeface="Verdana"/>
+                <a:latin typeface="Times New Roman"/>
               </a:rPr>
               <a:t>Resources (to S1)</a:t>
             </a:r>
@@ -5906,7 +5906,7 @@
                 <a:solidFill>
                   <a:srgbClr val="2B2B2B"/>
                 </a:solidFill>
-                <a:latin typeface="Verdana"/>
+                <a:latin typeface="Comic Sans MS"/>
               </a:rPr>
               <a:t>codebook: the corpus stipulations as text; null sources; test definitions</a:t>
             </a:r>
@@ -5969,7 +5969,7 @@
                 <a:solidFill>
                   <a:srgbClr val="2B2B2B"/>
                 </a:solidFill>
-                <a:latin typeface="Verdana"/>
+                <a:latin typeface="Comic Sans MS"/>
               </a:rPr>
               <a:t>timeline DB: report, vaccine, term, first-mention stage</a:t>
             </a:r>
@@ -6140,7 +6140,7 @@
                 <a:solidFill>
                   <a:srgbClr val="FFFFFF"/>
                 </a:solidFill>
-                <a:latin typeface="Verdana"/>
+                <a:latin typeface="Comic Sans MS"/>
               </a:rPr>
               <a:t>S1</a:t>
             </a:r>
@@ -6152,7 +6152,7 @@
                 <a:solidFill>
                   <a:srgbClr val="FFFFFF"/>
                 </a:solidFill>
-                <a:latin typeface="Verdana"/>
+                <a:latin typeface="Comic Sans MS"/>
               </a:rPr>
               <a:t>LLM</a:t>
             </a:r>
@@ -6191,7 +6191,7 @@
                 <a:solidFill>
                   <a:srgbClr val="4F6B75"/>
                 </a:solidFill>
-                <a:latin typeface="Verdana"/>
+                <a:latin typeface="Times New Roman"/>
               </a:rPr>
               <a:t>Articulate</a:t>
             </a:r>
@@ -6207,7 +6207,7 @@
                 <a:solidFill>
                   <a:srgbClr val="5F5F5F"/>
                 </a:solidFill>
-                <a:latin typeface="Verdana"/>
+                <a:latin typeface="Comic Sans MS"/>
               </a:rPr>
               <a:t>form a structured plan; the claim-type mapping is withheld</a:t>
             </a:r>
@@ -6304,7 +6304,7 @@
                 <a:solidFill>
                   <a:srgbClr val="FFFFFF"/>
                 </a:solidFill>
-                <a:latin typeface="Verdana"/>
+                <a:latin typeface="Comic Sans MS"/>
               </a:rPr>
               <a:t>1</a:t>
             </a:r>
@@ -6343,7 +6343,7 @@
                 <a:solidFill>
                   <a:srgbClr val="2B2B2B"/>
                 </a:solidFill>
-                <a:latin typeface="Verdana"/>
+                <a:latin typeface="Comic Sans MS"/>
               </a:rPr>
               <a:t>Parse the claim</a:t>
             </a:r>
@@ -6406,7 +6406,7 @@
                 <a:solidFill>
                   <a:srgbClr val="2B2B2B"/>
                 </a:solidFill>
-                <a:latin typeface="Verdana"/>
+                <a:latin typeface="Comic Sans MS"/>
               </a:rPr>
               <a:t>events, cohort, quantity, direction</a:t>
             </a:r>
@@ -6540,7 +6540,7 @@
                 <a:solidFill>
                   <a:srgbClr val="FFFFFF"/>
                 </a:solidFill>
-                <a:latin typeface="Verdana"/>
+                <a:latin typeface="Comic Sans MS"/>
               </a:rPr>
               <a:t>2</a:t>
             </a:r>
@@ -6579,7 +6579,7 @@
                 <a:solidFill>
                   <a:srgbClr val="2B2B2B"/>
                 </a:solidFill>
-                <a:latin typeface="Verdana"/>
+                <a:latin typeface="Comic Sans MS"/>
               </a:rPr>
               <a:t>Choose the primitive</a:t>
             </a:r>
@@ -6642,7 +6642,7 @@
                 <a:solidFill>
                   <a:srgbClr val="2B2B2B"/>
                 </a:solidFill>
-                <a:latin typeface="Verdana"/>
+                <a:latin typeface="Comic Sans MS"/>
               </a:rPr>
               <a:t>denominator rule; arms</a:t>
             </a:r>
@@ -6776,7 +6776,7 @@
                 <a:solidFill>
                   <a:srgbClr val="FFFFFF"/>
                 </a:solidFill>
-                <a:latin typeface="Verdana"/>
+                <a:latin typeface="Comic Sans MS"/>
               </a:rPr>
               <a:t>3</a:t>
             </a:r>
@@ -6815,7 +6815,7 @@
                 <a:solidFill>
                   <a:srgbClr val="2B2B2B"/>
                 </a:solidFill>
-                <a:latin typeface="Verdana"/>
+                <a:latin typeface="Comic Sans MS"/>
               </a:rPr>
               <a:t>Compose the plan</a:t>
             </a:r>
@@ -6878,7 +6878,7 @@
                 <a:solidFill>
                   <a:srgbClr val="2B2B2B"/>
                 </a:solidFill>
-                <a:latin typeface="Verdana"/>
+                <a:latin typeface="Comic Sans MS"/>
               </a:rPr>
               <a:t>null, p0, tail, test family, floor</a:t>
             </a:r>
@@ -7012,7 +7012,7 @@
                 <a:solidFill>
                   <a:srgbClr val="FFFFFF"/>
                 </a:solidFill>
-                <a:latin typeface="Verdana"/>
+                <a:latin typeface="Comic Sans MS"/>
               </a:rPr>
               <a:t>4</a:t>
             </a:r>
@@ -7051,7 +7051,7 @@
                 <a:solidFill>
                   <a:srgbClr val="2B2B2B"/>
                 </a:solidFill>
-                <a:latin typeface="Verdana"/>
+                <a:latin typeface="Comic Sans MS"/>
               </a:rPr>
               <a:t>Verify, 1 round</a:t>
             </a:r>
@@ -7114,7 +7114,7 @@
                 <a:solidFill>
                   <a:srgbClr val="2B2B2B"/>
                 </a:solidFill>
-                <a:latin typeface="Verdana"/>
+                <a:latin typeface="Comic Sans MS"/>
               </a:rPr>
               <a:t>plan vs the codebook; re-ask once</a:t>
             </a:r>
@@ -7199,7 +7199,7 @@
                 <a:solidFill>
                   <a:srgbClr val="A0522D"/>
                 </a:solidFill>
-                <a:latin typeface="Verdana"/>
+                <a:latin typeface="Comic Sans MS"/>
               </a:rPr>
               <a:t>Contract: </a:t>
             </a:r>
@@ -7208,7 +7208,7 @@
                 <a:solidFill>
                   <a:srgbClr val="2B2B2B"/>
                 </a:solidFill>
-                <a:latin typeface="Verdana"/>
+                <a:latin typeface="Comic Sans MS"/>
               </a:rPr>
               <a:t>the harness resolves the plan's primitive into its exact rule and states it to S2</a:t>
             </a:r>
@@ -7342,7 +7342,7 @@
                 <a:solidFill>
                   <a:srgbClr val="FFFFFF"/>
                 </a:solidFill>
-                <a:latin typeface="Verdana"/>
+                <a:latin typeface="Comic Sans MS"/>
               </a:rPr>
               <a:t>S2</a:t>
             </a:r>
@@ -7354,7 +7354,7 @@
                 <a:solidFill>
                   <a:srgbClr val="FFFFFF"/>
                 </a:solidFill>
-                <a:latin typeface="Verdana"/>
+                <a:latin typeface="Comic Sans MS"/>
               </a:rPr>
               <a:t>LLM</a:t>
             </a:r>
@@ -7393,7 +7393,7 @@
                 <a:solidFill>
                   <a:srgbClr val="A0522D"/>
                 </a:solidFill>
-                <a:latin typeface="Verdana"/>
+                <a:latin typeface="Times New Roman"/>
               </a:rPr>
               <a:t>Retrieve</a:t>
             </a:r>
@@ -7409,7 +7409,7 @@
                 <a:solidFill>
                   <a:srgbClr val="5F5F5F"/>
                 </a:solidFill>
-                <a:latin typeface="Verdana"/>
+                <a:latin typeface="Comic Sans MS"/>
               </a:rPr>
               <a:t>plan to evidence sets</a:t>
             </a:r>
@@ -7472,7 +7472,7 @@
                 <a:solidFill>
                   <a:srgbClr val="2B2B2B"/>
                 </a:solidFill>
-                <a:latin typeface="Verdana"/>
+                <a:latin typeface="Comic Sans MS"/>
               </a:rPr>
               <a:t>told the schema and the contract; one SQL per arm, one row per report</a:t>
             </a:r>
@@ -7535,7 +7535,7 @@
                 <a:solidFill>
                   <a:srgbClr val="2B2B2B"/>
                 </a:solidFill>
-                <a:latin typeface="Verdana"/>
+                <a:latin typeface="Comic Sans MS"/>
               </a:rPr>
               <a:t>sandbox: read-only execution → n, k and report ids per arm</a:t>
             </a:r>
@@ -7598,7 +7598,7 @@
                 <a:solidFill>
                   <a:srgbClr val="2B2B2B"/>
                 </a:solidFill>
-                <a:latin typeface="Verdana"/>
+                <a:latin typeface="Comic Sans MS"/>
               </a:rPr>
               <a:t>verify, up to 2 rounds: rejected SQL, n = k, empty arm, rule leaks</a:t>
             </a:r>
@@ -7732,7 +7732,7 @@
                 <a:solidFill>
                   <a:srgbClr val="FFFFFF"/>
                 </a:solidFill>
-                <a:latin typeface="Verdana"/>
+                <a:latin typeface="Comic Sans MS"/>
               </a:rPr>
               <a:t>S3</a:t>
             </a:r>
@@ -7744,7 +7744,7 @@
                 <a:solidFill>
                   <a:srgbClr val="FFFFFF"/>
                 </a:solidFill>
-                <a:latin typeface="Verdana"/>
+                <a:latin typeface="Comic Sans MS"/>
               </a:rPr>
               <a:t>function</a:t>
             </a:r>
@@ -7783,7 +7783,7 @@
                 <a:solidFill>
                   <a:srgbClr val="A8812E"/>
                 </a:solidFill>
-                <a:latin typeface="Verdana"/>
+                <a:latin typeface="Times New Roman"/>
               </a:rPr>
               <a:t>Test</a:t>
             </a:r>
@@ -7799,7 +7799,7 @@
                 <a:solidFill>
                   <a:srgbClr val="5F5F5F"/>
                 </a:solidFill>
-                <a:latin typeface="Verdana"/>
+                <a:latin typeface="Comic Sans MS"/>
               </a:rPr>
               <a:t>exact, deterministic</a:t>
             </a:r>
@@ -7862,7 +7862,7 @@
                 <a:solidFill>
                   <a:srgbClr val="2B2B2B"/>
                 </a:solidFill>
-                <a:latin typeface="Verdana"/>
+                <a:latin typeface="Comic Sans MS"/>
               </a:rPr>
               <a:t>exact binomial vs p0; Fisher's test, two arms; modal-vs-runner-up, argmax; floor n ≥ 10</a:t>
             </a:r>
@@ -7925,7 +7925,7 @@
                 <a:solidFill>
                   <a:srgbClr val="2B2B2B"/>
                 </a:solidFill>
-                <a:latin typeface="Verdana"/>
+                <a:latin typeface="Comic Sans MS"/>
               </a:rPr>
               <a:t>Supported</a:t>
             </a:r>
@@ -7988,7 +7988,7 @@
                 <a:solidFill>
                   <a:srgbClr val="2B2B2B"/>
                 </a:solidFill>
-                <a:latin typeface="Verdana"/>
+                <a:latin typeface="Comic Sans MS"/>
               </a:rPr>
               <a:t>Refuted</a:t>
             </a:r>
@@ -8051,7 +8051,7 @@
                 <a:solidFill>
                   <a:srgbClr val="2B2B2B"/>
                 </a:solidFill>
-                <a:latin typeface="Verdana"/>
+                <a:latin typeface="Comic Sans MS"/>
               </a:rPr>
               <a:t>Insufficient</a:t>
             </a:r>
@@ -8104,7 +8104,7 @@
                 <a:solidFill>
                   <a:srgbClr val="FFFFFF"/>
                 </a:solidFill>
-                <a:latin typeface="Verdana"/>
+                <a:latin typeface="Comic Sans MS"/>
               </a:rPr>
               <a:t>3</a:t>
             </a:r>
@@ -8143,7 +8143,7 @@
                 <a:solidFill>
                   <a:srgbClr val="4F6B75"/>
                 </a:solidFill>
-                <a:latin typeface="Verdana"/>
+                <a:latin typeface="Times New Roman"/>
               </a:rPr>
               <a:t>Evaluation</a:t>
             </a:r>
@@ -8182,7 +8182,7 @@
                 <a:solidFill>
                   <a:srgbClr val="5F5F5F"/>
                 </a:solidFill>
-                <a:latin typeface="Verdana"/>
+                <a:latin typeface="Comic Sans MS"/>
               </a:rPr>
               <a:t>per stage; any stage can be set to gold</a:t>
             </a:r>
@@ -8291,7 +8291,7 @@
                 <a:solidFill>
                   <a:srgbClr val="4F6B75"/>
                 </a:solidFill>
-                <a:latin typeface="Verdana"/>
+                <a:latin typeface="Comic Sans MS"/>
               </a:rPr>
               <a:t>Plan correctness</a:t>
             </a:r>
@@ -8307,7 +8307,7 @@
                 <a:solidFill>
                   <a:srgbClr val="5F5F5F"/>
                 </a:solidFill>
-                <a:latin typeface="Verdana"/>
+                <a:latin typeface="Comic Sans MS"/>
               </a:rPr>
               <a:t>plan EM, claim-type EM</a:t>
             </a:r>
@@ -8416,7 +8416,7 @@
                 <a:solidFill>
                   <a:srgbClr val="A0522D"/>
                 </a:solidFill>
-                <a:latin typeface="Verdana"/>
+                <a:latin typeface="Comic Sans MS"/>
               </a:rPr>
               <a:t>Evidence correctness</a:t>
             </a:r>
@@ -8432,7 +8432,7 @@
                 <a:solidFill>
                   <a:srgbClr val="5F5F5F"/>
                 </a:solidFill>
-                <a:latin typeface="Verdana"/>
+                <a:latin typeface="Comic Sans MS"/>
               </a:rPr>
               <a:t>evidence F1, co-exist / tie leak, faithfulness</a:t>
             </a:r>
@@ -8541,7 +8541,7 @@
                 <a:solidFill>
                   <a:srgbClr val="A8812E"/>
                 </a:solidFill>
-                <a:latin typeface="Verdana"/>
+                <a:latin typeface="Comic Sans MS"/>
               </a:rPr>
               <a:t>Verdict</a:t>
             </a:r>
@@ -8557,7 +8557,7 @@
                 <a:solidFill>
                   <a:srgbClr val="5F5F5F"/>
                 </a:solidFill>
-                <a:latin typeface="Verdana"/>
+                <a:latin typeface="Comic Sans MS"/>
               </a:rPr>
               <a:t>accuracy, P/R/F1, over- and underclaim</a:t>
             </a:r>

</xml_diff>

<commit_message>
Figure 2: body text +2 pt; taller panels, Articulate steps as a 2x2 grid, labels shortened to one line
Co-Authored-By: Claude Opus 5.5 <noreply@anthropic.com>
</commit_message>
<xml_diff>
--- a/docs/draft/Figures/STRATA_framework_editable.pptx
+++ b/docs/draft/Figures/STRATA_framework_editable.pptx
@@ -7,7 +7,7 @@
   <p:sldIdLst>
     <p:sldId id="256" r:id="rId7"/>
   </p:sldIdLst>
-  <p:sldSz cx="10058400" cy="4882896" type="screen4x3"/>
+  <p:sldSz cx="10058400" cy="5733288" type="screen4x3"/>
   <p:notesSz cx="6858000" cy="9144000"/>
   <p:defaultTextStyle>
     <a:defPPr>
@@ -3097,7 +3097,7 @@
         <p:spPr>
           <a:xfrm>
             <a:off x="91440" y="73152"/>
-            <a:ext cx="9875520" cy="2011680"/>
+            <a:ext cx="9875520" cy="2286000"/>
           </a:xfrm>
           <a:prstGeom prst="roundRect">
             <a:avLst>
@@ -3233,7 +3233,7 @@
         <p:spPr>
           <a:xfrm>
             <a:off x="182880" y="566928"/>
-            <a:ext cx="1965960" cy="1444752"/>
+            <a:ext cx="1965960" cy="1700784"/>
           </a:xfrm>
           <a:prstGeom prst="roundRect">
             <a:avLst>
@@ -3420,8 +3420,8 @@
         </p:nvSpPr>
         <p:spPr>
           <a:xfrm>
-            <a:off x="1024128" y="932688"/>
-            <a:ext cx="1069848" cy="457200"/>
+            <a:off x="1024128" y="914400"/>
+            <a:ext cx="1069848" cy="658368"/>
           </a:xfrm>
           <a:prstGeom prst="rect">
             <a:avLst/>
@@ -3440,7 +3440,7 @@
               </a:lnSpc>
             </a:pPr>
             <a:r>
-              <a:rPr sz="900" b="0" i="0">
+              <a:rPr sz="1100" b="0" i="0">
                 <a:solidFill>
                   <a:srgbClr val="2B2B2B"/>
                 </a:solidFill>
@@ -3451,15 +3451,54 @@
           </a:p>
         </p:txBody>
       </p:sp>
+      <p:sp>
+        <p:nvSpPr>
+          <p:cNvPr id="11" name="TextBox 10"/>
+          <p:cNvSpPr txBox="1"/>
+          <p:nvPr/>
+        </p:nvSpPr>
+        <p:spPr>
+          <a:xfrm>
+            <a:off x="274320" y="1609343"/>
+            <a:ext cx="1783080" cy="201168"/>
+          </a:xfrm>
+          <a:prstGeom prst="rect">
+            <a:avLst/>
+          </a:prstGeom>
+          <a:noFill/>
+        </p:spPr>
+        <p:txBody>
+          <a:bodyPr wrap="square" lIns="27432" rIns="27432" tIns="9144" bIns="9144" anchor="t">
+            <a:spAutoFit/>
+          </a:bodyPr>
+          <a:lstStyle/>
+          <a:p>
+            <a:pPr algn="ctr">
+              <a:lnSpc>
+                <a:spcPct val="100000"/>
+              </a:lnSpc>
+            </a:pPr>
+            <a:r>
+              <a:rPr sz="1000" b="0" i="0">
+                <a:solidFill>
+                  <a:srgbClr val="5F5F5F"/>
+                </a:solidFill>
+                <a:latin typeface="Comic Sans MS"/>
+              </a:rPr>
+              <a:t>one stage per circle</a:t>
+            </a:r>
+          </a:p>
+        </p:txBody>
+      </p:sp>
       <p:cxnSp>
         <p:nvCxnSpPr>
-          <p:cNvPr id="11" name="Connector 10"/>
+          <p:cNvPr id="12" name="Connector 11"/>
           <p:cNvCxnSpPr/>
           <p:nvPr/>
         </p:nvCxnSpPr>
         <p:spPr>
           <a:xfrm>
-            <a:off x="384048" y="1591056"/>
+            <a:off x="384048" y="1938528"/>
             <a:ext cx="1563624" cy="0"/>
           </a:xfrm>
           <a:prstGeom prst="line">
@@ -3489,13 +3528,13 @@
       </p:cxnSp>
       <p:sp>
         <p:nvSpPr>
-          <p:cNvPr id="12" name="Oval 11"/>
+          <p:cNvPr id="13" name="Oval 12"/>
           <p:cNvSpPr/>
           <p:nvPr/>
         </p:nvSpPr>
         <p:spPr>
           <a:xfrm>
-            <a:off x="402336" y="1517904"/>
+            <a:off x="402336" y="1865376"/>
             <a:ext cx="146304" cy="146304"/>
           </a:xfrm>
           <a:prstGeom prst="ellipse">
@@ -3542,13 +3581,13 @@
       </p:sp>
       <p:sp>
         <p:nvSpPr>
-          <p:cNvPr id="13" name="TextBox 12"/>
+          <p:cNvPr id="14" name="TextBox 13"/>
           <p:cNvSpPr txBox="1"/>
           <p:nvPr/>
         </p:nvSpPr>
         <p:spPr>
           <a:xfrm>
-            <a:off x="18288" y="1682496"/>
+            <a:off x="18288" y="2029968"/>
             <a:ext cx="914400" cy="219456"/>
           </a:xfrm>
           <a:prstGeom prst="rect">
@@ -3568,7 +3607,7 @@
               </a:lnSpc>
             </a:pPr>
             <a:r>
-              <a:rPr sz="900" b="1" i="0">
+              <a:rPr sz="1100" b="1" i="0">
                 <a:solidFill>
                   <a:srgbClr val="4F6B75"/>
                 </a:solidFill>
@@ -3581,13 +3620,13 @@
       </p:sp>
       <p:sp>
         <p:nvSpPr>
-          <p:cNvPr id="14" name="Oval 13"/>
+          <p:cNvPr id="15" name="Oval 14"/>
           <p:cNvSpPr/>
           <p:nvPr/>
         </p:nvSpPr>
         <p:spPr>
           <a:xfrm>
-            <a:off x="1092707" y="1517904"/>
+            <a:off x="1092707" y="1865376"/>
             <a:ext cx="146304" cy="146304"/>
           </a:xfrm>
           <a:prstGeom prst="ellipse">
@@ -3634,13 +3673,13 @@
       </p:sp>
       <p:sp>
         <p:nvSpPr>
-          <p:cNvPr id="15" name="TextBox 14"/>
+          <p:cNvPr id="16" name="TextBox 15"/>
           <p:cNvSpPr txBox="1"/>
           <p:nvPr/>
         </p:nvSpPr>
         <p:spPr>
           <a:xfrm>
-            <a:off x="708659" y="1682496"/>
+            <a:off x="708659" y="2029968"/>
             <a:ext cx="914400" cy="219456"/>
           </a:xfrm>
           <a:prstGeom prst="rect">
@@ -3660,7 +3699,7 @@
               </a:lnSpc>
             </a:pPr>
             <a:r>
-              <a:rPr sz="900" b="1" i="0">
+              <a:rPr sz="1100" b="1" i="0">
                 <a:solidFill>
                   <a:srgbClr val="A0522D"/>
                 </a:solidFill>
@@ -3673,13 +3712,13 @@
       </p:sp>
       <p:sp>
         <p:nvSpPr>
-          <p:cNvPr id="16" name="Oval 15"/>
+          <p:cNvPr id="17" name="Oval 16"/>
           <p:cNvSpPr/>
           <p:nvPr/>
         </p:nvSpPr>
         <p:spPr>
           <a:xfrm>
-            <a:off x="1783079" y="1517904"/>
+            <a:off x="1783079" y="1865376"/>
             <a:ext cx="146304" cy="146304"/>
           </a:xfrm>
           <a:prstGeom prst="ellipse">
@@ -3726,13 +3765,13 @@
       </p:sp>
       <p:sp>
         <p:nvSpPr>
-          <p:cNvPr id="17" name="TextBox 16"/>
+          <p:cNvPr id="18" name="TextBox 17"/>
           <p:cNvSpPr txBox="1"/>
           <p:nvPr/>
         </p:nvSpPr>
         <p:spPr>
           <a:xfrm>
-            <a:off x="1399031" y="1682496"/>
+            <a:off x="1399031" y="2029968"/>
             <a:ext cx="914400" cy="219456"/>
           </a:xfrm>
           <a:prstGeom prst="rect">
@@ -3752,52 +3791,13 @@
               </a:lnSpc>
             </a:pPr>
             <a:r>
-              <a:rPr sz="900" b="1" i="0">
+              <a:rPr sz="1100" b="1" i="0">
                 <a:solidFill>
                   <a:srgbClr val="A8812E"/>
                 </a:solidFill>
                 <a:latin typeface="Comic Sans MS"/>
               </a:rPr>
               <a:t>Fatigue</a:t>
-            </a:r>
-          </a:p>
-        </p:txBody>
-      </p:sp>
-      <p:sp>
-        <p:nvSpPr>
-          <p:cNvPr id="18" name="TextBox 17"/>
-          <p:cNvSpPr txBox="1"/>
-          <p:nvPr/>
-        </p:nvSpPr>
-        <p:spPr>
-          <a:xfrm>
-            <a:off x="274320" y="1353312"/>
-            <a:ext cx="1783080" cy="182880"/>
-          </a:xfrm>
-          <a:prstGeom prst="rect">
-            <a:avLst/>
-          </a:prstGeom>
-          <a:noFill/>
-        </p:spPr>
-        <p:txBody>
-          <a:bodyPr wrap="square" lIns="27432" rIns="27432" tIns="9144" bIns="9144" anchor="t">
-            <a:spAutoFit/>
-          </a:bodyPr>
-          <a:lstStyle/>
-          <a:p>
-            <a:pPr algn="ctr">
-              <a:lnSpc>
-                <a:spcPct val="100000"/>
-              </a:lnSpc>
-            </a:pPr>
-            <a:r>
-              <a:rPr sz="800" b="0" i="0">
-                <a:solidFill>
-                  <a:srgbClr val="5F5F5F"/>
-                </a:solidFill>
-                <a:latin typeface="Comic Sans MS"/>
-              </a:rPr>
-              <a:t>a leveled order: one stage per circle</a:t>
             </a:r>
           </a:p>
         </p:txBody>
@@ -3810,7 +3810,7 @@
         </p:nvCxnSpPr>
         <p:spPr>
           <a:xfrm>
-            <a:off x="2167128" y="1289304"/>
+            <a:off x="2167128" y="1417320"/>
             <a:ext cx="164592" cy="0"/>
           </a:xfrm>
           <a:prstGeom prst="line">
@@ -3848,7 +3848,7 @@
         <p:spPr>
           <a:xfrm>
             <a:off x="2350008" y="566928"/>
-            <a:ext cx="2880360" cy="1444752"/>
+            <a:ext cx="2880360" cy="1700784"/>
           </a:xfrm>
           <a:prstGeom prst="roundRect">
             <a:avLst>
@@ -3989,7 +3989,7 @@
         </p:nvGraphicFramePr>
         <p:xfrm>
           <a:off x="2423160" y="950976"/>
-          <a:ext cx="2734056" cy="1024128"/>
+          <a:ext cx="2734056" cy="1243578"/>
         </p:xfrm>
         <a:graphic>
           <a:graphicData uri="http://schemas.openxmlformats.org/drawingml/2006/table">
@@ -3998,17 +3998,17 @@
                 <a:tableStyleId>{5C22544A-7EE6-4342-B048-85BDC9FD1C3A}</a:tableStyleId>
               </a:tblPr>
               <a:tblGrid>
-                <a:gridCol w="914400"/>
-                <a:gridCol w="1819656"/>
+                <a:gridCol w="868680"/>
+                <a:gridCol w="1865376"/>
               </a:tblGrid>
-              <a:tr h="146304">
+              <a:tr h="177654">
                 <a:tc>
                   <a:txBody>
                     <a:bodyPr/>
                     <a:lstStyle/>
                     <a:p>
                       <a:r>
-                        <a:rPr sz="900" b="1">
+                        <a:rPr sz="1100" b="1">
                           <a:solidFill>
                             <a:srgbClr val="2B2B2B"/>
                           </a:solidFill>
@@ -4030,7 +4030,7 @@
                     <a:lstStyle/>
                     <a:p>
                       <a:r>
-                        <a:rPr sz="900" b="0">
+                        <a:rPr sz="1100" b="0">
                           <a:solidFill>
                             <a:srgbClr val="2B2B2B"/>
                           </a:solidFill>
@@ -4047,14 +4047,14 @@
                   </a:tcPr>
                 </a:tc>
               </a:tr>
-              <a:tr h="146304">
+              <a:tr h="177654">
                 <a:tc>
                   <a:txBody>
                     <a:bodyPr/>
                     <a:lstStyle/>
                     <a:p>
                       <a:r>
-                        <a:rPr sz="900" b="1">
+                        <a:rPr sz="1100" b="1">
                           <a:solidFill>
                             <a:srgbClr val="2B2B2B"/>
                           </a:solidFill>
@@ -4076,7 +4076,7 @@
                     <a:lstStyle/>
                     <a:p>
                       <a:r>
-                        <a:rPr sz="900" b="0">
+                        <a:rPr sz="1100" b="0">
                           <a:solidFill>
                             <a:srgbClr val="2B2B2B"/>
                           </a:solidFill>
@@ -4093,14 +4093,14 @@
                   </a:tcPr>
                 </a:tc>
               </a:tr>
-              <a:tr h="146304">
+              <a:tr h="177654">
                 <a:tc>
                   <a:txBody>
                     <a:bodyPr/>
                     <a:lstStyle/>
                     <a:p>
                       <a:r>
-                        <a:rPr sz="900" b="1">
+                        <a:rPr sz="1100" b="1">
                           <a:solidFill>
                             <a:srgbClr val="2B2B2B"/>
                           </a:solidFill>
@@ -4122,7 +4122,7 @@
                     <a:lstStyle/>
                     <a:p>
                       <a:r>
-                        <a:rPr sz="900" b="0">
+                        <a:rPr sz="1100" b="0">
                           <a:solidFill>
                             <a:srgbClr val="2B2B2B"/>
                           </a:solidFill>
@@ -4139,14 +4139,14 @@
                   </a:tcPr>
                 </a:tc>
               </a:tr>
-              <a:tr h="146304">
+              <a:tr h="177654">
                 <a:tc>
                   <a:txBody>
                     <a:bodyPr/>
                     <a:lstStyle/>
                     <a:p>
                       <a:r>
-                        <a:rPr sz="900" b="1">
+                        <a:rPr sz="1100" b="1">
                           <a:solidFill>
                             <a:srgbClr val="2B2B2B"/>
                           </a:solidFill>
@@ -4168,7 +4168,7 @@
                     <a:lstStyle/>
                     <a:p>
                       <a:r>
-                        <a:rPr sz="900" b="0">
+                        <a:rPr sz="1100" b="0">
                           <a:solidFill>
                             <a:srgbClr val="2B2B2B"/>
                           </a:solidFill>
@@ -4185,14 +4185,14 @@
                   </a:tcPr>
                 </a:tc>
               </a:tr>
-              <a:tr h="146304">
+              <a:tr h="177654">
                 <a:tc>
                   <a:txBody>
                     <a:bodyPr/>
                     <a:lstStyle/>
                     <a:p>
                       <a:r>
-                        <a:rPr sz="900" b="1">
+                        <a:rPr sz="1100" b="1">
                           <a:solidFill>
                             <a:srgbClr val="2B2B2B"/>
                           </a:solidFill>
@@ -4214,7 +4214,7 @@
                     <a:lstStyle/>
                     <a:p>
                       <a:r>
-                        <a:rPr sz="900" b="0">
+                        <a:rPr sz="1100" b="0">
                           <a:solidFill>
                             <a:srgbClr val="2B2B2B"/>
                           </a:solidFill>
@@ -4231,14 +4231,14 @@
                   </a:tcPr>
                 </a:tc>
               </a:tr>
-              <a:tr h="146304">
+              <a:tr h="177654">
                 <a:tc>
                   <a:txBody>
                     <a:bodyPr/>
                     <a:lstStyle/>
                     <a:p>
                       <a:r>
-                        <a:rPr sz="900" b="1">
+                        <a:rPr sz="1100" b="1">
                           <a:solidFill>
                             <a:srgbClr val="2B2B2B"/>
                           </a:solidFill>
@@ -4260,7 +4260,7 @@
                     <a:lstStyle/>
                     <a:p>
                       <a:r>
-                        <a:rPr sz="900" b="0">
+                        <a:rPr sz="1100" b="0">
                           <a:solidFill>
                             <a:srgbClr val="2B2B2B"/>
                           </a:solidFill>
@@ -4277,14 +4277,14 @@
                   </a:tcPr>
                 </a:tc>
               </a:tr>
-              <a:tr h="146304">
+              <a:tr h="177654">
                 <a:tc>
                   <a:txBody>
                     <a:bodyPr/>
                     <a:lstStyle/>
                     <a:p>
                       <a:r>
-                        <a:rPr sz="900" b="1">
+                        <a:rPr sz="1100" b="1">
                           <a:solidFill>
                             <a:srgbClr val="2B2B2B"/>
                           </a:solidFill>
@@ -4306,7 +4306,7 @@
                     <a:lstStyle/>
                     <a:p>
                       <a:r>
-                        <a:rPr sz="900" b="0">
+                        <a:rPr sz="1100" b="0">
                           <a:solidFill>
                             <a:srgbClr val="2B2B2B"/>
                           </a:solidFill>
@@ -4335,7 +4335,7 @@
         </p:nvCxnSpPr>
         <p:spPr>
           <a:xfrm>
-            <a:off x="5248655" y="1289304"/>
+            <a:off x="5248655" y="1417320"/>
             <a:ext cx="164593" cy="0"/>
           </a:xfrm>
           <a:prstGeom prst="line">
@@ -4373,7 +4373,7 @@
         <p:spPr>
           <a:xfrm>
             <a:off x="5431536" y="566928"/>
-            <a:ext cx="2103120" cy="1444752"/>
+            <a:ext cx="2103120" cy="1700784"/>
           </a:xfrm>
           <a:prstGeom prst="roundRect">
             <a:avLst>
@@ -4513,7 +4513,7 @@
         <p:spPr>
           <a:xfrm>
             <a:off x="5504688" y="950976"/>
-            <a:ext cx="1956815" cy="320040"/>
+            <a:ext cx="1956815" cy="402336"/>
           </a:xfrm>
           <a:prstGeom prst="roundRect">
             <a:avLst>
@@ -4564,8 +4564,8 @@
         </p:blipFill>
         <p:spPr>
           <a:xfrm>
-            <a:off x="5550408" y="987552"/>
-            <a:ext cx="246888" cy="246888"/>
+            <a:off x="5550408" y="1014984"/>
+            <a:ext cx="256032" cy="256032"/>
           </a:xfrm>
           <a:prstGeom prst="rect">
             <a:avLst/>
@@ -4580,8 +4580,8 @@
         </p:nvSpPr>
         <p:spPr>
           <a:xfrm>
-            <a:off x="5852160" y="950976"/>
-            <a:ext cx="1591055" cy="320040"/>
+            <a:off x="5870448" y="950976"/>
+            <a:ext cx="1572767" cy="402336"/>
           </a:xfrm>
           <a:prstGeom prst="rect">
             <a:avLst/>
@@ -4600,11 +4600,11 @@
               </a:lnSpc>
             </a:pPr>
             <a:r>
-              <a:rPr sz="1000" b="1" i="0">
+              <a:rPr sz="1200" b="1" i="0">
                 <a:solidFill>
                   <a:srgbClr val="2B2B2B"/>
                 </a:solidFill>
-                <a:latin typeface="Comic Sans MS"/>
+                <a:latin typeface="Times New Roman"/>
               </a:rPr>
               <a:t>26 groups</a:t>
             </a:r>
@@ -4616,13 +4616,13 @@
               </a:lnSpc>
             </a:pPr>
             <a:r>
-              <a:rPr sz="850" b="0" i="0">
+              <a:rPr sz="1050" b="0" i="0">
                 <a:solidFill>
                   <a:srgbClr val="5F5F5F"/>
                 </a:solidFill>
                 <a:latin typeface="Comic Sans MS"/>
               </a:rPr>
-              <a:t>9 report, 16 cohort, 1 two-cohort</a:t>
+              <a:t>9 report, 17 cohort-level</a:t>
             </a:r>
           </a:p>
         </p:txBody>
@@ -4635,8 +4635,8 @@
         </p:nvSpPr>
         <p:spPr>
           <a:xfrm>
-            <a:off x="5504688" y="1298448"/>
-            <a:ext cx="1956815" cy="320040"/>
+            <a:off x="5504688" y="1380744"/>
+            <a:ext cx="1956815" cy="402336"/>
           </a:xfrm>
           <a:prstGeom prst="roundRect">
             <a:avLst>
@@ -4687,8 +4687,8 @@
         </p:blipFill>
         <p:spPr>
           <a:xfrm>
-            <a:off x="5550408" y="1335024"/>
-            <a:ext cx="246888" cy="246888"/>
+            <a:off x="5550408" y="1444752"/>
+            <a:ext cx="256032" cy="256032"/>
           </a:xfrm>
           <a:prstGeom prst="rect">
             <a:avLst/>
@@ -4703,8 +4703,8 @@
         </p:nvSpPr>
         <p:spPr>
           <a:xfrm>
-            <a:off x="5852160" y="1298448"/>
-            <a:ext cx="1591055" cy="320040"/>
+            <a:off x="5870448" y="1380744"/>
+            <a:ext cx="1572767" cy="402336"/>
           </a:xfrm>
           <a:prstGeom prst="rect">
             <a:avLst/>
@@ -4723,11 +4723,11 @@
               </a:lnSpc>
             </a:pPr>
             <a:r>
-              <a:rPr sz="1000" b="1" i="0">
+              <a:rPr sz="1200" b="1" i="0">
                 <a:solidFill>
                   <a:srgbClr val="2B2B2B"/>
                 </a:solidFill>
-                <a:latin typeface="Comic Sans MS"/>
+                <a:latin typeface="Times New Roman"/>
               </a:rPr>
               <a:t>7 claim families</a:t>
             </a:r>
@@ -4739,13 +4739,13 @@
               </a:lnSpc>
             </a:pPr>
             <a:r>
-              <a:rPr sz="850" b="0" i="0">
+              <a:rPr sz="1050" b="0" i="0">
                 <a:solidFill>
                   <a:srgbClr val="5F5F5F"/>
                 </a:solidFill>
                 <a:latin typeface="Comic Sans MS"/>
               </a:rPr>
-              <a:t>order, timing and position</a:t>
+              <a:t>order, timing, position</a:t>
             </a:r>
           </a:p>
         </p:txBody>
@@ -4758,8 +4758,8 @@
         </p:nvSpPr>
         <p:spPr>
           <a:xfrm>
-            <a:off x="5504688" y="1645920"/>
-            <a:ext cx="1956815" cy="320040"/>
+            <a:off x="5504688" y="1810512"/>
+            <a:ext cx="1956815" cy="402336"/>
           </a:xfrm>
           <a:prstGeom prst="roundRect">
             <a:avLst>
@@ -4810,8 +4810,8 @@
         </p:blipFill>
         <p:spPr>
           <a:xfrm>
-            <a:off x="5550408" y="1682496"/>
-            <a:ext cx="246888" cy="246888"/>
+            <a:off x="5550408" y="1874519"/>
+            <a:ext cx="256032" cy="256032"/>
           </a:xfrm>
           <a:prstGeom prst="rect">
             <a:avLst/>
@@ -4826,8 +4826,8 @@
         </p:nvSpPr>
         <p:spPr>
           <a:xfrm>
-            <a:off x="5852160" y="1645920"/>
-            <a:ext cx="1591055" cy="320040"/>
+            <a:off x="5870448" y="1810512"/>
+            <a:ext cx="1572767" cy="402336"/>
           </a:xfrm>
           <a:prstGeom prst="rect">
             <a:avLst/>
@@ -4846,11 +4846,11 @@
               </a:lnSpc>
             </a:pPr>
             <a:r>
-              <a:rPr sz="1000" b="1" i="0">
+              <a:rPr sz="1200" b="1" i="0">
                 <a:solidFill>
                   <a:srgbClr val="2B2B2B"/>
                 </a:solidFill>
-                <a:latin typeface="Comic Sans MS"/>
+                <a:latin typeface="Times New Roman"/>
               </a:rPr>
               <a:t>3 difficulty levels</a:t>
             </a:r>
@@ -4862,7 +4862,7 @@
               </a:lnSpc>
             </a:pPr>
             <a:r>
-              <a:rPr sz="850" b="0" i="0">
+              <a:rPr sz="1050" b="0" i="0">
                 <a:solidFill>
                   <a:srgbClr val="5F5F5F"/>
                 </a:solidFill>
@@ -4881,7 +4881,7 @@
         </p:nvCxnSpPr>
         <p:spPr>
           <a:xfrm>
-            <a:off x="7552944" y="1289304"/>
+            <a:off x="7552944" y="1417320"/>
             <a:ext cx="164592" cy="0"/>
           </a:xfrm>
           <a:prstGeom prst="line">
@@ -4919,7 +4919,7 @@
         <p:spPr>
           <a:xfrm>
             <a:off x="7735824" y="566928"/>
-            <a:ext cx="2139696" cy="1444752"/>
+            <a:ext cx="2139696" cy="1700784"/>
           </a:xfrm>
           <a:prstGeom prst="roundRect">
             <a:avLst>
@@ -5059,7 +5059,7 @@
         <p:spPr>
           <a:xfrm>
             <a:off x="7808976" y="950976"/>
-            <a:ext cx="1993391" cy="320040"/>
+            <a:ext cx="1993391" cy="402336"/>
           </a:xfrm>
           <a:prstGeom prst="roundRect">
             <a:avLst>
@@ -5110,8 +5110,8 @@
         </p:blipFill>
         <p:spPr>
           <a:xfrm>
-            <a:off x="7854696" y="987552"/>
-            <a:ext cx="246888" cy="246888"/>
+            <a:off x="7854696" y="1014984"/>
+            <a:ext cx="256032" cy="256032"/>
           </a:xfrm>
           <a:prstGeom prst="rect">
             <a:avLst/>
@@ -5126,8 +5126,8 @@
         </p:nvSpPr>
         <p:spPr>
           <a:xfrm>
-            <a:off x="8156448" y="950976"/>
-            <a:ext cx="1627631" cy="320040"/>
+            <a:off x="8174736" y="950976"/>
+            <a:ext cx="1609343" cy="402336"/>
           </a:xfrm>
           <a:prstGeom prst="rect">
             <a:avLst/>
@@ -5146,11 +5146,11 @@
               </a:lnSpc>
             </a:pPr>
             <a:r>
-              <a:rPr sz="1000" b="1" i="0">
+              <a:rPr sz="1200" b="1" i="0">
                 <a:solidFill>
                   <a:srgbClr val="2B2B2B"/>
                 </a:solidFill>
-                <a:latin typeface="Comic Sans MS"/>
+                <a:latin typeface="Times New Roman"/>
               </a:rPr>
               <a:t>Plan</a:t>
             </a:r>
@@ -5162,13 +5162,13 @@
               </a:lnSpc>
             </a:pPr>
             <a:r>
-              <a:rPr sz="850" b="0" i="0">
+              <a:rPr sz="1050" b="0" i="0">
                 <a:solidFill>
                   <a:srgbClr val="5F5F5F"/>
                 </a:solidFill>
                 <a:latin typeface="Comic Sans MS"/>
               </a:rPr>
-              <a:t>rule, null, tail, test, floor</a:t>
+              <a:t>rule, null, test, floor</a:t>
             </a:r>
           </a:p>
         </p:txBody>
@@ -5181,8 +5181,8 @@
         </p:nvSpPr>
         <p:spPr>
           <a:xfrm>
-            <a:off x="7808976" y="1298448"/>
-            <a:ext cx="1993391" cy="320040"/>
+            <a:off x="7808976" y="1380744"/>
+            <a:ext cx="1993391" cy="402336"/>
           </a:xfrm>
           <a:prstGeom prst="roundRect">
             <a:avLst>
@@ -5233,8 +5233,8 @@
         </p:blipFill>
         <p:spPr>
           <a:xfrm>
-            <a:off x="7854696" y="1335024"/>
-            <a:ext cx="246888" cy="246888"/>
+            <a:off x="7854696" y="1444752"/>
+            <a:ext cx="256032" cy="256032"/>
           </a:xfrm>
           <a:prstGeom prst="rect">
             <a:avLst/>
@@ -5249,8 +5249,8 @@
         </p:nvSpPr>
         <p:spPr>
           <a:xfrm>
-            <a:off x="8156448" y="1298448"/>
-            <a:ext cx="1627631" cy="320040"/>
+            <a:off x="8174736" y="1380744"/>
+            <a:ext cx="1609343" cy="402336"/>
           </a:xfrm>
           <a:prstGeom prst="rect">
             <a:avLst/>
@@ -5269,11 +5269,11 @@
               </a:lnSpc>
             </a:pPr>
             <a:r>
-              <a:rPr sz="1000" b="1" i="0">
+              <a:rPr sz="1200" b="1" i="0">
                 <a:solidFill>
                   <a:srgbClr val="2B2B2B"/>
                 </a:solidFill>
-                <a:latin typeface="Comic Sans MS"/>
+                <a:latin typeface="Times New Roman"/>
               </a:rPr>
               <a:t>Evidence</a:t>
             </a:r>
@@ -5285,7 +5285,7 @@
               </a:lnSpc>
             </a:pPr>
             <a:r>
-              <a:rPr sz="850" b="0" i="0">
+              <a:rPr sz="1050" b="0" i="0">
                 <a:solidFill>
                   <a:srgbClr val="5F5F5F"/>
                 </a:solidFill>
@@ -5304,8 +5304,8 @@
         </p:nvSpPr>
         <p:spPr>
           <a:xfrm>
-            <a:off x="7808976" y="1645920"/>
-            <a:ext cx="1993391" cy="320040"/>
+            <a:off x="7808976" y="1810512"/>
+            <a:ext cx="1993391" cy="402336"/>
           </a:xfrm>
           <a:prstGeom prst="roundRect">
             <a:avLst>
@@ -5356,8 +5356,8 @@
         </p:blipFill>
         <p:spPr>
           <a:xfrm>
-            <a:off x="7854696" y="1682496"/>
-            <a:ext cx="246888" cy="246888"/>
+            <a:off x="7854696" y="1874519"/>
+            <a:ext cx="256032" cy="256032"/>
           </a:xfrm>
           <a:prstGeom prst="rect">
             <a:avLst/>
@@ -5372,8 +5372,8 @@
         </p:nvSpPr>
         <p:spPr>
           <a:xfrm>
-            <a:off x="8156448" y="1645920"/>
-            <a:ext cx="1627631" cy="320040"/>
+            <a:off x="8174736" y="1810512"/>
+            <a:ext cx="1609343" cy="402336"/>
           </a:xfrm>
           <a:prstGeom prst="rect">
             <a:avLst/>
@@ -5392,11 +5392,11 @@
               </a:lnSpc>
             </a:pPr>
             <a:r>
-              <a:rPr sz="1000" b="1" i="0">
+              <a:rPr sz="1200" b="1" i="0">
                 <a:solidFill>
                   <a:srgbClr val="2B2B2B"/>
                 </a:solidFill>
-                <a:latin typeface="Comic Sans MS"/>
+                <a:latin typeface="Times New Roman"/>
               </a:rPr>
               <a:t>Statistics, verdict</a:t>
             </a:r>
@@ -5408,7 +5408,7 @@
               </a:lnSpc>
             </a:pPr>
             <a:r>
-              <a:rPr sz="850" b="0" i="0">
+              <a:rPr sz="1050" b="0" i="0">
                 <a:solidFill>
                   <a:srgbClr val="5F5F5F"/>
                 </a:solidFill>
@@ -5427,8 +5427,8 @@
         </p:nvSpPr>
         <p:spPr>
           <a:xfrm>
-            <a:off x="91440" y="2157984"/>
-            <a:ext cx="9875520" cy="2633472"/>
+            <a:off x="91440" y="2432304"/>
+            <a:ext cx="9875520" cy="3118104"/>
           </a:xfrm>
           <a:prstGeom prst="roundRect">
             <a:avLst>
@@ -5471,7 +5471,7 @@
         </p:nvSpPr>
         <p:spPr>
           <a:xfrm>
-            <a:off x="237744" y="2203703"/>
+            <a:off x="237744" y="2478024"/>
             <a:ext cx="420624" cy="420624"/>
           </a:xfrm>
           <a:prstGeom prst="ellipse">
@@ -5524,7 +5524,7 @@
         </p:nvSpPr>
         <p:spPr>
           <a:xfrm>
-            <a:off x="731520" y="2176272"/>
+            <a:off x="731520" y="2450592"/>
             <a:ext cx="6400800" cy="475488"/>
           </a:xfrm>
           <a:prstGeom prst="rect">
@@ -5563,8 +5563,8 @@
         </p:nvSpPr>
         <p:spPr>
           <a:xfrm>
-            <a:off x="182880" y="2615184"/>
-            <a:ext cx="1371600" cy="1481328"/>
+            <a:off x="182880" y="2889504"/>
+            <a:ext cx="1371600" cy="1874519"/>
           </a:xfrm>
           <a:prstGeom prst="roundRect">
             <a:avLst>
@@ -5609,7 +5609,7 @@
         </p:nvSpPr>
         <p:spPr>
           <a:xfrm>
-            <a:off x="237744" y="2651760"/>
+            <a:off x="237744" y="2926080"/>
             <a:ext cx="1261872" cy="274320"/>
           </a:xfrm>
           <a:prstGeom prst="rect">
@@ -5656,7 +5656,7 @@
         </p:blipFill>
         <p:spPr>
           <a:xfrm>
-            <a:off x="256032" y="3017520"/>
+            <a:off x="256032" y="3346704"/>
             <a:ext cx="274320" cy="274320"/>
           </a:xfrm>
           <a:prstGeom prst="rect">
@@ -5672,7 +5672,7 @@
         </p:nvSpPr>
         <p:spPr>
           <a:xfrm>
-            <a:off x="585216" y="2999232"/>
+            <a:off x="585216" y="3328416"/>
             <a:ext cx="914400" cy="310896"/>
           </a:xfrm>
           <a:prstGeom prst="rect">
@@ -5692,7 +5692,7 @@
               </a:lnSpc>
             </a:pPr>
             <a:r>
-              <a:rPr sz="1000" b="0" i="0">
+              <a:rPr sz="1200" b="0" i="0">
                 <a:solidFill>
                   <a:srgbClr val="2B2B2B"/>
                 </a:solidFill>
@@ -5719,7 +5719,7 @@
         </p:blipFill>
         <p:spPr>
           <a:xfrm>
-            <a:off x="256032" y="3364991"/>
+            <a:off x="256032" y="3767328"/>
             <a:ext cx="274320" cy="274320"/>
           </a:xfrm>
           <a:prstGeom prst="rect">
@@ -5735,7 +5735,7 @@
         </p:nvSpPr>
         <p:spPr>
           <a:xfrm>
-            <a:off x="585216" y="3346703"/>
+            <a:off x="585216" y="3749040"/>
             <a:ext cx="914400" cy="310896"/>
           </a:xfrm>
           <a:prstGeom prst="rect">
@@ -5755,7 +5755,7 @@
               </a:lnSpc>
             </a:pPr>
             <a:r>
-              <a:rPr sz="1000" b="0" i="0">
+              <a:rPr sz="1200" b="0" i="0">
                 <a:solidFill>
                   <a:srgbClr val="2B2B2B"/>
                 </a:solidFill>
@@ -5782,7 +5782,7 @@
         </p:blipFill>
         <p:spPr>
           <a:xfrm>
-            <a:off x="256032" y="3712463"/>
+            <a:off x="256032" y="4187952"/>
             <a:ext cx="274320" cy="274320"/>
           </a:xfrm>
           <a:prstGeom prst="rect">
@@ -5798,7 +5798,7 @@
         </p:nvSpPr>
         <p:spPr>
           <a:xfrm>
-            <a:off x="585216" y="3694176"/>
+            <a:off x="585216" y="4169664"/>
             <a:ext cx="914400" cy="310896"/>
           </a:xfrm>
           <a:prstGeom prst="rect">
@@ -5818,7 +5818,7 @@
               </a:lnSpc>
             </a:pPr>
             <a:r>
-              <a:rPr sz="1000" b="0" i="0">
+              <a:rPr sz="1200" b="0" i="0">
                 <a:solidFill>
                   <a:srgbClr val="2B2B2B"/>
                 </a:solidFill>
@@ -5837,7 +5837,7 @@
         </p:nvCxnSpPr>
         <p:spPr>
           <a:xfrm>
-            <a:off x="1572768" y="3355848"/>
+            <a:off x="1572768" y="3826764"/>
             <a:ext cx="164592" cy="0"/>
           </a:xfrm>
           <a:prstGeom prst="line">
@@ -5874,8 +5874,8 @@
         </p:nvSpPr>
         <p:spPr>
           <a:xfrm>
-            <a:off x="1755648" y="2615184"/>
-            <a:ext cx="3657600" cy="1481328"/>
+            <a:off x="1755648" y="2889504"/>
+            <a:ext cx="3657600" cy="1874519"/>
           </a:xfrm>
           <a:prstGeom prst="roundRect">
             <a:avLst>
@@ -5918,7 +5918,7 @@
         </p:nvSpPr>
         <p:spPr>
           <a:xfrm>
-            <a:off x="1828800" y="2679191"/>
+            <a:off x="1828800" y="2953512"/>
             <a:ext cx="420624" cy="420624"/>
           </a:xfrm>
           <a:prstGeom prst="ellipse">
@@ -5983,7 +5983,7 @@
         </p:nvSpPr>
         <p:spPr>
           <a:xfrm>
-            <a:off x="2322576" y="2651760"/>
+            <a:off x="2322576" y="2926080"/>
             <a:ext cx="3035808" cy="475488"/>
           </a:xfrm>
           <a:prstGeom prst="rect">
@@ -6019,7 +6019,7 @@
               </a:lnSpc>
             </a:pPr>
             <a:r>
-              <a:rPr sz="900" b="0" i="0">
+              <a:rPr sz="1100" b="0" i="0">
                 <a:solidFill>
                   <a:srgbClr val="5F5F5F"/>
                 </a:solidFill>
@@ -6038,8 +6038,8 @@
         </p:nvSpPr>
         <p:spPr>
           <a:xfrm>
-            <a:off x="1828800" y="3182112"/>
-            <a:ext cx="836675" cy="566928"/>
+            <a:off x="1828800" y="3456432"/>
+            <a:ext cx="1719072" cy="457200"/>
           </a:xfrm>
           <a:prstGeom prst="roundRect">
             <a:avLst>
@@ -6082,8 +6082,8 @@
         </p:nvSpPr>
         <p:spPr>
           <a:xfrm>
-            <a:off x="1865376" y="3236976"/>
-            <a:ext cx="182880" cy="182880"/>
+            <a:off x="1883664" y="3584448"/>
+            <a:ext cx="201168" cy="201168"/>
           </a:xfrm>
           <a:prstGeom prst="ellipse">
             <a:avLst/>
@@ -6135,8 +6135,8 @@
         </p:nvSpPr>
         <p:spPr>
           <a:xfrm>
-            <a:off x="2057400" y="3204972"/>
-            <a:ext cx="598931" cy="237744"/>
+            <a:off x="2139696" y="3456432"/>
+            <a:ext cx="1389888" cy="457200"/>
           </a:xfrm>
           <a:prstGeom prst="rect">
             <a:avLst/>
@@ -6151,52 +6151,29 @@
           <a:p>
             <a:pPr algn="l">
               <a:lnSpc>
-                <a:spcPct val="100000"/>
+                <a:spcPct val="85000"/>
               </a:lnSpc>
             </a:pPr>
             <a:r>
-              <a:rPr sz="1000" b="1" i="0">
+              <a:rPr sz="1200" b="1" i="0">
                 <a:solidFill>
                   <a:srgbClr val="2B2B2B"/>
                 </a:solidFill>
-                <a:latin typeface="Comic Sans MS"/>
+                <a:latin typeface="Times New Roman"/>
               </a:rPr>
               <a:t>Parse</a:t>
             </a:r>
           </a:p>
-        </p:txBody>
-      </p:sp>
-      <p:sp>
-        <p:nvSpPr>
-          <p:cNvPr id="68" name="TextBox 67"/>
-          <p:cNvSpPr txBox="1"/>
-          <p:nvPr/>
-        </p:nvSpPr>
-        <p:spPr>
-          <a:xfrm>
-            <a:off x="1874519" y="3456432"/>
-            <a:ext cx="763524" cy="274320"/>
-          </a:xfrm>
-          <a:prstGeom prst="rect">
-            <a:avLst/>
-          </a:prstGeom>
-          <a:noFill/>
-        </p:spPr>
-        <p:txBody>
-          <a:bodyPr wrap="square" lIns="27432" rIns="27432" tIns="9144" bIns="9144" anchor="t">
-            <a:spAutoFit/>
-          </a:bodyPr>
-          <a:lstStyle/>
           <a:p>
             <a:pPr algn="l">
               <a:lnSpc>
-                <a:spcPct val="90000"/>
+                <a:spcPct val="85000"/>
               </a:lnSpc>
             </a:pPr>
             <a:r>
-              <a:rPr sz="900" b="0" i="0">
-                <a:solidFill>
-                  <a:srgbClr val="2B2B2B"/>
+              <a:rPr sz="1100" b="0" i="0">
+                <a:solidFill>
+                  <a:srgbClr val="5F5F5F"/>
                 </a:solidFill>
                 <a:latin typeface="Comic Sans MS"/>
               </a:rPr>
@@ -6207,14 +6184,14 @@
       </p:sp>
       <p:cxnSp>
         <p:nvCxnSpPr>
-          <p:cNvPr id="69" name="Connector 68"/>
+          <p:cNvPr id="68" name="Connector 67"/>
           <p:cNvCxnSpPr/>
           <p:nvPr/>
         </p:nvCxnSpPr>
         <p:spPr>
           <a:xfrm>
-            <a:off x="2665476" y="3465576"/>
-            <a:ext cx="54864" cy="0"/>
+            <a:off x="3547872" y="3685032"/>
+            <a:ext cx="73152" cy="0"/>
           </a:xfrm>
           <a:prstGeom prst="line">
             <a:avLst/>
@@ -6244,14 +6221,14 @@
       </p:cxnSp>
       <p:sp>
         <p:nvSpPr>
-          <p:cNvPr id="70" name="Rounded Rectangle 69"/>
+          <p:cNvPr id="69" name="Rounded Rectangle 68"/>
           <p:cNvSpPr/>
           <p:nvPr/>
         </p:nvSpPr>
         <p:spPr>
           <a:xfrm>
-            <a:off x="2720339" y="3182112"/>
-            <a:ext cx="836675" cy="566928"/>
+            <a:off x="3621024" y="3456432"/>
+            <a:ext cx="1719072" cy="457200"/>
           </a:xfrm>
           <a:prstGeom prst="roundRect">
             <a:avLst>
@@ -6288,14 +6265,14 @@
       </p:sp>
       <p:sp>
         <p:nvSpPr>
-          <p:cNvPr id="71" name="Oval 70"/>
+          <p:cNvPr id="70" name="Oval 69"/>
           <p:cNvSpPr/>
           <p:nvPr/>
         </p:nvSpPr>
         <p:spPr>
           <a:xfrm>
-            <a:off x="2756915" y="3236976"/>
-            <a:ext cx="182880" cy="182880"/>
+            <a:off x="3675887" y="3584448"/>
+            <a:ext cx="201168" cy="201168"/>
           </a:xfrm>
           <a:prstGeom prst="ellipse">
             <a:avLst/>
@@ -6341,14 +6318,14 @@
       </p:sp>
       <p:sp>
         <p:nvSpPr>
-          <p:cNvPr id="72" name="TextBox 71"/>
+          <p:cNvPr id="71" name="TextBox 70"/>
           <p:cNvSpPr txBox="1"/>
           <p:nvPr/>
         </p:nvSpPr>
         <p:spPr>
           <a:xfrm>
-            <a:off x="2948939" y="3204972"/>
-            <a:ext cx="598931" cy="237744"/>
+            <a:off x="3931920" y="3456432"/>
+            <a:ext cx="1389888" cy="457200"/>
           </a:xfrm>
           <a:prstGeom prst="rect">
             <a:avLst/>
@@ -6363,52 +6340,29 @@
           <a:p>
             <a:pPr algn="l">
               <a:lnSpc>
-                <a:spcPct val="100000"/>
+                <a:spcPct val="85000"/>
               </a:lnSpc>
             </a:pPr>
             <a:r>
-              <a:rPr sz="1000" b="1" i="0">
+              <a:rPr sz="1200" b="1" i="0">
                 <a:solidFill>
                   <a:srgbClr val="2B2B2B"/>
                 </a:solidFill>
-                <a:latin typeface="Comic Sans MS"/>
+                <a:latin typeface="Times New Roman"/>
               </a:rPr>
               <a:t>Primitive</a:t>
             </a:r>
           </a:p>
-        </p:txBody>
-      </p:sp>
-      <p:sp>
-        <p:nvSpPr>
-          <p:cNvPr id="73" name="TextBox 72"/>
-          <p:cNvSpPr txBox="1"/>
-          <p:nvPr/>
-        </p:nvSpPr>
-        <p:spPr>
-          <a:xfrm>
-            <a:off x="2766059" y="3456432"/>
-            <a:ext cx="763524" cy="274320"/>
-          </a:xfrm>
-          <a:prstGeom prst="rect">
-            <a:avLst/>
-          </a:prstGeom>
-          <a:noFill/>
-        </p:spPr>
-        <p:txBody>
-          <a:bodyPr wrap="square" lIns="27432" rIns="27432" tIns="9144" bIns="9144" anchor="t">
-            <a:spAutoFit/>
-          </a:bodyPr>
-          <a:lstStyle/>
           <a:p>
             <a:pPr algn="l">
               <a:lnSpc>
-                <a:spcPct val="90000"/>
+                <a:spcPct val="85000"/>
               </a:lnSpc>
             </a:pPr>
             <a:r>
-              <a:rPr sz="900" b="0" i="0">
-                <a:solidFill>
-                  <a:srgbClr val="2B2B2B"/>
+              <a:rPr sz="1100" b="0" i="0">
+                <a:solidFill>
+                  <a:srgbClr val="5F5F5F"/>
                 </a:solidFill>
                 <a:latin typeface="Comic Sans MS"/>
               </a:rPr>
@@ -6417,16 +6371,168 @@
           </a:p>
         </p:txBody>
       </p:sp>
+      <p:sp>
+        <p:nvSpPr>
+          <p:cNvPr id="72" name="Rounded Rectangle 71"/>
+          <p:cNvSpPr/>
+          <p:nvPr/>
+        </p:nvSpPr>
+        <p:spPr>
+          <a:xfrm>
+            <a:off x="1828800" y="3968496"/>
+            <a:ext cx="1719072" cy="457200"/>
+          </a:xfrm>
+          <a:prstGeom prst="roundRect">
+            <a:avLst>
+              <a:gd name="adj" fmla="val 10000"/>
+            </a:avLst>
+          </a:prstGeom>
+          <a:solidFill>
+            <a:srgbClr val="FFFFFF"/>
+          </a:solidFill>
+          <a:ln>
+            <a:noFill/>
+          </a:ln>
+          <a:effectLst/>
+        </p:spPr>
+        <p:style>
+          <a:lnRef idx="1">
+            <a:schemeClr val="accent1"/>
+          </a:lnRef>
+          <a:fillRef idx="3">
+            <a:schemeClr val="accent1"/>
+          </a:fillRef>
+          <a:effectRef idx="0">
+            <a:schemeClr val="accent1"/>
+          </a:effectRef>
+          <a:fontRef idx="minor">
+            <a:schemeClr val="lt1"/>
+          </a:fontRef>
+        </p:style>
+        <p:txBody>
+          <a:bodyPr rtlCol="0" anchor="ctr"/>
+          <a:lstStyle/>
+          <a:p/>
+        </p:txBody>
+      </p:sp>
+      <p:sp>
+        <p:nvSpPr>
+          <p:cNvPr id="73" name="Oval 72"/>
+          <p:cNvSpPr/>
+          <p:nvPr/>
+        </p:nvSpPr>
+        <p:spPr>
+          <a:xfrm>
+            <a:off x="1883664" y="4096511"/>
+            <a:ext cx="201168" cy="201168"/>
+          </a:xfrm>
+          <a:prstGeom prst="ellipse">
+            <a:avLst/>
+          </a:prstGeom>
+          <a:solidFill>
+            <a:srgbClr val="4F6B75"/>
+          </a:solidFill>
+          <a:ln>
+            <a:noFill/>
+          </a:ln>
+          <a:effectLst/>
+        </p:spPr>
+        <p:style>
+          <a:lnRef idx="1">
+            <a:schemeClr val="accent1"/>
+          </a:lnRef>
+          <a:fillRef idx="3">
+            <a:schemeClr val="accent1"/>
+          </a:fillRef>
+          <a:effectRef idx="0">
+            <a:schemeClr val="accent1"/>
+          </a:effectRef>
+          <a:fontRef idx="minor">
+            <a:schemeClr val="lt1"/>
+          </a:fontRef>
+        </p:style>
+        <p:txBody>
+          <a:bodyPr rtlCol="0" anchor="ctr" lIns="0" rIns="0" tIns="0" bIns="0"/>
+          <a:lstStyle/>
+          <a:p>
+            <a:pPr algn="ctr"/>
+            <a:r>
+              <a:rPr sz="800" b="1">
+                <a:solidFill>
+                  <a:srgbClr val="FFFFFF"/>
+                </a:solidFill>
+                <a:latin typeface="Comic Sans MS"/>
+              </a:rPr>
+              <a:t>3</a:t>
+            </a:r>
+          </a:p>
+        </p:txBody>
+      </p:sp>
+      <p:sp>
+        <p:nvSpPr>
+          <p:cNvPr id="74" name="TextBox 73"/>
+          <p:cNvSpPr txBox="1"/>
+          <p:nvPr/>
+        </p:nvSpPr>
+        <p:spPr>
+          <a:xfrm>
+            <a:off x="2139696" y="3968496"/>
+            <a:ext cx="1389888" cy="457200"/>
+          </a:xfrm>
+          <a:prstGeom prst="rect">
+            <a:avLst/>
+          </a:prstGeom>
+          <a:noFill/>
+        </p:spPr>
+        <p:txBody>
+          <a:bodyPr wrap="square" lIns="27432" rIns="27432" tIns="9144" bIns="9144" anchor="ctr">
+            <a:spAutoFit/>
+          </a:bodyPr>
+          <a:lstStyle/>
+          <a:p>
+            <a:pPr algn="l">
+              <a:lnSpc>
+                <a:spcPct val="85000"/>
+              </a:lnSpc>
+            </a:pPr>
+            <a:r>
+              <a:rPr sz="1200" b="1" i="0">
+                <a:solidFill>
+                  <a:srgbClr val="2B2B2B"/>
+                </a:solidFill>
+                <a:latin typeface="Times New Roman"/>
+              </a:rPr>
+              <a:t>Compose</a:t>
+            </a:r>
+          </a:p>
+          <a:p>
+            <a:pPr algn="l">
+              <a:lnSpc>
+                <a:spcPct val="85000"/>
+              </a:lnSpc>
+            </a:pPr>
+            <a:r>
+              <a:rPr sz="1100" b="0" i="0">
+                <a:solidFill>
+                  <a:srgbClr val="5F5F5F"/>
+                </a:solidFill>
+                <a:latin typeface="Comic Sans MS"/>
+              </a:rPr>
+              <a:t>null, p0, test</a:t>
+            </a:r>
+          </a:p>
+        </p:txBody>
+      </p:sp>
       <p:cxnSp>
         <p:nvCxnSpPr>
-          <p:cNvPr id="74" name="Connector 73"/>
+          <p:cNvPr id="75" name="Connector 74"/>
           <p:cNvCxnSpPr/>
           <p:nvPr/>
         </p:nvCxnSpPr>
         <p:spPr>
           <a:xfrm>
-            <a:off x="3557015" y="3465576"/>
-            <a:ext cx="54864" cy="0"/>
+            <a:off x="3547872" y="4197096"/>
+            <a:ext cx="73152" cy="0"/>
           </a:xfrm>
           <a:prstGeom prst="line">
             <a:avLst/>
@@ -6456,14 +6562,14 @@
       </p:cxnSp>
       <p:sp>
         <p:nvSpPr>
-          <p:cNvPr id="75" name="Rounded Rectangle 74"/>
+          <p:cNvPr id="76" name="Rounded Rectangle 75"/>
           <p:cNvSpPr/>
           <p:nvPr/>
         </p:nvSpPr>
         <p:spPr>
           <a:xfrm>
-            <a:off x="3611879" y="3182112"/>
-            <a:ext cx="836675" cy="566928"/>
+            <a:off x="3621024" y="3968496"/>
+            <a:ext cx="1719072" cy="457200"/>
           </a:xfrm>
           <a:prstGeom prst="roundRect">
             <a:avLst>
@@ -6500,14 +6606,14 @@
       </p:sp>
       <p:sp>
         <p:nvSpPr>
-          <p:cNvPr id="76" name="Oval 75"/>
+          <p:cNvPr id="77" name="Oval 76"/>
           <p:cNvSpPr/>
           <p:nvPr/>
         </p:nvSpPr>
         <p:spPr>
           <a:xfrm>
-            <a:off x="3648456" y="3236976"/>
-            <a:ext cx="182880" cy="182880"/>
+            <a:off x="3675887" y="4096511"/>
+            <a:ext cx="201168" cy="201168"/>
           </a:xfrm>
           <a:prstGeom prst="ellipse">
             <a:avLst/>
@@ -6546,21 +6652,21 @@
                 </a:solidFill>
                 <a:latin typeface="Comic Sans MS"/>
               </a:rPr>
-              <a:t>3</a:t>
-            </a:r>
-          </a:p>
-        </p:txBody>
-      </p:sp>
-      <p:sp>
-        <p:nvSpPr>
-          <p:cNvPr id="77" name="TextBox 76"/>
+              <a:t>4</a:t>
+            </a:r>
+          </a:p>
+        </p:txBody>
+      </p:sp>
+      <p:sp>
+        <p:nvSpPr>
+          <p:cNvPr id="78" name="TextBox 77"/>
           <p:cNvSpPr txBox="1"/>
           <p:nvPr/>
         </p:nvSpPr>
         <p:spPr>
           <a:xfrm>
-            <a:off x="3840479" y="3204972"/>
-            <a:ext cx="598931" cy="237744"/>
+            <a:off x="3931920" y="3968496"/>
+            <a:ext cx="1389888" cy="457200"/>
           </a:xfrm>
           <a:prstGeom prst="rect">
             <a:avLst/>
@@ -6575,282 +6681,47 @@
           <a:p>
             <a:pPr algn="l">
               <a:lnSpc>
-                <a:spcPct val="100000"/>
+                <a:spcPct val="85000"/>
               </a:lnSpc>
             </a:pPr>
             <a:r>
-              <a:rPr sz="1000" b="1" i="0">
+              <a:rPr sz="1200" b="1" i="0">
                 <a:solidFill>
                   <a:srgbClr val="2B2B2B"/>
+                </a:solidFill>
+                <a:latin typeface="Times New Roman"/>
+              </a:rPr>
+              <a:t>Verify</a:t>
+            </a:r>
+          </a:p>
+          <a:p>
+            <a:pPr algn="l">
+              <a:lnSpc>
+                <a:spcPct val="85000"/>
+              </a:lnSpc>
+            </a:pPr>
+            <a:r>
+              <a:rPr sz="1100" b="0" i="0">
+                <a:solidFill>
+                  <a:srgbClr val="5F5F5F"/>
                 </a:solidFill>
                 <a:latin typeface="Comic Sans MS"/>
               </a:rPr>
-              <a:t>Compose</a:t>
-            </a:r>
-          </a:p>
-        </p:txBody>
-      </p:sp>
-      <p:sp>
-        <p:nvSpPr>
-          <p:cNvPr id="78" name="TextBox 77"/>
-          <p:cNvSpPr txBox="1"/>
-          <p:nvPr/>
-        </p:nvSpPr>
-        <p:spPr>
-          <a:xfrm>
-            <a:off x="3657599" y="3456432"/>
-            <a:ext cx="763524" cy="274320"/>
-          </a:xfrm>
-          <a:prstGeom prst="rect">
-            <a:avLst/>
-          </a:prstGeom>
-          <a:noFill/>
-        </p:spPr>
-        <p:txBody>
-          <a:bodyPr wrap="square" lIns="27432" rIns="27432" tIns="9144" bIns="9144" anchor="t">
-            <a:spAutoFit/>
-          </a:bodyPr>
-          <a:lstStyle/>
-          <a:p>
-            <a:pPr algn="l">
-              <a:lnSpc>
-                <a:spcPct val="90000"/>
-              </a:lnSpc>
-            </a:pPr>
-            <a:r>
-              <a:rPr sz="900" b="0" i="0">
-                <a:solidFill>
-                  <a:srgbClr val="2B2B2B"/>
-                </a:solidFill>
-                <a:latin typeface="Comic Sans MS"/>
-              </a:rPr>
-              <a:t>null, p0, test</a:t>
-            </a:r>
-          </a:p>
-        </p:txBody>
-      </p:sp>
-      <p:cxnSp>
-        <p:nvCxnSpPr>
-          <p:cNvPr id="79" name="Connector 78"/>
-          <p:cNvCxnSpPr/>
-          <p:nvPr/>
-        </p:nvCxnSpPr>
-        <p:spPr>
-          <a:xfrm>
-            <a:off x="4448555" y="3465576"/>
-            <a:ext cx="54864" cy="0"/>
-          </a:xfrm>
-          <a:prstGeom prst="line">
-            <a:avLst/>
-          </a:prstGeom>
-          <a:ln w="12700">
-            <a:solidFill>
-              <a:srgbClr val="5F5F5F"/>
-            </a:solidFill>
-            <a:tailEnd type="triangle" w="med" len="med"/>
-          </a:ln>
-          <a:effectLst/>
-        </p:spPr>
-        <p:style>
-          <a:lnRef idx="2">
-            <a:schemeClr val="accent1"/>
-          </a:lnRef>
-          <a:fillRef idx="0">
-            <a:schemeClr val="accent1"/>
-          </a:fillRef>
-          <a:effectRef idx="0">
-            <a:schemeClr val="accent1"/>
-          </a:effectRef>
-          <a:fontRef idx="minor">
-            <a:schemeClr val="tx1"/>
-          </a:fontRef>
-        </p:style>
-      </p:cxnSp>
-      <p:sp>
-        <p:nvSpPr>
-          <p:cNvPr id="80" name="Rounded Rectangle 79"/>
+              <a:t>one round</a:t>
+            </a:r>
+          </a:p>
+        </p:txBody>
+      </p:sp>
+      <p:sp>
+        <p:nvSpPr>
+          <p:cNvPr id="79" name="Rounded Rectangle 78"/>
           <p:cNvSpPr/>
           <p:nvPr/>
         </p:nvSpPr>
         <p:spPr>
           <a:xfrm>
-            <a:off x="4503420" y="3182112"/>
-            <a:ext cx="836675" cy="566928"/>
-          </a:xfrm>
-          <a:prstGeom prst="roundRect">
-            <a:avLst>
-              <a:gd name="adj" fmla="val 10000"/>
-            </a:avLst>
-          </a:prstGeom>
-          <a:solidFill>
-            <a:srgbClr val="FFFFFF"/>
-          </a:solidFill>
-          <a:ln>
-            <a:noFill/>
-          </a:ln>
-          <a:effectLst/>
-        </p:spPr>
-        <p:style>
-          <a:lnRef idx="1">
-            <a:schemeClr val="accent1"/>
-          </a:lnRef>
-          <a:fillRef idx="3">
-            <a:schemeClr val="accent1"/>
-          </a:fillRef>
-          <a:effectRef idx="0">
-            <a:schemeClr val="accent1"/>
-          </a:effectRef>
-          <a:fontRef idx="minor">
-            <a:schemeClr val="lt1"/>
-          </a:fontRef>
-        </p:style>
-        <p:txBody>
-          <a:bodyPr rtlCol="0" anchor="ctr"/>
-          <a:lstStyle/>
-          <a:p/>
-        </p:txBody>
-      </p:sp>
-      <p:sp>
-        <p:nvSpPr>
-          <p:cNvPr id="81" name="Oval 80"/>
-          <p:cNvSpPr/>
-          <p:nvPr/>
-        </p:nvSpPr>
-        <p:spPr>
-          <a:xfrm>
-            <a:off x="4539996" y="3236976"/>
-            <a:ext cx="182880" cy="182880"/>
-          </a:xfrm>
-          <a:prstGeom prst="ellipse">
-            <a:avLst/>
-          </a:prstGeom>
-          <a:solidFill>
-            <a:srgbClr val="4F6B75"/>
-          </a:solidFill>
-          <a:ln>
-            <a:noFill/>
-          </a:ln>
-          <a:effectLst/>
-        </p:spPr>
-        <p:style>
-          <a:lnRef idx="1">
-            <a:schemeClr val="accent1"/>
-          </a:lnRef>
-          <a:fillRef idx="3">
-            <a:schemeClr val="accent1"/>
-          </a:fillRef>
-          <a:effectRef idx="0">
-            <a:schemeClr val="accent1"/>
-          </a:effectRef>
-          <a:fontRef idx="minor">
-            <a:schemeClr val="lt1"/>
-          </a:fontRef>
-        </p:style>
-        <p:txBody>
-          <a:bodyPr rtlCol="0" anchor="ctr" lIns="0" rIns="0" tIns="0" bIns="0"/>
-          <a:lstStyle/>
-          <a:p>
-            <a:pPr algn="ctr"/>
-            <a:r>
-              <a:rPr sz="800" b="1">
-                <a:solidFill>
-                  <a:srgbClr val="FFFFFF"/>
-                </a:solidFill>
-                <a:latin typeface="Comic Sans MS"/>
-              </a:rPr>
-              <a:t>4</a:t>
-            </a:r>
-          </a:p>
-        </p:txBody>
-      </p:sp>
-      <p:sp>
-        <p:nvSpPr>
-          <p:cNvPr id="82" name="TextBox 81"/>
-          <p:cNvSpPr txBox="1"/>
-          <p:nvPr/>
-        </p:nvSpPr>
-        <p:spPr>
-          <a:xfrm>
-            <a:off x="4732020" y="3204972"/>
-            <a:ext cx="598931" cy="237744"/>
-          </a:xfrm>
-          <a:prstGeom prst="rect">
-            <a:avLst/>
-          </a:prstGeom>
-          <a:noFill/>
-        </p:spPr>
-        <p:txBody>
-          <a:bodyPr wrap="square" lIns="27432" rIns="27432" tIns="9144" bIns="9144" anchor="ctr">
-            <a:spAutoFit/>
-          </a:bodyPr>
-          <a:lstStyle/>
-          <a:p>
-            <a:pPr algn="l">
-              <a:lnSpc>
-                <a:spcPct val="100000"/>
-              </a:lnSpc>
-            </a:pPr>
-            <a:r>
-              <a:rPr sz="1000" b="1" i="0">
-                <a:solidFill>
-                  <a:srgbClr val="2B2B2B"/>
-                </a:solidFill>
-                <a:latin typeface="Comic Sans MS"/>
-              </a:rPr>
-              <a:t>Verify</a:t>
-            </a:r>
-          </a:p>
-        </p:txBody>
-      </p:sp>
-      <p:sp>
-        <p:nvSpPr>
-          <p:cNvPr id="83" name="TextBox 82"/>
-          <p:cNvSpPr txBox="1"/>
-          <p:nvPr/>
-        </p:nvSpPr>
-        <p:spPr>
-          <a:xfrm>
-            <a:off x="4549140" y="3456432"/>
-            <a:ext cx="763524" cy="274320"/>
-          </a:xfrm>
-          <a:prstGeom prst="rect">
-            <a:avLst/>
-          </a:prstGeom>
-          <a:noFill/>
-        </p:spPr>
-        <p:txBody>
-          <a:bodyPr wrap="square" lIns="27432" rIns="27432" tIns="9144" bIns="9144" anchor="t">
-            <a:spAutoFit/>
-          </a:bodyPr>
-          <a:lstStyle/>
-          <a:p>
-            <a:pPr algn="l">
-              <a:lnSpc>
-                <a:spcPct val="90000"/>
-              </a:lnSpc>
-            </a:pPr>
-            <a:r>
-              <a:rPr sz="900" b="0" i="0">
-                <a:solidFill>
-                  <a:srgbClr val="2B2B2B"/>
-                </a:solidFill>
-                <a:latin typeface="Comic Sans MS"/>
-              </a:rPr>
-              <a:t>1 round</a:t>
-            </a:r>
-          </a:p>
-        </p:txBody>
-      </p:sp>
-      <p:sp>
-        <p:nvSpPr>
-          <p:cNvPr id="84" name="Rounded Rectangle 83"/>
-          <p:cNvSpPr/>
-          <p:nvPr/>
-        </p:nvSpPr>
-        <p:spPr>
-          <a:xfrm>
-            <a:off x="1828800" y="3803904"/>
-            <a:ext cx="3511296" cy="237744"/>
+            <a:off x="1828800" y="4480560"/>
+            <a:ext cx="3511296" cy="246888"/>
           </a:xfrm>
           <a:prstGeom prst="roundRect">
             <a:avLst>
@@ -6889,14 +6760,14 @@
       </p:sp>
       <p:sp>
         <p:nvSpPr>
-          <p:cNvPr id="85" name="TextBox 84"/>
+          <p:cNvPr id="80" name="TextBox 79"/>
           <p:cNvSpPr txBox="1"/>
           <p:nvPr/>
         </p:nvSpPr>
         <p:spPr>
           <a:xfrm>
-            <a:off x="1865376" y="3803904"/>
-            <a:ext cx="3438144" cy="237744"/>
+            <a:off x="1865376" y="4480560"/>
+            <a:ext cx="3438144" cy="246888"/>
           </a:xfrm>
           <a:prstGeom prst="rect">
             <a:avLst/>
@@ -6915,7 +6786,7 @@
               </a:lnSpc>
             </a:pPr>
             <a:r>
-              <a:rPr sz="900" b="1" i="0">
+              <a:rPr sz="1100" b="1" i="0">
                 <a:solidFill>
                   <a:srgbClr val="A0522D"/>
                 </a:solidFill>
@@ -6924,26 +6795,26 @@
               <a:t>Contract: </a:t>
             </a:r>
             <a:r>
-              <a:rPr sz="900" b="0" i="0">
+              <a:rPr sz="1100" b="0" i="0">
                 <a:solidFill>
                   <a:srgbClr val="2B2B2B"/>
                 </a:solidFill>
                 <a:latin typeface="Comic Sans MS"/>
               </a:rPr>
-              <a:t>the harness resolves the primitive into its exact rule</a:t>
+              <a:t>harness expands the primitive to its rule</a:t>
             </a:r>
           </a:p>
         </p:txBody>
       </p:sp>
       <p:cxnSp>
         <p:nvCxnSpPr>
-          <p:cNvPr id="86" name="Connector 85"/>
+          <p:cNvPr id="81" name="Connector 80"/>
           <p:cNvCxnSpPr/>
           <p:nvPr/>
         </p:nvCxnSpPr>
         <p:spPr>
           <a:xfrm>
-            <a:off x="5431536" y="3355848"/>
+            <a:off x="5431536" y="3826764"/>
             <a:ext cx="164592" cy="0"/>
           </a:xfrm>
           <a:prstGeom prst="line">
@@ -6974,14 +6845,14 @@
       </p:cxnSp>
       <p:sp>
         <p:nvSpPr>
-          <p:cNvPr id="87" name="Rounded Rectangle 86"/>
+          <p:cNvPr id="82" name="Rounded Rectangle 81"/>
           <p:cNvSpPr/>
           <p:nvPr/>
         </p:nvSpPr>
         <p:spPr>
           <a:xfrm>
-            <a:off x="5614416" y="2615184"/>
-            <a:ext cx="2286000" cy="1481328"/>
+            <a:off x="5614416" y="2889504"/>
+            <a:ext cx="2286000" cy="1874519"/>
           </a:xfrm>
           <a:prstGeom prst="roundRect">
             <a:avLst>
@@ -7018,13 +6889,13 @@
       </p:sp>
       <p:sp>
         <p:nvSpPr>
-          <p:cNvPr id="88" name="Oval 87"/>
+          <p:cNvPr id="83" name="Oval 82"/>
           <p:cNvSpPr/>
           <p:nvPr/>
         </p:nvSpPr>
         <p:spPr>
           <a:xfrm>
-            <a:off x="5687568" y="2679191"/>
+            <a:off x="5687568" y="2953512"/>
             <a:ext cx="420624" cy="420624"/>
           </a:xfrm>
           <a:prstGeom prst="ellipse">
@@ -7083,13 +6954,13 @@
       </p:sp>
       <p:sp>
         <p:nvSpPr>
-          <p:cNvPr id="89" name="TextBox 88"/>
+          <p:cNvPr id="84" name="TextBox 83"/>
           <p:cNvSpPr txBox="1"/>
           <p:nvPr/>
         </p:nvSpPr>
         <p:spPr>
           <a:xfrm>
-            <a:off x="6181344" y="2651760"/>
+            <a:off x="6181344" y="2926080"/>
             <a:ext cx="1664207" cy="475488"/>
           </a:xfrm>
           <a:prstGeom prst="rect">
@@ -7125,7 +6996,7 @@
               </a:lnSpc>
             </a:pPr>
             <a:r>
-              <a:rPr sz="900" b="0" i="0">
+              <a:rPr sz="1100" b="0" i="0">
                 <a:solidFill>
                   <a:srgbClr val="5F5F5F"/>
                 </a:solidFill>
@@ -7138,7 +7009,7 @@
       </p:sp>
       <p:pic>
         <p:nvPicPr>
-          <p:cNvPr id="90" name="Picture 89" descr="code_A0522D.png"/>
+          <p:cNvPr id="85" name="Picture 84" descr="code_A0522D.png"/>
           <p:cNvPicPr>
             <a:picLocks noChangeAspect="1"/>
           </p:cNvPicPr>
@@ -7152,8 +7023,8 @@
         </p:blipFill>
         <p:spPr>
           <a:xfrm>
-            <a:off x="5705855" y="3218688"/>
-            <a:ext cx="237744" cy="237744"/>
+            <a:off x="5705855" y="3547872"/>
+            <a:ext cx="256032" cy="256032"/>
           </a:xfrm>
           <a:prstGeom prst="rect">
             <a:avLst/>
@@ -7162,14 +7033,14 @@
       </p:pic>
       <p:sp>
         <p:nvSpPr>
-          <p:cNvPr id="91" name="TextBox 90"/>
+          <p:cNvPr id="86" name="TextBox 85"/>
           <p:cNvSpPr txBox="1"/>
           <p:nvPr/>
         </p:nvSpPr>
         <p:spPr>
           <a:xfrm>
-            <a:off x="5998464" y="3200400"/>
-            <a:ext cx="1847088" cy="274320"/>
+            <a:off x="6016752" y="3529584"/>
+            <a:ext cx="1828800" cy="292608"/>
           </a:xfrm>
           <a:prstGeom prst="rect">
             <a:avLst/>
@@ -7188,7 +7059,7 @@
               </a:lnSpc>
             </a:pPr>
             <a:r>
-              <a:rPr sz="900" b="0" i="0">
+              <a:rPr sz="1100" b="0" i="0">
                 <a:solidFill>
                   <a:srgbClr val="2B2B2B"/>
                 </a:solidFill>
@@ -7201,7 +7072,7 @@
       </p:sp>
       <p:pic>
         <p:nvPicPr>
-          <p:cNvPr id="92" name="Picture 91" descr="table-2_A0522D.png"/>
+          <p:cNvPr id="87" name="Picture 86" descr="table-2_A0522D.png"/>
           <p:cNvPicPr>
             <a:picLocks noChangeAspect="1"/>
           </p:cNvPicPr>
@@ -7215,8 +7086,8 @@
         </p:blipFill>
         <p:spPr>
           <a:xfrm>
-            <a:off x="5705855" y="3502152"/>
-            <a:ext cx="237744" cy="237744"/>
+            <a:off x="5705855" y="3931920"/>
+            <a:ext cx="256032" cy="256032"/>
           </a:xfrm>
           <a:prstGeom prst="rect">
             <a:avLst/>
@@ -7225,14 +7096,14 @@
       </p:pic>
       <p:sp>
         <p:nvSpPr>
-          <p:cNvPr id="93" name="TextBox 92"/>
+          <p:cNvPr id="88" name="TextBox 87"/>
           <p:cNvSpPr txBox="1"/>
           <p:nvPr/>
         </p:nvSpPr>
         <p:spPr>
           <a:xfrm>
-            <a:off x="5998464" y="3483864"/>
-            <a:ext cx="1847088" cy="274320"/>
+            <a:off x="6016752" y="3913632"/>
+            <a:ext cx="1828800" cy="292608"/>
           </a:xfrm>
           <a:prstGeom prst="rect">
             <a:avLst/>
@@ -7251,7 +7122,7 @@
               </a:lnSpc>
             </a:pPr>
             <a:r>
-              <a:rPr sz="900" b="0" i="0">
+              <a:rPr sz="1100" b="0" i="0">
                 <a:solidFill>
                   <a:srgbClr val="2B2B2B"/>
                 </a:solidFill>
@@ -7264,7 +7135,7 @@
       </p:sp>
       <p:pic>
         <p:nvPicPr>
-          <p:cNvPr id="94" name="Picture 93" descr="timer-reset_A0522D.png"/>
+          <p:cNvPr id="89" name="Picture 88" descr="timer-reset_A0522D.png"/>
           <p:cNvPicPr>
             <a:picLocks noChangeAspect="1"/>
           </p:cNvPicPr>
@@ -7278,8 +7149,8 @@
         </p:blipFill>
         <p:spPr>
           <a:xfrm>
-            <a:off x="5705855" y="3785615"/>
-            <a:ext cx="237744" cy="237744"/>
+            <a:off x="5705855" y="4315968"/>
+            <a:ext cx="256032" cy="256032"/>
           </a:xfrm>
           <a:prstGeom prst="rect">
             <a:avLst/>
@@ -7288,14 +7159,14 @@
       </p:pic>
       <p:sp>
         <p:nvSpPr>
-          <p:cNvPr id="95" name="TextBox 94"/>
+          <p:cNvPr id="90" name="TextBox 89"/>
           <p:cNvSpPr txBox="1"/>
           <p:nvPr/>
         </p:nvSpPr>
         <p:spPr>
           <a:xfrm>
-            <a:off x="5998464" y="3767328"/>
-            <a:ext cx="1847088" cy="274320"/>
+            <a:off x="6016752" y="4297680"/>
+            <a:ext cx="1828800" cy="292608"/>
           </a:xfrm>
           <a:prstGeom prst="rect">
             <a:avLst/>
@@ -7314,7 +7185,7 @@
               </a:lnSpc>
             </a:pPr>
             <a:r>
-              <a:rPr sz="900" b="0" i="0">
+              <a:rPr sz="1100" b="0" i="0">
                 <a:solidFill>
                   <a:srgbClr val="2B2B2B"/>
                 </a:solidFill>
@@ -7327,13 +7198,13 @@
       </p:sp>
       <p:cxnSp>
         <p:nvCxnSpPr>
-          <p:cNvPr id="96" name="Connector 95"/>
+          <p:cNvPr id="91" name="Connector 90"/>
           <p:cNvCxnSpPr/>
           <p:nvPr/>
         </p:nvCxnSpPr>
         <p:spPr>
           <a:xfrm>
-            <a:off x="7918704" y="3355848"/>
+            <a:off x="7918704" y="3826764"/>
             <a:ext cx="164592" cy="0"/>
           </a:xfrm>
           <a:prstGeom prst="line">
@@ -7364,14 +7235,14 @@
       </p:cxnSp>
       <p:sp>
         <p:nvSpPr>
-          <p:cNvPr id="97" name="Rounded Rectangle 96"/>
+          <p:cNvPr id="92" name="Rounded Rectangle 91"/>
           <p:cNvSpPr/>
           <p:nvPr/>
         </p:nvSpPr>
         <p:spPr>
           <a:xfrm>
-            <a:off x="8101583" y="2615184"/>
-            <a:ext cx="1773936" cy="1481328"/>
+            <a:off x="8101583" y="2889504"/>
+            <a:ext cx="1773936" cy="1874519"/>
           </a:xfrm>
           <a:prstGeom prst="roundRect">
             <a:avLst>
@@ -7408,13 +7279,13 @@
       </p:sp>
       <p:sp>
         <p:nvSpPr>
-          <p:cNvPr id="98" name="Oval 97"/>
+          <p:cNvPr id="93" name="Oval 92"/>
           <p:cNvSpPr/>
           <p:nvPr/>
         </p:nvSpPr>
         <p:spPr>
           <a:xfrm>
-            <a:off x="8174736" y="2679191"/>
+            <a:off x="8174736" y="2953512"/>
             <a:ext cx="420624" cy="420624"/>
           </a:xfrm>
           <a:prstGeom prst="ellipse">
@@ -7473,13 +7344,13 @@
       </p:sp>
       <p:sp>
         <p:nvSpPr>
-          <p:cNvPr id="99" name="TextBox 98"/>
+          <p:cNvPr id="94" name="TextBox 93"/>
           <p:cNvSpPr txBox="1"/>
           <p:nvPr/>
         </p:nvSpPr>
         <p:spPr>
           <a:xfrm>
-            <a:off x="8668511" y="2651760"/>
+            <a:off x="8668511" y="2926080"/>
             <a:ext cx="1152143" cy="475488"/>
           </a:xfrm>
           <a:prstGeom prst="rect">
@@ -7515,27 +7386,27 @@
               </a:lnSpc>
             </a:pPr>
             <a:r>
-              <a:rPr sz="900" b="0" i="0">
+              <a:rPr sz="1100" b="0" i="0">
                 <a:solidFill>
                   <a:srgbClr val="5F5F5F"/>
                 </a:solidFill>
                 <a:latin typeface="Comic Sans MS"/>
               </a:rPr>
-              <a:t>exact, deterministic</a:t>
-            </a:r>
-          </a:p>
-        </p:txBody>
-      </p:sp>
-      <p:sp>
-        <p:nvSpPr>
-          <p:cNvPr id="100" name="TextBox 99"/>
+              <a:t>deterministic</a:t>
+            </a:r>
+          </a:p>
+        </p:txBody>
+      </p:sp>
+      <p:sp>
+        <p:nvSpPr>
+          <p:cNvPr id="95" name="TextBox 94"/>
           <p:cNvSpPr txBox="1"/>
           <p:nvPr/>
         </p:nvSpPr>
         <p:spPr>
           <a:xfrm>
-            <a:off x="8193023" y="3163824"/>
-            <a:ext cx="1627632" cy="384048"/>
+            <a:off x="8193023" y="3438144"/>
+            <a:ext cx="1627632" cy="603504"/>
           </a:xfrm>
           <a:prstGeom prst="rect">
             <a:avLst/>
@@ -7554,7 +7425,7 @@
               </a:lnSpc>
             </a:pPr>
             <a:r>
-              <a:rPr sz="900" b="0" i="0">
+              <a:rPr sz="1100" b="0" i="0">
                 <a:solidFill>
                   <a:srgbClr val="2B2B2B"/>
                 </a:solidFill>
@@ -7567,7 +7438,7 @@
       </p:sp>
       <p:pic>
         <p:nvPicPr>
-          <p:cNvPr id="101" name="Picture 100" descr="circle-check_4F6B75.png"/>
+          <p:cNvPr id="96" name="Picture 95" descr="circle-check_4F6B75.png"/>
           <p:cNvPicPr>
             <a:picLocks noChangeAspect="1"/>
           </p:cNvPicPr>
@@ -7581,8 +7452,8 @@
         </p:blipFill>
         <p:spPr>
           <a:xfrm>
-            <a:off x="8211311" y="3566160"/>
-            <a:ext cx="155448" cy="155448"/>
+            <a:off x="8211311" y="4096512"/>
+            <a:ext cx="173736" cy="173736"/>
           </a:xfrm>
           <a:prstGeom prst="rect">
             <a:avLst/>
@@ -7591,14 +7462,14 @@
       </p:pic>
       <p:sp>
         <p:nvSpPr>
-          <p:cNvPr id="102" name="TextBox 101"/>
+          <p:cNvPr id="97" name="TextBox 96"/>
           <p:cNvSpPr txBox="1"/>
           <p:nvPr/>
         </p:nvSpPr>
         <p:spPr>
           <a:xfrm>
-            <a:off x="8412480" y="3529584"/>
-            <a:ext cx="1408176" cy="219456"/>
+            <a:off x="8430767" y="4059936"/>
+            <a:ext cx="1389888" cy="246888"/>
           </a:xfrm>
           <a:prstGeom prst="rect">
             <a:avLst/>
@@ -7617,7 +7488,7 @@
               </a:lnSpc>
             </a:pPr>
             <a:r>
-              <a:rPr sz="900" b="1" i="0">
+              <a:rPr sz="1100" b="1" i="0">
                 <a:solidFill>
                   <a:srgbClr val="2B2B2B"/>
                 </a:solidFill>
@@ -7630,7 +7501,7 @@
       </p:sp>
       <p:pic>
         <p:nvPicPr>
-          <p:cNvPr id="103" name="Picture 102" descr="circle-x_A0522D.png"/>
+          <p:cNvPr id="98" name="Picture 97" descr="circle-x_A0522D.png"/>
           <p:cNvPicPr>
             <a:picLocks noChangeAspect="1"/>
           </p:cNvPicPr>
@@ -7644,8 +7515,8 @@
         </p:blipFill>
         <p:spPr>
           <a:xfrm>
-            <a:off x="8211311" y="3739896"/>
-            <a:ext cx="155448" cy="155448"/>
+            <a:off x="8211311" y="4315968"/>
+            <a:ext cx="173736" cy="173736"/>
           </a:xfrm>
           <a:prstGeom prst="rect">
             <a:avLst/>
@@ -7654,14 +7525,14 @@
       </p:pic>
       <p:sp>
         <p:nvSpPr>
-          <p:cNvPr id="104" name="TextBox 103"/>
+          <p:cNvPr id="99" name="TextBox 98"/>
           <p:cNvSpPr txBox="1"/>
           <p:nvPr/>
         </p:nvSpPr>
         <p:spPr>
           <a:xfrm>
-            <a:off x="8412480" y="3703320"/>
-            <a:ext cx="1408176" cy="219456"/>
+            <a:off x="8430767" y="4279392"/>
+            <a:ext cx="1389888" cy="246888"/>
           </a:xfrm>
           <a:prstGeom prst="rect">
             <a:avLst/>
@@ -7680,7 +7551,7 @@
               </a:lnSpc>
             </a:pPr>
             <a:r>
-              <a:rPr sz="900" b="1" i="0">
+              <a:rPr sz="1100" b="1" i="0">
                 <a:solidFill>
                   <a:srgbClr val="2B2B2B"/>
                 </a:solidFill>
@@ -7693,7 +7564,7 @@
       </p:sp>
       <p:pic>
         <p:nvPicPr>
-          <p:cNvPr id="105" name="Picture 104" descr="circle-help_A8812E.png"/>
+          <p:cNvPr id="100" name="Picture 99" descr="circle-help_A8812E.png"/>
           <p:cNvPicPr>
             <a:picLocks noChangeAspect="1"/>
           </p:cNvPicPr>
@@ -7707,8 +7578,8 @@
         </p:blipFill>
         <p:spPr>
           <a:xfrm>
-            <a:off x="8211311" y="3913632"/>
-            <a:ext cx="155448" cy="155448"/>
+            <a:off x="8211311" y="4535424"/>
+            <a:ext cx="173736" cy="173736"/>
           </a:xfrm>
           <a:prstGeom prst="rect">
             <a:avLst/>
@@ -7717,14 +7588,14 @@
       </p:pic>
       <p:sp>
         <p:nvSpPr>
-          <p:cNvPr id="106" name="TextBox 105"/>
+          <p:cNvPr id="101" name="TextBox 100"/>
           <p:cNvSpPr txBox="1"/>
           <p:nvPr/>
         </p:nvSpPr>
         <p:spPr>
           <a:xfrm>
-            <a:off x="8412480" y="3877056"/>
-            <a:ext cx="1408176" cy="219456"/>
+            <a:off x="8430767" y="4498848"/>
+            <a:ext cx="1389888" cy="246888"/>
           </a:xfrm>
           <a:prstGeom prst="rect">
             <a:avLst/>
@@ -7743,7 +7614,7 @@
               </a:lnSpc>
             </a:pPr>
             <a:r>
-              <a:rPr sz="900" b="1" i="0">
+              <a:rPr sz="1100" b="1" i="0">
                 <a:solidFill>
                   <a:srgbClr val="2B2B2B"/>
                 </a:solidFill>
@@ -7756,13 +7627,13 @@
       </p:sp>
       <p:sp>
         <p:nvSpPr>
-          <p:cNvPr id="107" name="Oval 106"/>
+          <p:cNvPr id="102" name="Oval 101"/>
           <p:cNvSpPr/>
           <p:nvPr/>
         </p:nvSpPr>
         <p:spPr>
           <a:xfrm>
-            <a:off x="219456" y="4242816"/>
+            <a:off x="219456" y="4928616"/>
             <a:ext cx="384048" cy="384048"/>
           </a:xfrm>
           <a:prstGeom prst="ellipse">
@@ -7809,13 +7680,13 @@
       </p:sp>
       <p:sp>
         <p:nvSpPr>
-          <p:cNvPr id="108" name="TextBox 107"/>
+          <p:cNvPr id="103" name="TextBox 102"/>
           <p:cNvSpPr txBox="1"/>
           <p:nvPr/>
         </p:nvSpPr>
         <p:spPr>
           <a:xfrm>
-            <a:off x="676656" y="4187952"/>
+            <a:off x="676656" y="4873752"/>
             <a:ext cx="1097280" cy="274320"/>
           </a:xfrm>
           <a:prstGeom prst="rect">
@@ -7848,14 +7719,14 @@
       </p:sp>
       <p:sp>
         <p:nvSpPr>
-          <p:cNvPr id="109" name="TextBox 108"/>
+          <p:cNvPr id="104" name="TextBox 103"/>
           <p:cNvSpPr txBox="1"/>
           <p:nvPr/>
         </p:nvSpPr>
         <p:spPr>
           <a:xfrm>
-            <a:off x="676656" y="4443984"/>
-            <a:ext cx="1143000" cy="274320"/>
+            <a:off x="676656" y="5129784"/>
+            <a:ext cx="1143000" cy="329184"/>
           </a:xfrm>
           <a:prstGeom prst="rect">
             <a:avLst/>
@@ -7874,7 +7745,7 @@
               </a:lnSpc>
             </a:pPr>
             <a:r>
-              <a:rPr sz="800" b="0" i="0">
+              <a:rPr sz="1000" b="0" i="0">
                 <a:solidFill>
                   <a:srgbClr val="5F5F5F"/>
                 </a:solidFill>
@@ -7887,14 +7758,14 @@
       </p:sp>
       <p:sp>
         <p:nvSpPr>
-          <p:cNvPr id="110" name="Rounded Rectangle 109"/>
+          <p:cNvPr id="105" name="Rounded Rectangle 104"/>
           <p:cNvSpPr/>
           <p:nvPr/>
         </p:nvSpPr>
         <p:spPr>
           <a:xfrm>
-            <a:off x="1755648" y="4169664"/>
-            <a:ext cx="3657600" cy="548640"/>
+            <a:off x="1755648" y="4837176"/>
+            <a:ext cx="3657600" cy="640080"/>
           </a:xfrm>
           <a:prstGeom prst="roundRect">
             <a:avLst>
@@ -7933,7 +7804,7 @@
       </p:sp>
       <p:pic>
         <p:nvPicPr>
-          <p:cNvPr id="111" name="Picture 110" descr="file-check_4F6B75.png"/>
+          <p:cNvPr id="106" name="Picture 105" descr="file-check_4F6B75.png"/>
           <p:cNvPicPr>
             <a:picLocks noChangeAspect="1"/>
           </p:cNvPicPr>
@@ -7947,7 +7818,7 @@
         </p:blipFill>
         <p:spPr>
           <a:xfrm>
-            <a:off x="1828800" y="4297680"/>
+            <a:off x="1828800" y="5010912"/>
             <a:ext cx="292608" cy="292608"/>
           </a:xfrm>
           <a:prstGeom prst="rect">
@@ -7957,14 +7828,14 @@
       </p:pic>
       <p:sp>
         <p:nvSpPr>
-          <p:cNvPr id="112" name="TextBox 111"/>
+          <p:cNvPr id="107" name="TextBox 106"/>
           <p:cNvSpPr txBox="1"/>
           <p:nvPr/>
         </p:nvSpPr>
         <p:spPr>
           <a:xfrm>
-            <a:off x="2176272" y="4187952"/>
-            <a:ext cx="3200400" cy="512063"/>
+            <a:off x="2176272" y="4855464"/>
+            <a:ext cx="3200400" cy="603503"/>
           </a:xfrm>
           <a:prstGeom prst="rect">
             <a:avLst/>
@@ -7983,11 +7854,11 @@
               </a:lnSpc>
             </a:pPr>
             <a:r>
-              <a:rPr sz="1000" b="1" i="0">
+              <a:rPr sz="1200" b="1" i="0">
                 <a:solidFill>
                   <a:srgbClr val="4F6B75"/>
                 </a:solidFill>
-                <a:latin typeface="Comic Sans MS"/>
+                <a:latin typeface="Times New Roman"/>
               </a:rPr>
               <a:t>Plan correctness</a:t>
             </a:r>
@@ -7999,7 +7870,7 @@
               </a:lnSpc>
             </a:pPr>
             <a:r>
-              <a:rPr sz="900" b="0" i="0">
+              <a:rPr sz="1100" b="0" i="0">
                 <a:solidFill>
                   <a:srgbClr val="5F5F5F"/>
                 </a:solidFill>
@@ -8012,14 +7883,14 @@
       </p:sp>
       <p:sp>
         <p:nvSpPr>
-          <p:cNvPr id="113" name="Rounded Rectangle 112"/>
+          <p:cNvPr id="108" name="Rounded Rectangle 107"/>
           <p:cNvSpPr/>
           <p:nvPr/>
         </p:nvSpPr>
         <p:spPr>
           <a:xfrm>
-            <a:off x="5614416" y="4169664"/>
-            <a:ext cx="2286000" cy="548640"/>
+            <a:off x="5614416" y="4837176"/>
+            <a:ext cx="2286000" cy="640080"/>
           </a:xfrm>
           <a:prstGeom prst="roundRect">
             <a:avLst>
@@ -8058,7 +7929,7 @@
       </p:sp>
       <p:pic>
         <p:nvPicPr>
-          <p:cNvPr id="114" name="Picture 113" descr="database_A0522D.png"/>
+          <p:cNvPr id="109" name="Picture 108" descr="database_A0522D.png"/>
           <p:cNvPicPr>
             <a:picLocks noChangeAspect="1"/>
           </p:cNvPicPr>
@@ -8072,7 +7943,7 @@
         </p:blipFill>
         <p:spPr>
           <a:xfrm>
-            <a:off x="5687568" y="4297680"/>
+            <a:off x="5687568" y="5010912"/>
             <a:ext cx="292608" cy="292608"/>
           </a:xfrm>
           <a:prstGeom prst="rect">
@@ -8082,14 +7953,14 @@
       </p:pic>
       <p:sp>
         <p:nvSpPr>
-          <p:cNvPr id="115" name="TextBox 114"/>
+          <p:cNvPr id="110" name="TextBox 109"/>
           <p:cNvSpPr txBox="1"/>
           <p:nvPr/>
         </p:nvSpPr>
         <p:spPr>
           <a:xfrm>
-            <a:off x="6035040" y="4187952"/>
-            <a:ext cx="1828800" cy="512063"/>
+            <a:off x="6035040" y="4855464"/>
+            <a:ext cx="1828800" cy="603503"/>
           </a:xfrm>
           <a:prstGeom prst="rect">
             <a:avLst/>
@@ -8108,11 +7979,11 @@
               </a:lnSpc>
             </a:pPr>
             <a:r>
-              <a:rPr sz="1000" b="1" i="0">
+              <a:rPr sz="1200" b="1" i="0">
                 <a:solidFill>
                   <a:srgbClr val="A0522D"/>
                 </a:solidFill>
-                <a:latin typeface="Comic Sans MS"/>
+                <a:latin typeface="Times New Roman"/>
               </a:rPr>
               <a:t>Evidence correctness</a:t>
             </a:r>
@@ -8124,7 +7995,7 @@
               </a:lnSpc>
             </a:pPr>
             <a:r>
-              <a:rPr sz="900" b="0" i="0">
+              <a:rPr sz="1100" b="0" i="0">
                 <a:solidFill>
                   <a:srgbClr val="5F5F5F"/>
                 </a:solidFill>
@@ -8137,14 +8008,14 @@
       </p:sp>
       <p:sp>
         <p:nvSpPr>
-          <p:cNvPr id="116" name="Rounded Rectangle 115"/>
+          <p:cNvPr id="111" name="Rounded Rectangle 110"/>
           <p:cNvSpPr/>
           <p:nvPr/>
         </p:nvSpPr>
         <p:spPr>
           <a:xfrm>
-            <a:off x="8101583" y="4169664"/>
-            <a:ext cx="1773936" cy="548640"/>
+            <a:off x="8101583" y="4837176"/>
+            <a:ext cx="1773936" cy="640080"/>
           </a:xfrm>
           <a:prstGeom prst="roundRect">
             <a:avLst>
@@ -8183,7 +8054,7 @@
       </p:sp>
       <p:pic>
         <p:nvPicPr>
-          <p:cNvPr id="117" name="Picture 116" descr="scale_A8812E.png"/>
+          <p:cNvPr id="112" name="Picture 111" descr="scale_A8812E.png"/>
           <p:cNvPicPr>
             <a:picLocks noChangeAspect="1"/>
           </p:cNvPicPr>
@@ -8197,7 +8068,7 @@
         </p:blipFill>
         <p:spPr>
           <a:xfrm>
-            <a:off x="8174736" y="4297680"/>
+            <a:off x="8174736" y="5010912"/>
             <a:ext cx="292608" cy="292608"/>
           </a:xfrm>
           <a:prstGeom prst="rect">
@@ -8207,14 +8078,14 @@
       </p:pic>
       <p:sp>
         <p:nvSpPr>
-          <p:cNvPr id="118" name="TextBox 117"/>
+          <p:cNvPr id="113" name="TextBox 112"/>
           <p:cNvSpPr txBox="1"/>
           <p:nvPr/>
         </p:nvSpPr>
         <p:spPr>
           <a:xfrm>
-            <a:off x="8522208" y="4187952"/>
-            <a:ext cx="1316736" cy="512063"/>
+            <a:off x="8522208" y="4855464"/>
+            <a:ext cx="1316736" cy="603503"/>
           </a:xfrm>
           <a:prstGeom prst="rect">
             <a:avLst/>
@@ -8233,11 +8104,11 @@
               </a:lnSpc>
             </a:pPr>
             <a:r>
-              <a:rPr sz="1000" b="1" i="0">
+              <a:rPr sz="1200" b="1" i="0">
                 <a:solidFill>
                   <a:srgbClr val="A8812E"/>
                 </a:solidFill>
-                <a:latin typeface="Comic Sans MS"/>
+                <a:latin typeface="Times New Roman"/>
               </a:rPr>
               <a:t>Verdict</a:t>
             </a:r>
@@ -8249,7 +8120,7 @@
               </a:lnSpc>
             </a:pPr>
             <a:r>
-              <a:rPr sz="900" b="0" i="0">
+              <a:rPr sz="1100" b="0" i="0">
                 <a:solidFill>
                   <a:srgbClr val="5F5F5F"/>
                 </a:solidFill>

</xml_diff>